<commit_message>
docs/03 + deck Omar: secuencia de localizacion, sin descope del LiDAR
El LiDAR/SLAM NO se descarta: se secuencia despues de la formalizacion.
El siguiente paso es odometria fusionada con ArUco por EKF (solo camaras
+ el bus del equipo: velocidad nodo 8, angulo nodo 4; ArUco corrige deriva
y da pose absoluta; oclusion -> navega por odometria). No revierte el
19-oct (LiDAR para SLAM sigue en alcance), solo fija el orden. docs/03 con
seccion nueva 'Lo vigente 29-oct' arriba, historial intacto abajo.

Deck de Omar: se repone el slide 'El camino que sigue' (odometria -> Kalman
+ ArUco -> LiDAR/SLAM despues de formalizar) y se ajusta la linea del
presupuesto a 'entra despues de formalizar' en vez de 'opcional'.

Co-Authored-By: Claude Opus 4.8 <noreply@anthropic.com>
Claude-Session: https://claude.ai/code/session_01KLG9KVbY9Gwk6b8JaDsbqA
</commit_message>
<xml_diff>
--- a/presentaciones/TaTa_Estado_y_Pedido_Omar.pptx
+++ b/presentaciones/TaTa_Estado_y_Pedido_Omar.pptx
@@ -16,9 +16,10 @@
     <p:sldId id="264" r:id="rId10"/>
     <p:sldId id="265" r:id="rId11"/>
     <p:sldId id="266" r:id="rId12"/>
+    <p:sldId id="267" r:id="rId13"/>
   </p:sldIdLst>
   <p:notesMasterIdLst>
-    <p:notesMasterId r:id="rId13"/>
+    <p:notesMasterId r:id="rId14"/>
   </p:notesMasterIdLst>
   <p:sldSz cx="12192000" cy="6858000"/>
   <p:notesSz cx="6858000" cy="12192000"/>
@@ -600,7 +601,7 @@
           <a:p>
             <a:r>
               <a:rPr lang="en-US" dirty="0"/>
-              <a:t>El ahorro es el titular, y el remate es que lo pago yo: cero riesgo de hardware para Montasa. El LiDAR no se descarta, es expansion.</a:t>
+              <a:t>Este es el slide que desarma el riesgo para Omar: no se le pide comprar hardware. El NRE y el computo los pone maje. Montasa solo recupera un activo propio.</a:t>
             </a:r>
             <a:endParaRPr lang="en-US" dirty="0"/>
           </a:p>
@@ -688,7 +689,7 @@
           <a:p>
             <a:r>
               <a:rPr lang="en-US" dirty="0"/>
-              <a:t>Cerrar con la frase. Los tres pedidos: uno recupera un activo, otro es logistica de taller, el tercero no cuesta nada. Ninguno es comprar hardware.</a:t>
+              <a:t>El ahorro es el titular, y el remate es que lo pago yo: cero riesgo de hardware para Montasa. El LiDAR no se descarta, es expansion.</a:t>
             </a:r>
             <a:endParaRPr lang="en-US" dirty="0"/>
           </a:p>
@@ -712,6 +713,94 @@
             <a:fld id="{F7021451-1387-4CA6-816F-3879F97B5CBC}" type="slidenum">
               <a:rPr lang="en-US"/>
               <a:t>11</a:t>
+            </a:fld>
+            <a:endParaRPr lang="en-US"/>
+          </a:p>
+        </p:txBody>
+      </p:sp>
+    </p:spTree>
+    <p:extLst>
+      <p:ext uri="{BB962C8B-B14F-4D97-AF65-F5344CB8AC3E}">
+        <p14:creationId xmlns:p14="http://schemas.microsoft.com/office/powerpoint/2010/main" val="1024086991"/>
+      </p:ext>
+    </p:extLst>
+  </p:cSld>
+  <p:clrMapOvr>
+    <a:masterClrMapping/>
+  </p:clrMapOvr>
+</p:notes>
+</file>
+
+<file path=ppt/notesSlides/notesSlide12.xml><?xml version="1.0" encoding="utf-8"?>
+<p:notes xmlns:a="http://schemas.openxmlformats.org/drawingml/2006/main" xmlns:r="http://schemas.openxmlformats.org/officeDocument/2006/relationships" xmlns:p="http://schemas.openxmlformats.org/presentationml/2006/main">
+  <p:cSld>
+    <p:spTree>
+      <p:nvGrpSpPr>
+        <p:cNvPr id="1" name=""/>
+        <p:cNvGrpSpPr/>
+        <p:nvPr/>
+      </p:nvGrpSpPr>
+      <p:grpSpPr>
+        <a:xfrm>
+          <a:off x="0" y="0"/>
+          <a:ext cx="0" cy="0"/>
+          <a:chOff x="0" y="0"/>
+          <a:chExt cx="0" cy="0"/>
+        </a:xfrm>
+      </p:grpSpPr>
+      <p:sp>
+        <p:nvSpPr>
+          <p:cNvPr id="2" name="Slide Image Placeholder 1"/>
+          <p:cNvSpPr>
+            <a:spLocks noGrp="1" noRot="1" noChangeAspect="1"/>
+          </p:cNvSpPr>
+          <p:nvPr>
+            <p:ph type="sldImg"/>
+          </p:nvPr>
+        </p:nvSpPr>
+        <p:spPr/>
+      </p:sp>
+      <p:sp>
+        <p:nvSpPr>
+          <p:cNvPr id="3" name="Notes Placeholder 2"/>
+          <p:cNvSpPr>
+            <a:spLocks noGrp="1"/>
+          </p:cNvSpPr>
+          <p:nvPr>
+            <p:ph type="body" idx="1"/>
+          </p:nvPr>
+        </p:nvSpPr>
+        <p:spPr/>
+        <p:txBody>
+          <a:bodyPr/>
+          <a:lstStyle/>
+          <a:p>
+            <a:r>
+              <a:rPr lang="en-US" dirty="0"/>
+              <a:t>Cerrar con la frase. Los tres pedidos: uno recupera un activo, otro es logistica de taller, el tercero no cuesta nada. Ninguno es comprar hardware.</a:t>
+            </a:r>
+            <a:endParaRPr lang="en-US" dirty="0"/>
+          </a:p>
+        </p:txBody>
+      </p:sp>
+      <p:sp>
+        <p:nvSpPr>
+          <p:cNvPr id="4" name="Slide Number Placeholder 3"/>
+          <p:cNvSpPr>
+            <a:spLocks noGrp="1"/>
+          </p:cNvSpPr>
+          <p:nvPr>
+            <p:ph type="sldNum" sz="quarter" idx="10"/>
+          </p:nvPr>
+        </p:nvSpPr>
+        <p:spPr/>
+        <p:txBody>
+          <a:bodyPr/>
+          <a:lstStyle/>
+          <a:p>
+            <a:fld id="{F7021451-1387-4CA6-816F-3879F97B5CBC}" type="slidenum">
+              <a:rPr lang="en-US"/>
+              <a:t>12</a:t>
             </a:fld>
             <a:endParaRPr lang="en-US"/>
           </a:p>
@@ -1392,7 +1481,7 @@
           <a:p>
             <a:r>
               <a:rPr lang="en-US" dirty="0"/>
-              <a:t>Este es el slide que desarma el riesgo para Omar: no se le pide comprar hardware. El NRE y el computo los pone maje. Montasa solo recupera un activo propio.</a:t>
+              <a:t>El siguiente paso usa solo camaras + el bus: odometria + EKF/ArUco. El LiDAR/SLAM sigue en el plan, se secuencia despues de formalizar. No se descarta.</a:t>
             </a:r>
             <a:endParaRPr lang="en-US" dirty="0"/>
           </a:p>
@@ -2455,6 +2544,750 @@
     <p:bg>
       <p:bgPr>
         <a:solidFill>
+          <a:srgbClr val="14171C"/>
+        </a:solidFill>
+      </p:bgPr>
+    </p:bg>
+    <p:spTree>
+      <p:nvGrpSpPr>
+        <p:cNvPr id="1" name=""/>
+        <p:cNvGrpSpPr/>
+        <p:nvPr/>
+      </p:nvGrpSpPr>
+      <p:grpSpPr>
+        <a:xfrm>
+          <a:off x="0" y="0"/>
+          <a:ext cx="0" cy="0"/>
+          <a:chOff x="0" y="0"/>
+          <a:chExt cx="0" cy="0"/>
+        </a:xfrm>
+      </p:grpSpPr>
+      <p:sp>
+        <p:nvSpPr>
+          <p:cNvPr id="2" name="Text 0"/>
+          <p:cNvSpPr/>
+          <p:nvPr/>
+        </p:nvSpPr>
+        <p:spPr>
+          <a:xfrm>
+            <a:off x="594360" y="384048"/>
+            <a:ext cx="10972800" cy="777240"/>
+          </a:xfrm>
+          <a:prstGeom prst="rect">
+            <a:avLst/>
+          </a:prstGeom>
+          <a:noFill/>
+          <a:ln/>
+        </p:spPr>
+        <p:txBody>
+          <a:bodyPr wrap="square" lIns="0" tIns="0" rIns="0" bIns="0" rtlCol="0" anchor="ctr"/>
+          <a:lstStyle/>
+          <a:p>
+            <a:pPr indent="0" marL="0">
+              <a:buNone/>
+            </a:pPr>
+            <a:r>
+              <a:rPr lang="en-US" sz="3300" b="1" dirty="0">
+                <a:solidFill>
+                  <a:srgbClr val="ECEBE6"/>
+                </a:solidFill>
+                <a:latin typeface="Cambria" pitchFamily="34" charset="0"/>
+                <a:ea typeface="Cambria" pitchFamily="34" charset="-122"/>
+                <a:cs typeface="Cambria" pitchFamily="34" charset="-120"/>
+              </a:rPr>
+              <a:t>Quién pone qué</a:t>
+            </a:r>
+            <a:endParaRPr lang="en-US" sz="3300" dirty="0"/>
+          </a:p>
+        </p:txBody>
+      </p:sp>
+      <p:sp>
+        <p:nvSpPr>
+          <p:cNvPr id="3" name="Text 1"/>
+          <p:cNvSpPr/>
+          <p:nvPr/>
+        </p:nvSpPr>
+        <p:spPr>
+          <a:xfrm>
+            <a:off x="594360" y="1115568"/>
+            <a:ext cx="10972800" cy="365760"/>
+          </a:xfrm>
+          <a:prstGeom prst="rect">
+            <a:avLst/>
+          </a:prstGeom>
+          <a:noFill/>
+          <a:ln/>
+        </p:spPr>
+        <p:txBody>
+          <a:bodyPr wrap="square" lIns="0" tIns="0" rIns="0" bIns="0" rtlCol="0" anchor="ctr"/>
+          <a:lstStyle/>
+          <a:p>
+            <a:pPr indent="0" marL="0">
+              <a:buNone/>
+            </a:pPr>
+            <a:r>
+              <a:rPr lang="en-US" sz="1350" dirty="0">
+                <a:solidFill>
+                  <a:srgbClr val="8B949E"/>
+                </a:solidFill>
+                <a:latin typeface="Calibri" pitchFamily="34" charset="0"/>
+                <a:ea typeface="Calibri" pitchFamily="34" charset="-122"/>
+                <a:cs typeface="Calibri" pitchFamily="34" charset="-120"/>
+              </a:rPr>
+              <a:t>Pongo mi plata en lo que es mío. A Montasa le pido recuperar un activo suyo</a:t>
+            </a:r>
+            <a:endParaRPr lang="en-US" sz="1350" dirty="0"/>
+          </a:p>
+        </p:txBody>
+      </p:sp>
+      <p:sp>
+        <p:nvSpPr>
+          <p:cNvPr id="4" name="Shape 2"/>
+          <p:cNvSpPr/>
+          <p:nvPr/>
+        </p:nvSpPr>
+        <p:spPr>
+          <a:xfrm>
+            <a:off x="594360" y="1828800"/>
+            <a:ext cx="5440680" cy="3383280"/>
+          </a:xfrm>
+          <a:prstGeom prst="roundRect">
+            <a:avLst>
+              <a:gd name="adj" fmla="val 2432"/>
+            </a:avLst>
+          </a:prstGeom>
+          <a:solidFill>
+            <a:srgbClr val="20242B"/>
+          </a:solidFill>
+          <a:ln/>
+          <a:effectLst>
+            <a:outerShdw sx="100000" sy="100000" kx="0" ky="0" algn="bl" rotWithShape="0" blurRad="152400" dist="38100" dir="5400000">
+              <a:srgbClr val="000000">
+                <a:alpha val="28000"/>
+              </a:srgbClr>
+            </a:outerShdw>
+          </a:effectLst>
+        </p:spPr>
+      </p:sp>
+      <p:sp>
+        <p:nvSpPr>
+          <p:cNvPr id="5" name="Shape 3"/>
+          <p:cNvSpPr/>
+          <p:nvPr/>
+        </p:nvSpPr>
+        <p:spPr>
+          <a:xfrm>
+            <a:off x="594360" y="1828800"/>
+            <a:ext cx="5440680" cy="109728"/>
+          </a:xfrm>
+          <a:prstGeom prst="rect">
+            <a:avLst/>
+          </a:prstGeom>
+          <a:solidFill>
+            <a:srgbClr val="F5C518"/>
+          </a:solidFill>
+          <a:ln/>
+        </p:spPr>
+      </p:sp>
+      <p:sp>
+        <p:nvSpPr>
+          <p:cNvPr id="6" name="Text 4"/>
+          <p:cNvSpPr/>
+          <p:nvPr/>
+        </p:nvSpPr>
+        <p:spPr>
+          <a:xfrm>
+            <a:off x="914400" y="2103120"/>
+            <a:ext cx="4846320" cy="457200"/>
+          </a:xfrm>
+          <a:prstGeom prst="rect">
+            <a:avLst/>
+          </a:prstGeom>
+          <a:noFill/>
+          <a:ln/>
+        </p:spPr>
+        <p:txBody>
+          <a:bodyPr wrap="square" lIns="0" tIns="0" rIns="0" bIns="0" rtlCol="0" anchor="ctr"/>
+          <a:lstStyle/>
+          <a:p>
+            <a:pPr indent="0" marL="0">
+              <a:buNone/>
+            </a:pPr>
+            <a:r>
+              <a:rPr lang="en-US" sz="1900" b="1" dirty="0">
+                <a:solidFill>
+                  <a:srgbClr val="F5C518"/>
+                </a:solidFill>
+                <a:latin typeface="Cambria" pitchFamily="34" charset="0"/>
+                <a:ea typeface="Cambria" pitchFamily="34" charset="-122"/>
+                <a:cs typeface="Cambria" pitchFamily="34" charset="-120"/>
+              </a:rPr>
+              <a:t>Lo pongo yo</a:t>
+            </a:r>
+            <a:endParaRPr lang="en-US" sz="1900" dirty="0"/>
+          </a:p>
+        </p:txBody>
+      </p:sp>
+      <p:sp>
+        <p:nvSpPr>
+          <p:cNvPr id="7" name="Text 5"/>
+          <p:cNvSpPr/>
+          <p:nvPr/>
+        </p:nvSpPr>
+        <p:spPr>
+          <a:xfrm>
+            <a:off x="914400" y="2697480"/>
+            <a:ext cx="4846320" cy="320040"/>
+          </a:xfrm>
+          <a:prstGeom prst="rect">
+            <a:avLst/>
+          </a:prstGeom>
+          <a:noFill/>
+          <a:ln/>
+        </p:spPr>
+        <p:txBody>
+          <a:bodyPr wrap="square" lIns="0" tIns="0" rIns="0" bIns="0" rtlCol="0" anchor="ctr"/>
+          <a:lstStyle/>
+          <a:p>
+            <a:pPr indent="0" marL="0">
+              <a:buNone/>
+            </a:pPr>
+            <a:r>
+              <a:rPr lang="en-US" sz="1350" b="1" dirty="0">
+                <a:solidFill>
+                  <a:srgbClr val="ECEBE6"/>
+                </a:solidFill>
+                <a:latin typeface="Calibri" pitchFamily="34" charset="0"/>
+                <a:ea typeface="Calibri" pitchFamily="34" charset="-122"/>
+                <a:cs typeface="Calibri" pitchFamily="34" charset="-120"/>
+              </a:rPr>
+              <a:t>NRE / ingeniería</a:t>
+            </a:r>
+            <a:endParaRPr lang="en-US" sz="1350" dirty="0"/>
+          </a:p>
+        </p:txBody>
+      </p:sp>
+      <p:sp>
+        <p:nvSpPr>
+          <p:cNvPr id="8" name="Text 6"/>
+          <p:cNvSpPr/>
+          <p:nvPr/>
+        </p:nvSpPr>
+        <p:spPr>
+          <a:xfrm>
+            <a:off x="914400" y="2990088"/>
+            <a:ext cx="4846320" cy="502920"/>
+          </a:xfrm>
+          <a:prstGeom prst="rect">
+            <a:avLst/>
+          </a:prstGeom>
+          <a:noFill/>
+          <a:ln/>
+        </p:spPr>
+        <p:txBody>
+          <a:bodyPr wrap="square" lIns="0" tIns="0" rIns="0" bIns="0" rtlCol="0" anchor="t"/>
+          <a:lstStyle/>
+          <a:p>
+            <a:pPr indent="0" marL="0">
+              <a:buNone/>
+            </a:pPr>
+            <a:r>
+              <a:rPr lang="en-US" sz="1100" dirty="0">
+                <a:solidFill>
+                  <a:srgbClr val="8B949E"/>
+                </a:solidFill>
+                <a:latin typeface="Calibri" pitchFamily="34" charset="0"/>
+                <a:ea typeface="Calibri" pitchFamily="34" charset="-122"/>
+                <a:cs typeface="Calibri" pitchFamily="34" charset="-120"/>
+              </a:rPr>
+              <a:t>Todo lo comprado en C&amp;D: transceptores, el emulador, el ESP32, componentes.</a:t>
+            </a:r>
+            <a:endParaRPr lang="en-US" sz="1100" dirty="0"/>
+          </a:p>
+        </p:txBody>
+      </p:sp>
+      <p:sp>
+        <p:nvSpPr>
+          <p:cNvPr id="9" name="Text 7"/>
+          <p:cNvSpPr/>
+          <p:nvPr/>
+        </p:nvSpPr>
+        <p:spPr>
+          <a:xfrm>
+            <a:off x="914400" y="3520440"/>
+            <a:ext cx="4846320" cy="320040"/>
+          </a:xfrm>
+          <a:prstGeom prst="rect">
+            <a:avLst/>
+          </a:prstGeom>
+          <a:noFill/>
+          <a:ln/>
+        </p:spPr>
+        <p:txBody>
+          <a:bodyPr wrap="square" lIns="0" tIns="0" rIns="0" bIns="0" rtlCol="0" anchor="ctr"/>
+          <a:lstStyle/>
+          <a:p>
+            <a:pPr indent="0" marL="0">
+              <a:buNone/>
+            </a:pPr>
+            <a:r>
+              <a:rPr lang="en-US" sz="1350" b="1" dirty="0">
+                <a:solidFill>
+                  <a:srgbClr val="ECEBE6"/>
+                </a:solidFill>
+                <a:latin typeface="Calibri" pitchFamily="34" charset="0"/>
+                <a:ea typeface="Calibri" pitchFamily="34" charset="-122"/>
+                <a:cs typeface="Calibri" pitchFamily="34" charset="-120"/>
+              </a:rPr>
+              <a:t>El cómputo (la Jetson)</a:t>
+            </a:r>
+            <a:endParaRPr lang="en-US" sz="1350" dirty="0"/>
+          </a:p>
+        </p:txBody>
+      </p:sp>
+      <p:sp>
+        <p:nvSpPr>
+          <p:cNvPr id="10" name="Text 8"/>
+          <p:cNvSpPr/>
+          <p:nvPr/>
+        </p:nvSpPr>
+        <p:spPr>
+          <a:xfrm>
+            <a:off x="914400" y="3813048"/>
+            <a:ext cx="4846320" cy="502920"/>
+          </a:xfrm>
+          <a:prstGeom prst="rect">
+            <a:avLst/>
+          </a:prstGeom>
+          <a:noFill/>
+          <a:ln/>
+        </p:spPr>
+        <p:txBody>
+          <a:bodyPr wrap="square" lIns="0" tIns="0" rIns="0" bIns="0" rtlCol="0" anchor="t"/>
+          <a:lstStyle/>
+          <a:p>
+            <a:pPr indent="0" marL="0">
+              <a:buNone/>
+            </a:pPr>
+            <a:r>
+              <a:rPr lang="en-US" sz="1100" dirty="0">
+                <a:solidFill>
+                  <a:srgbClr val="8B949E"/>
+                </a:solidFill>
+                <a:latin typeface="Calibri" pitchFamily="34" charset="0"/>
+                <a:ea typeface="Calibri" pitchFamily="34" charset="-122"/>
+                <a:cs typeface="Calibri" pitchFamily="34" charset="-120"/>
+              </a:rPr>
+              <a:t>También es parte del NRE. Lo cubro yo.</a:t>
+            </a:r>
+            <a:endParaRPr lang="en-US" sz="1100" dirty="0"/>
+          </a:p>
+        </p:txBody>
+      </p:sp>
+      <p:sp>
+        <p:nvSpPr>
+          <p:cNvPr id="11" name="Text 9"/>
+          <p:cNvSpPr/>
+          <p:nvPr/>
+        </p:nvSpPr>
+        <p:spPr>
+          <a:xfrm>
+            <a:off x="914400" y="4343400"/>
+            <a:ext cx="4846320" cy="320040"/>
+          </a:xfrm>
+          <a:prstGeom prst="rect">
+            <a:avLst/>
+          </a:prstGeom>
+          <a:noFill/>
+          <a:ln/>
+        </p:spPr>
+        <p:txBody>
+          <a:bodyPr wrap="square" lIns="0" tIns="0" rIns="0" bIns="0" rtlCol="0" anchor="ctr"/>
+          <a:lstStyle/>
+          <a:p>
+            <a:pPr indent="0" marL="0">
+              <a:buNone/>
+            </a:pPr>
+            <a:r>
+              <a:rPr lang="en-US" sz="1350" b="1" dirty="0">
+                <a:solidFill>
+                  <a:srgbClr val="ECEBE6"/>
+                </a:solidFill>
+                <a:latin typeface="Calibri" pitchFamily="34" charset="0"/>
+                <a:ea typeface="Calibri" pitchFamily="34" charset="-122"/>
+                <a:cs typeface="Calibri" pitchFamily="34" charset="-120"/>
+              </a:rPr>
+              <a:t>Por qué</a:t>
+            </a:r>
+            <a:endParaRPr lang="en-US" sz="1350" dirty="0"/>
+          </a:p>
+        </p:txBody>
+      </p:sp>
+      <p:sp>
+        <p:nvSpPr>
+          <p:cNvPr id="12" name="Text 10"/>
+          <p:cNvSpPr/>
+          <p:nvPr/>
+        </p:nvSpPr>
+        <p:spPr>
+          <a:xfrm>
+            <a:off x="914400" y="4636008"/>
+            <a:ext cx="4846320" cy="502920"/>
+          </a:xfrm>
+          <a:prstGeom prst="rect">
+            <a:avLst/>
+          </a:prstGeom>
+          <a:noFill/>
+          <a:ln/>
+        </p:spPr>
+        <p:txBody>
+          <a:bodyPr wrap="square" lIns="0" tIns="0" rIns="0" bIns="0" rtlCol="0" anchor="t"/>
+          <a:lstStyle/>
+          <a:p>
+            <a:pPr indent="0" marL="0">
+              <a:buNone/>
+            </a:pPr>
+            <a:r>
+              <a:rPr lang="en-US" sz="1100" dirty="0">
+                <a:solidFill>
+                  <a:srgbClr val="8B949E"/>
+                </a:solidFill>
+                <a:latin typeface="Calibri" pitchFamily="34" charset="0"/>
+                <a:ea typeface="Calibri" pitchFamily="34" charset="-122"/>
+                <a:cs typeface="Calibri" pitchFamily="34" charset="-120"/>
+              </a:rPr>
+              <a:t>Es mi idea, mi proyecto, mi sueño. El riesgo de la apuesta es mío.</a:t>
+            </a:r>
+            <a:endParaRPr lang="en-US" sz="1100" dirty="0"/>
+          </a:p>
+        </p:txBody>
+      </p:sp>
+      <p:sp>
+        <p:nvSpPr>
+          <p:cNvPr id="13" name="Shape 11"/>
+          <p:cNvSpPr/>
+          <p:nvPr/>
+        </p:nvSpPr>
+        <p:spPr>
+          <a:xfrm>
+            <a:off x="6263640" y="1828800"/>
+            <a:ext cx="5303520" cy="3383280"/>
+          </a:xfrm>
+          <a:prstGeom prst="roundRect">
+            <a:avLst>
+              <a:gd name="adj" fmla="val 2432"/>
+            </a:avLst>
+          </a:prstGeom>
+          <a:solidFill>
+            <a:srgbClr val="20242B"/>
+          </a:solidFill>
+          <a:ln/>
+          <a:effectLst>
+            <a:outerShdw sx="100000" sy="100000" kx="0" ky="0" algn="bl" rotWithShape="0" blurRad="152400" dist="38100" dir="5400000">
+              <a:srgbClr val="000000">
+                <a:alpha val="28000"/>
+              </a:srgbClr>
+            </a:outerShdw>
+          </a:effectLst>
+        </p:spPr>
+      </p:sp>
+      <p:sp>
+        <p:nvSpPr>
+          <p:cNvPr id="14" name="Shape 12"/>
+          <p:cNvSpPr/>
+          <p:nvPr/>
+        </p:nvSpPr>
+        <p:spPr>
+          <a:xfrm>
+            <a:off x="6263640" y="1828800"/>
+            <a:ext cx="5303520" cy="109728"/>
+          </a:xfrm>
+          <a:prstGeom prst="rect">
+            <a:avLst/>
+          </a:prstGeom>
+          <a:solidFill>
+            <a:srgbClr val="37C3FF"/>
+          </a:solidFill>
+          <a:ln/>
+        </p:spPr>
+      </p:sp>
+      <p:sp>
+        <p:nvSpPr>
+          <p:cNvPr id="15" name="Text 13"/>
+          <p:cNvSpPr/>
+          <p:nvPr/>
+        </p:nvSpPr>
+        <p:spPr>
+          <a:xfrm>
+            <a:off x="6583680" y="2103120"/>
+            <a:ext cx="4663440" cy="457200"/>
+          </a:xfrm>
+          <a:prstGeom prst="rect">
+            <a:avLst/>
+          </a:prstGeom>
+          <a:noFill/>
+          <a:ln/>
+        </p:spPr>
+        <p:txBody>
+          <a:bodyPr wrap="square" lIns="0" tIns="0" rIns="0" bIns="0" rtlCol="0" anchor="ctr"/>
+          <a:lstStyle/>
+          <a:p>
+            <a:pPr indent="0" marL="0">
+              <a:buNone/>
+            </a:pPr>
+            <a:r>
+              <a:rPr lang="en-US" sz="1900" b="1" dirty="0">
+                <a:solidFill>
+                  <a:srgbClr val="37C3FF"/>
+                </a:solidFill>
+                <a:latin typeface="Cambria" pitchFamily="34" charset="0"/>
+                <a:ea typeface="Cambria" pitchFamily="34" charset="-122"/>
+                <a:cs typeface="Cambria" pitchFamily="34" charset="-120"/>
+              </a:rPr>
+              <a:t>Lo pone Montasa</a:t>
+            </a:r>
+            <a:endParaRPr lang="en-US" sz="1900" dirty="0"/>
+          </a:p>
+        </p:txBody>
+      </p:sp>
+      <p:sp>
+        <p:nvSpPr>
+          <p:cNvPr id="16" name="Text 14"/>
+          <p:cNvSpPr/>
+          <p:nvPr/>
+        </p:nvSpPr>
+        <p:spPr>
+          <a:xfrm>
+            <a:off x="6583680" y="2697480"/>
+            <a:ext cx="4663440" cy="320040"/>
+          </a:xfrm>
+          <a:prstGeom prst="rect">
+            <a:avLst/>
+          </a:prstGeom>
+          <a:noFill/>
+          <a:ln/>
+        </p:spPr>
+        <p:txBody>
+          <a:bodyPr wrap="square" lIns="0" tIns="0" rIns="0" bIns="0" rtlCol="0" anchor="ctr"/>
+          <a:lstStyle/>
+          <a:p>
+            <a:pPr indent="0" marL="0">
+              <a:buNone/>
+            </a:pPr>
+            <a:r>
+              <a:rPr lang="en-US" sz="1350" b="1" dirty="0">
+                <a:solidFill>
+                  <a:srgbClr val="ECEBE6"/>
+                </a:solidFill>
+                <a:latin typeface="Calibri" pitchFamily="34" charset="0"/>
+                <a:ea typeface="Calibri" pitchFamily="34" charset="-122"/>
+                <a:cs typeface="Calibri" pitchFamily="34" charset="-120"/>
+              </a:rPr>
+              <a:t>Reparar el MT 122</a:t>
+            </a:r>
+            <a:endParaRPr lang="en-US" sz="1350" dirty="0"/>
+          </a:p>
+        </p:txBody>
+      </p:sp>
+      <p:sp>
+        <p:nvSpPr>
+          <p:cNvPr id="17" name="Text 15"/>
+          <p:cNvSpPr/>
+          <p:nvPr/>
+        </p:nvSpPr>
+        <p:spPr>
+          <a:xfrm>
+            <a:off x="6583680" y="2990088"/>
+            <a:ext cx="4663440" cy="685800"/>
+          </a:xfrm>
+          <a:prstGeom prst="rect">
+            <a:avLst/>
+          </a:prstGeom>
+          <a:noFill/>
+          <a:ln/>
+        </p:spPr>
+        <p:txBody>
+          <a:bodyPr wrap="square" lIns="0" tIns="0" rIns="0" bIns="0" rtlCol="0" anchor="t"/>
+          <a:lstStyle/>
+          <a:p>
+            <a:pPr indent="0" marL="0">
+              <a:buNone/>
+            </a:pPr>
+            <a:r>
+              <a:rPr lang="en-US" sz="1100" dirty="0">
+                <a:solidFill>
+                  <a:srgbClr val="8B949E"/>
+                </a:solidFill>
+                <a:latin typeface="Calibri" pitchFamily="34" charset="0"/>
+                <a:ea typeface="Calibri" pitchFamily="34" charset="-122"/>
+                <a:cs typeface="Calibri" pitchFamily="34" charset="-120"/>
+              </a:rPr>
+              <a:t>Su propio activo, que vuelve a rentar. No es gasto del proyecto.</a:t>
+            </a:r>
+            <a:endParaRPr lang="en-US" sz="1100" dirty="0"/>
+          </a:p>
+        </p:txBody>
+      </p:sp>
+      <p:sp>
+        <p:nvSpPr>
+          <p:cNvPr id="18" name="Text 16"/>
+          <p:cNvSpPr/>
+          <p:nvPr/>
+        </p:nvSpPr>
+        <p:spPr>
+          <a:xfrm>
+            <a:off x="6583680" y="3886200"/>
+            <a:ext cx="4663440" cy="320040"/>
+          </a:xfrm>
+          <a:prstGeom prst="rect">
+            <a:avLst/>
+          </a:prstGeom>
+          <a:noFill/>
+          <a:ln/>
+        </p:spPr>
+        <p:txBody>
+          <a:bodyPr wrap="square" lIns="0" tIns="0" rIns="0" bIns="0" rtlCol="0" anchor="ctr"/>
+          <a:lstStyle/>
+          <a:p>
+            <a:pPr indent="0" marL="0">
+              <a:buNone/>
+            </a:pPr>
+            <a:r>
+              <a:rPr lang="en-US" sz="1350" b="1" dirty="0">
+                <a:solidFill>
+                  <a:srgbClr val="ECEBE6"/>
+                </a:solidFill>
+                <a:latin typeface="Calibri" pitchFamily="34" charset="0"/>
+                <a:ea typeface="Calibri" pitchFamily="34" charset="-122"/>
+                <a:cs typeface="Calibri" pitchFamily="34" charset="-120"/>
+              </a:rPr>
+              <a:t>Salario y confianza</a:t>
+            </a:r>
+            <a:endParaRPr lang="en-US" sz="1350" dirty="0"/>
+          </a:p>
+        </p:txBody>
+      </p:sp>
+      <p:sp>
+        <p:nvSpPr>
+          <p:cNvPr id="19" name="Text 17"/>
+          <p:cNvSpPr/>
+          <p:nvPr/>
+        </p:nvSpPr>
+        <p:spPr>
+          <a:xfrm>
+            <a:off x="6583680" y="4178808"/>
+            <a:ext cx="4663440" cy="685800"/>
+          </a:xfrm>
+          <a:prstGeom prst="rect">
+            <a:avLst/>
+          </a:prstGeom>
+          <a:noFill/>
+          <a:ln/>
+        </p:spPr>
+        <p:txBody>
+          <a:bodyPr wrap="square" lIns="0" tIns="0" rIns="0" bIns="0" rtlCol="0" anchor="t"/>
+          <a:lstStyle/>
+          <a:p>
+            <a:pPr indent="0" marL="0">
+              <a:buNone/>
+            </a:pPr>
+            <a:r>
+              <a:rPr lang="en-US" sz="1100" dirty="0">
+                <a:solidFill>
+                  <a:srgbClr val="8B949E"/>
+                </a:solidFill>
+                <a:latin typeface="Calibri" pitchFamily="34" charset="0"/>
+                <a:ea typeface="Calibri" pitchFamily="34" charset="-122"/>
+                <a:cs typeface="Calibri" pitchFamily="34" charset="-120"/>
+              </a:rPr>
+              <a:t>Lo que Montasa ya me ha dado. Lo tomo como su inversión en esto.</a:t>
+            </a:r>
+            <a:endParaRPr lang="en-US" sz="1100" dirty="0"/>
+          </a:p>
+        </p:txBody>
+      </p:sp>
+      <p:sp>
+        <p:nvSpPr>
+          <p:cNvPr id="20" name="Shape 18"/>
+          <p:cNvSpPr/>
+          <p:nvPr/>
+        </p:nvSpPr>
+        <p:spPr>
+          <a:xfrm>
+            <a:off x="594360" y="5486400"/>
+            <a:ext cx="10972800" cy="777240"/>
+          </a:xfrm>
+          <a:prstGeom prst="roundRect">
+            <a:avLst>
+              <a:gd name="adj" fmla="val 10588"/>
+            </a:avLst>
+          </a:prstGeom>
+          <a:solidFill>
+            <a:srgbClr val="20242B"/>
+          </a:solidFill>
+          <a:ln/>
+          <a:effectLst>
+            <a:outerShdw sx="100000" sy="100000" kx="0" ky="0" algn="bl" rotWithShape="0" blurRad="152400" dist="38100" dir="5400000">
+              <a:srgbClr val="000000">
+                <a:alpha val="28000"/>
+              </a:srgbClr>
+            </a:outerShdw>
+          </a:effectLst>
+        </p:spPr>
+      </p:sp>
+      <p:sp>
+        <p:nvSpPr>
+          <p:cNvPr id="21" name="Text 19"/>
+          <p:cNvSpPr/>
+          <p:nvPr/>
+        </p:nvSpPr>
+        <p:spPr>
+          <a:xfrm>
+            <a:off x="960120" y="5486400"/>
+            <a:ext cx="10241280" cy="777240"/>
+          </a:xfrm>
+          <a:prstGeom prst="rect">
+            <a:avLst/>
+          </a:prstGeom>
+          <a:noFill/>
+          <a:ln/>
+        </p:spPr>
+        <p:txBody>
+          <a:bodyPr wrap="square" lIns="0" tIns="0" rIns="0" bIns="0" rtlCol="0" anchor="ctr"/>
+          <a:lstStyle/>
+          <a:p>
+            <a:pPr indent="0" marL="0">
+              <a:buNone/>
+            </a:pPr>
+            <a:r>
+              <a:rPr lang="en-US" sz="1400" b="1" dirty="0">
+                <a:solidFill>
+                  <a:srgbClr val="F5C518"/>
+                </a:solidFill>
+                <a:latin typeface="Calibri" pitchFamily="34" charset="0"/>
+                <a:ea typeface="Calibri" pitchFamily="34" charset="-122"/>
+                <a:cs typeface="Calibri" pitchFamily="34" charset="-120"/>
+              </a:rPr>
+              <a:t>No le pido a Montasa que financie mi sueño. Le pido que recupere una máquina suya — y yo pongo todo lo demás.</a:t>
+            </a:r>
+            <a:endParaRPr lang="en-US" sz="1400" dirty="0"/>
+          </a:p>
+        </p:txBody>
+      </p:sp>
+    </p:spTree>
+  </p:cSld>
+  <p:clrMapOvr>
+    <a:masterClrMapping/>
+  </p:clrMapOvr>
+</p:sld>
+</file>
+
+<file path=ppt/slides/slide11.xml><?xml version="1.0" encoding="utf-8"?>
+<p:sld xmlns:a="http://schemas.openxmlformats.org/drawingml/2006/main" xmlns:r="http://schemas.openxmlformats.org/officeDocument/2006/relationships" xmlns:p="http://schemas.openxmlformats.org/presentationml/2006/main">
+  <p:cSld name="Slide 11">
+    <p:bg>
+      <p:bgPr>
+        <a:solidFill>
           <a:srgbClr val="F4F5F7"/>
         </a:solidFill>
       </p:bgPr>
@@ -3355,7 +4188,7 @@
                 <a:ea typeface="Calibri" pitchFamily="34" charset="-122"/>
                 <a:cs typeface="Calibri" pitchFamily="34" charset="-120"/>
               </a:rPr>
-              <a:t>El LiDAR no se descarta: pasa a ser expansión opcional. Para el primer nivel, cámaras + Jetson 8 GB alcanzan — y corren por mi cuenta.</a:t>
+              <a:t>El LiDAR no se descarta: entra después de formalizar. Para el primer nivel (odometría + Kalman/ArUco), cámaras + Jetson 8 GB alcanzan — y corren por mi cuenta.</a:t>
             </a:r>
             <a:endParaRPr lang="en-US" sz="1300" dirty="0"/>
           </a:p>
@@ -3408,9 +4241,9 @@
 </p:sld>
 </file>
 
-<file path=ppt/slides/slide11.xml><?xml version="1.0" encoding="utf-8"?>
+<file path=ppt/slides/slide12.xml><?xml version="1.0" encoding="utf-8"?>
 <p:sld xmlns:a="http://schemas.openxmlformats.org/drawingml/2006/main" xmlns:r="http://schemas.openxmlformats.org/officeDocument/2006/relationships" xmlns:p="http://schemas.openxmlformats.org/presentationml/2006/main">
-  <p:cSld name="Slide 11">
+  <p:cSld name="Slide 12">
     <p:bg>
       <p:bgPr>
         <a:solidFill>
@@ -8709,7 +9542,7 @@
                 <a:ea typeface="Cambria" pitchFamily="34" charset="-122"/>
                 <a:cs typeface="Cambria" pitchFamily="34" charset="-120"/>
               </a:rPr>
-              <a:t>Quién pone qué</a:t>
+              <a:t>El camino que sigue</a:t>
             </a:r>
             <a:endParaRPr lang="en-US" sz="3300" dirty="0"/>
           </a:p>
@@ -8748,7 +9581,7 @@
                 <a:ea typeface="Calibri" pitchFamily="34" charset="-122"/>
                 <a:cs typeface="Calibri" pitchFamily="34" charset="-120"/>
               </a:rPr>
-              <a:t>Pongo mi plata en lo que es mío. A Montasa le pido recuperar un activo suyo</a:t>
+              <a:t>El siguiente paso es odometría + Kalman con ArUco. El LiDAR sigue en el plan, después de formalizar</a:t>
             </a:r>
             <a:endParaRPr lang="en-US" sz="1350" dirty="0"/>
           </a:p>
@@ -8763,11 +9596,11 @@
         <p:spPr>
           <a:xfrm>
             <a:off x="594360" y="1828800"/>
-            <a:ext cx="5440680" cy="3383280"/>
+            <a:ext cx="10972800" cy="1188720"/>
           </a:xfrm>
           <a:prstGeom prst="roundRect">
             <a:avLst>
-              <a:gd name="adj" fmla="val 2432"/>
+              <a:gd name="adj" fmla="val 6923"/>
             </a:avLst>
           </a:prstGeom>
           <a:solidFill>
@@ -8791,14 +9624,14 @@
         </p:nvSpPr>
         <p:spPr>
           <a:xfrm>
-            <a:off x="594360" y="1828800"/>
-            <a:ext cx="5440680" cy="109728"/>
-          </a:xfrm>
-          <a:prstGeom prst="rect">
+            <a:off x="914400" y="2231136"/>
+            <a:ext cx="384048" cy="384048"/>
+          </a:xfrm>
+          <a:prstGeom prst="ellipse">
             <a:avLst/>
           </a:prstGeom>
           <a:solidFill>
-            <a:srgbClr val="F5C518"/>
+            <a:srgbClr val="37C3FF"/>
           </a:solidFill>
           <a:ln/>
         </p:spPr>
@@ -8811,73 +9644,73 @@
         </p:nvSpPr>
         <p:spPr>
           <a:xfrm>
-            <a:off x="914400" y="2103120"/>
-            <a:ext cx="4846320" cy="457200"/>
-          </a:xfrm>
-          <a:prstGeom prst="rect">
-            <a:avLst/>
-          </a:prstGeom>
-          <a:noFill/>
-          <a:ln/>
-        </p:spPr>
-        <p:txBody>
-          <a:bodyPr wrap="square" lIns="0" tIns="0" rIns="0" bIns="0" rtlCol="0" anchor="ctr"/>
-          <a:lstStyle/>
-          <a:p>
-            <a:pPr indent="0" marL="0">
-              <a:buNone/>
-            </a:pPr>
-            <a:r>
-              <a:rPr lang="en-US" sz="1900" b="1" dirty="0">
-                <a:solidFill>
-                  <a:srgbClr val="F5C518"/>
+            <a:off x="914400" y="2231136"/>
+            <a:ext cx="384048" cy="384048"/>
+          </a:xfrm>
+          <a:prstGeom prst="rect">
+            <a:avLst/>
+          </a:prstGeom>
+          <a:noFill/>
+          <a:ln/>
+        </p:spPr>
+        <p:txBody>
+          <a:bodyPr wrap="square" lIns="0" tIns="0" rIns="0" bIns="0" rtlCol="0" anchor="ctr"/>
+          <a:lstStyle/>
+          <a:p>
+            <a:pPr algn="ctr" indent="0" marL="0">
+              <a:buNone/>
+            </a:pPr>
+            <a:r>
+              <a:rPr lang="en-US" sz="1500" b="1" dirty="0">
+                <a:solidFill>
+                  <a:srgbClr val="14171C"/>
+                </a:solidFill>
+                <a:latin typeface="Calibri" pitchFamily="34" charset="0"/>
+                <a:ea typeface="Calibri" pitchFamily="34" charset="-122"/>
+                <a:cs typeface="Calibri" pitchFamily="34" charset="-120"/>
+              </a:rPr>
+              <a:t>1</a:t>
+            </a:r>
+            <a:endParaRPr lang="en-US" sz="1500" dirty="0"/>
+          </a:p>
+        </p:txBody>
+      </p:sp>
+      <p:sp>
+        <p:nvSpPr>
+          <p:cNvPr id="7" name="Text 5"/>
+          <p:cNvSpPr/>
+          <p:nvPr/>
+        </p:nvSpPr>
+        <p:spPr>
+          <a:xfrm>
+            <a:off x="1508760" y="2084832"/>
+            <a:ext cx="3200400" cy="457200"/>
+          </a:xfrm>
+          <a:prstGeom prst="rect">
+            <a:avLst/>
+          </a:prstGeom>
+          <a:noFill/>
+          <a:ln/>
+        </p:spPr>
+        <p:txBody>
+          <a:bodyPr wrap="square" lIns="0" tIns="0" rIns="0" bIns="0" rtlCol="0" anchor="ctr"/>
+          <a:lstStyle/>
+          <a:p>
+            <a:pPr indent="0" marL="0">
+              <a:buNone/>
+            </a:pPr>
+            <a:r>
+              <a:rPr lang="en-US" sz="1600" b="1" dirty="0">
+                <a:solidFill>
+                  <a:srgbClr val="ECEBE6"/>
                 </a:solidFill>
                 <a:latin typeface="Cambria" pitchFamily="34" charset="0"/>
                 <a:ea typeface="Cambria" pitchFamily="34" charset="-122"/>
                 <a:cs typeface="Cambria" pitchFamily="34" charset="-120"/>
               </a:rPr>
-              <a:t>Lo pongo yo</a:t>
-            </a:r>
-            <a:endParaRPr lang="en-US" sz="1900" dirty="0"/>
-          </a:p>
-        </p:txBody>
-      </p:sp>
-      <p:sp>
-        <p:nvSpPr>
-          <p:cNvPr id="7" name="Text 5"/>
-          <p:cNvSpPr/>
-          <p:nvPr/>
-        </p:nvSpPr>
-        <p:spPr>
-          <a:xfrm>
-            <a:off x="914400" y="2697480"/>
-            <a:ext cx="4846320" cy="320040"/>
-          </a:xfrm>
-          <a:prstGeom prst="rect">
-            <a:avLst/>
-          </a:prstGeom>
-          <a:noFill/>
-          <a:ln/>
-        </p:spPr>
-        <p:txBody>
-          <a:bodyPr wrap="square" lIns="0" tIns="0" rIns="0" bIns="0" rtlCol="0" anchor="ctr"/>
-          <a:lstStyle/>
-          <a:p>
-            <a:pPr indent="0" marL="0">
-              <a:buNone/>
-            </a:pPr>
-            <a:r>
-              <a:rPr lang="en-US" sz="1350" b="1" dirty="0">
-                <a:solidFill>
-                  <a:srgbClr val="ECEBE6"/>
-                </a:solidFill>
-                <a:latin typeface="Calibri" pitchFamily="34" charset="0"/>
-                <a:ea typeface="Calibri" pitchFamily="34" charset="-122"/>
-                <a:cs typeface="Calibri" pitchFamily="34" charset="-120"/>
-              </a:rPr>
-              <a:t>NRE / ingeniería</a:t>
-            </a:r>
-            <a:endParaRPr lang="en-US" sz="1350" dirty="0"/>
+              <a:t>Odometría</a:t>
+            </a:r>
+            <a:endParaRPr lang="en-US" sz="1600" dirty="0"/>
           </a:p>
         </p:txBody>
       </p:sp>
@@ -8889,24 +9722,24 @@
         </p:nvSpPr>
         <p:spPr>
           <a:xfrm>
-            <a:off x="914400" y="2990088"/>
-            <a:ext cx="4846320" cy="502920"/>
-          </a:xfrm>
-          <a:prstGeom prst="rect">
-            <a:avLst/>
-          </a:prstGeom>
-          <a:noFill/>
-          <a:ln/>
-        </p:spPr>
-        <p:txBody>
-          <a:bodyPr wrap="square" lIns="0" tIns="0" rIns="0" bIns="0" rtlCol="0" anchor="t"/>
-          <a:lstStyle/>
-          <a:p>
-            <a:pPr indent="0" marL="0">
-              <a:buNone/>
-            </a:pPr>
-            <a:r>
-              <a:rPr lang="en-US" sz="1100" dirty="0">
+            <a:off x="4754880" y="2011680"/>
+            <a:ext cx="6583680" cy="914400"/>
+          </a:xfrm>
+          <a:prstGeom prst="rect">
+            <a:avLst/>
+          </a:prstGeom>
+          <a:noFill/>
+          <a:ln/>
+        </p:spPr>
+        <p:txBody>
+          <a:bodyPr wrap="square" lIns="0" tIns="0" rIns="0" bIns="0" rtlCol="0" anchor="ctr"/>
+          <a:lstStyle/>
+          <a:p>
+            <a:pPr indent="0" marL="0">
+              <a:buNone/>
+            </a:pPr>
+            <a:r>
+              <a:rPr lang="en-US" sz="1200" dirty="0">
                 <a:solidFill>
                   <a:srgbClr val="8B949E"/>
                 </a:solidFill>
@@ -8914,182 +9747,26 @@
                 <a:ea typeface="Calibri" pitchFamily="34" charset="-122"/>
                 <a:cs typeface="Calibri" pitchFamily="34" charset="-120"/>
               </a:rPr>
-              <a:t>Todo lo comprado en C&amp;D: transceptores, el emulador, el ESP32, componentes.</a:t>
-            </a:r>
-            <a:endParaRPr lang="en-US" sz="1100" dirty="0"/>
-          </a:p>
-        </p:txBody>
-      </p:sp>
-      <p:sp>
-        <p:nvSpPr>
-          <p:cNvPr id="9" name="Text 7"/>
-          <p:cNvSpPr/>
-          <p:nvPr/>
-        </p:nvSpPr>
-        <p:spPr>
-          <a:xfrm>
-            <a:off x="914400" y="3520440"/>
-            <a:ext cx="4846320" cy="320040"/>
-          </a:xfrm>
-          <a:prstGeom prst="rect">
-            <a:avLst/>
-          </a:prstGeom>
-          <a:noFill/>
-          <a:ln/>
-        </p:spPr>
-        <p:txBody>
-          <a:bodyPr wrap="square" lIns="0" tIns="0" rIns="0" bIns="0" rtlCol="0" anchor="ctr"/>
-          <a:lstStyle/>
-          <a:p>
-            <a:pPr indent="0" marL="0">
-              <a:buNone/>
-            </a:pPr>
-            <a:r>
-              <a:rPr lang="en-US" sz="1350" b="1" dirty="0">
-                <a:solidFill>
-                  <a:srgbClr val="ECEBE6"/>
-                </a:solidFill>
-                <a:latin typeface="Calibri" pitchFamily="34" charset="0"/>
-                <a:ea typeface="Calibri" pitchFamily="34" charset="-122"/>
-                <a:cs typeface="Calibri" pitchFamily="34" charset="-120"/>
-              </a:rPr>
-              <a:t>El cómputo (la Jetson)</a:t>
-            </a:r>
-            <a:endParaRPr lang="en-US" sz="1350" dirty="0"/>
-          </a:p>
-        </p:txBody>
-      </p:sp>
-      <p:sp>
-        <p:nvSpPr>
-          <p:cNvPr id="10" name="Text 8"/>
-          <p:cNvSpPr/>
-          <p:nvPr/>
-        </p:nvSpPr>
-        <p:spPr>
-          <a:xfrm>
-            <a:off x="914400" y="3813048"/>
-            <a:ext cx="4846320" cy="502920"/>
-          </a:xfrm>
-          <a:prstGeom prst="rect">
-            <a:avLst/>
-          </a:prstGeom>
-          <a:noFill/>
-          <a:ln/>
-        </p:spPr>
-        <p:txBody>
-          <a:bodyPr wrap="square" lIns="0" tIns="0" rIns="0" bIns="0" rtlCol="0" anchor="t"/>
-          <a:lstStyle/>
-          <a:p>
-            <a:pPr indent="0" marL="0">
-              <a:buNone/>
-            </a:pPr>
-            <a:r>
-              <a:rPr lang="en-US" sz="1100" dirty="0">
-                <a:solidFill>
-                  <a:srgbClr val="8B949E"/>
-                </a:solidFill>
-                <a:latin typeface="Calibri" pitchFamily="34" charset="0"/>
-                <a:ea typeface="Calibri" pitchFamily="34" charset="-122"/>
-                <a:cs typeface="Calibri" pitchFamily="34" charset="-120"/>
-              </a:rPr>
-              <a:t>También es parte del NRE. Lo cubro yo.</a:t>
-            </a:r>
-            <a:endParaRPr lang="en-US" sz="1100" dirty="0"/>
-          </a:p>
-        </p:txBody>
-      </p:sp>
-      <p:sp>
-        <p:nvSpPr>
-          <p:cNvPr id="11" name="Text 9"/>
-          <p:cNvSpPr/>
-          <p:nvPr/>
-        </p:nvSpPr>
-        <p:spPr>
-          <a:xfrm>
-            <a:off x="914400" y="4343400"/>
-            <a:ext cx="4846320" cy="320040"/>
-          </a:xfrm>
-          <a:prstGeom prst="rect">
-            <a:avLst/>
-          </a:prstGeom>
-          <a:noFill/>
-          <a:ln/>
-        </p:spPr>
-        <p:txBody>
-          <a:bodyPr wrap="square" lIns="0" tIns="0" rIns="0" bIns="0" rtlCol="0" anchor="ctr"/>
-          <a:lstStyle/>
-          <a:p>
-            <a:pPr indent="0" marL="0">
-              <a:buNone/>
-            </a:pPr>
-            <a:r>
-              <a:rPr lang="en-US" sz="1350" b="1" dirty="0">
-                <a:solidFill>
-                  <a:srgbClr val="ECEBE6"/>
-                </a:solidFill>
-                <a:latin typeface="Calibri" pitchFamily="34" charset="0"/>
-                <a:ea typeface="Calibri" pitchFamily="34" charset="-122"/>
-                <a:cs typeface="Calibri" pitchFamily="34" charset="-120"/>
-              </a:rPr>
-              <a:t>Por qué</a:t>
-            </a:r>
-            <a:endParaRPr lang="en-US" sz="1350" dirty="0"/>
-          </a:p>
-        </p:txBody>
-      </p:sp>
-      <p:sp>
-        <p:nvSpPr>
-          <p:cNvPr id="12" name="Text 10"/>
-          <p:cNvSpPr/>
-          <p:nvPr/>
-        </p:nvSpPr>
-        <p:spPr>
-          <a:xfrm>
-            <a:off x="914400" y="4636008"/>
-            <a:ext cx="4846320" cy="502920"/>
-          </a:xfrm>
-          <a:prstGeom prst="rect">
-            <a:avLst/>
-          </a:prstGeom>
-          <a:noFill/>
-          <a:ln/>
-        </p:spPr>
-        <p:txBody>
-          <a:bodyPr wrap="square" lIns="0" tIns="0" rIns="0" bIns="0" rtlCol="0" anchor="t"/>
-          <a:lstStyle/>
-          <a:p>
-            <a:pPr indent="0" marL="0">
-              <a:buNone/>
-            </a:pPr>
-            <a:r>
-              <a:rPr lang="en-US" sz="1100" dirty="0">
-                <a:solidFill>
-                  <a:srgbClr val="8B949E"/>
-                </a:solidFill>
-                <a:latin typeface="Calibri" pitchFamily="34" charset="0"/>
-                <a:ea typeface="Calibri" pitchFamily="34" charset="-122"/>
-                <a:cs typeface="Calibri" pitchFamily="34" charset="-120"/>
-              </a:rPr>
-              <a:t>Es mi idea, mi proyecto, mi sueño. El riesgo de la apuesta es mío.</a:t>
-            </a:r>
-            <a:endParaRPr lang="en-US" sz="1100" dirty="0"/>
-          </a:p>
-        </p:txBody>
-      </p:sp>
-      <p:sp>
-        <p:nvSpPr>
-          <p:cNvPr id="13" name="Shape 11"/>
-          <p:cNvSpPr/>
-          <p:nvPr/>
-        </p:nvSpPr>
-        <p:spPr>
-          <a:xfrm>
-            <a:off x="6263640" y="1828800"/>
-            <a:ext cx="5303520" cy="3383280"/>
+              <a:t>Velocidad y ángulo del propio bus del equipo — los sensores ya están adentro. Posición por “cuánto me moví”.</a:t>
+            </a:r>
+            <a:endParaRPr lang="en-US" sz="1200" dirty="0"/>
+          </a:p>
+        </p:txBody>
+      </p:sp>
+      <p:sp>
+        <p:nvSpPr>
+          <p:cNvPr id="9" name="Shape 7"/>
+          <p:cNvSpPr/>
+          <p:nvPr/>
+        </p:nvSpPr>
+        <p:spPr>
+          <a:xfrm>
+            <a:off x="594360" y="3200400"/>
+            <a:ext cx="10972800" cy="1188720"/>
           </a:xfrm>
           <a:prstGeom prst="roundRect">
             <a:avLst>
-              <a:gd name="adj" fmla="val 2432"/>
+              <a:gd name="adj" fmla="val 6923"/>
             </a:avLst>
           </a:prstGeom>
           <a:solidFill>
@@ -9107,128 +9784,128 @@
       </p:sp>
       <p:sp>
         <p:nvSpPr>
-          <p:cNvPr id="14" name="Shape 12"/>
-          <p:cNvSpPr/>
-          <p:nvPr/>
-        </p:nvSpPr>
-        <p:spPr>
-          <a:xfrm>
-            <a:off x="6263640" y="1828800"/>
-            <a:ext cx="5303520" cy="109728"/>
-          </a:xfrm>
-          <a:prstGeom prst="rect">
+          <p:cNvPr id="10" name="Shape 8"/>
+          <p:cNvSpPr/>
+          <p:nvPr/>
+        </p:nvSpPr>
+        <p:spPr>
+          <a:xfrm>
+            <a:off x="914400" y="3602736"/>
+            <a:ext cx="384048" cy="384048"/>
+          </a:xfrm>
+          <a:prstGeom prst="ellipse">
             <a:avLst/>
           </a:prstGeom>
           <a:solidFill>
-            <a:srgbClr val="37C3FF"/>
+            <a:srgbClr val="F5C518"/>
           </a:solidFill>
           <a:ln/>
         </p:spPr>
       </p:sp>
       <p:sp>
         <p:nvSpPr>
-          <p:cNvPr id="15" name="Text 13"/>
-          <p:cNvSpPr/>
-          <p:nvPr/>
-        </p:nvSpPr>
-        <p:spPr>
-          <a:xfrm>
-            <a:off x="6583680" y="2103120"/>
-            <a:ext cx="4663440" cy="457200"/>
-          </a:xfrm>
-          <a:prstGeom prst="rect">
-            <a:avLst/>
-          </a:prstGeom>
-          <a:noFill/>
-          <a:ln/>
-        </p:spPr>
-        <p:txBody>
-          <a:bodyPr wrap="square" lIns="0" tIns="0" rIns="0" bIns="0" rtlCol="0" anchor="ctr"/>
-          <a:lstStyle/>
-          <a:p>
-            <a:pPr indent="0" marL="0">
-              <a:buNone/>
-            </a:pPr>
-            <a:r>
-              <a:rPr lang="en-US" sz="1900" b="1" dirty="0">
-                <a:solidFill>
-                  <a:srgbClr val="37C3FF"/>
+          <p:cNvPr id="11" name="Text 9"/>
+          <p:cNvSpPr/>
+          <p:nvPr/>
+        </p:nvSpPr>
+        <p:spPr>
+          <a:xfrm>
+            <a:off x="914400" y="3602736"/>
+            <a:ext cx="384048" cy="384048"/>
+          </a:xfrm>
+          <a:prstGeom prst="rect">
+            <a:avLst/>
+          </a:prstGeom>
+          <a:noFill/>
+          <a:ln/>
+        </p:spPr>
+        <p:txBody>
+          <a:bodyPr wrap="square" lIns="0" tIns="0" rIns="0" bIns="0" rtlCol="0" anchor="ctr"/>
+          <a:lstStyle/>
+          <a:p>
+            <a:pPr algn="ctr" indent="0" marL="0">
+              <a:buNone/>
+            </a:pPr>
+            <a:r>
+              <a:rPr lang="en-US" sz="1500" b="1" dirty="0">
+                <a:solidFill>
+                  <a:srgbClr val="14171C"/>
+                </a:solidFill>
+                <a:latin typeface="Calibri" pitchFamily="34" charset="0"/>
+                <a:ea typeface="Calibri" pitchFamily="34" charset="-122"/>
+                <a:cs typeface="Calibri" pitchFamily="34" charset="-120"/>
+              </a:rPr>
+              <a:t>2</a:t>
+            </a:r>
+            <a:endParaRPr lang="en-US" sz="1500" dirty="0"/>
+          </a:p>
+        </p:txBody>
+      </p:sp>
+      <p:sp>
+        <p:nvSpPr>
+          <p:cNvPr id="12" name="Text 10"/>
+          <p:cNvSpPr/>
+          <p:nvPr/>
+        </p:nvSpPr>
+        <p:spPr>
+          <a:xfrm>
+            <a:off x="1508760" y="3456432"/>
+            <a:ext cx="3200400" cy="457200"/>
+          </a:xfrm>
+          <a:prstGeom prst="rect">
+            <a:avLst/>
+          </a:prstGeom>
+          <a:noFill/>
+          <a:ln/>
+        </p:spPr>
+        <p:txBody>
+          <a:bodyPr wrap="square" lIns="0" tIns="0" rIns="0" bIns="0" rtlCol="0" anchor="ctr"/>
+          <a:lstStyle/>
+          <a:p>
+            <a:pPr indent="0" marL="0">
+              <a:buNone/>
+            </a:pPr>
+            <a:r>
+              <a:rPr lang="en-US" sz="1600" b="1" dirty="0">
+                <a:solidFill>
+                  <a:srgbClr val="ECEBE6"/>
                 </a:solidFill>
                 <a:latin typeface="Cambria" pitchFamily="34" charset="0"/>
                 <a:ea typeface="Cambria" pitchFamily="34" charset="-122"/>
                 <a:cs typeface="Cambria" pitchFamily="34" charset="-120"/>
               </a:rPr>
-              <a:t>Lo pone Montasa</a:t>
-            </a:r>
-            <a:endParaRPr lang="en-US" sz="1900" dirty="0"/>
-          </a:p>
-        </p:txBody>
-      </p:sp>
-      <p:sp>
-        <p:nvSpPr>
-          <p:cNvPr id="16" name="Text 14"/>
-          <p:cNvSpPr/>
-          <p:nvPr/>
-        </p:nvSpPr>
-        <p:spPr>
-          <a:xfrm>
-            <a:off x="6583680" y="2697480"/>
-            <a:ext cx="4663440" cy="320040"/>
-          </a:xfrm>
-          <a:prstGeom prst="rect">
-            <a:avLst/>
-          </a:prstGeom>
-          <a:noFill/>
-          <a:ln/>
-        </p:spPr>
-        <p:txBody>
-          <a:bodyPr wrap="square" lIns="0" tIns="0" rIns="0" bIns="0" rtlCol="0" anchor="ctr"/>
-          <a:lstStyle/>
-          <a:p>
-            <a:pPr indent="0" marL="0">
-              <a:buNone/>
-            </a:pPr>
-            <a:r>
-              <a:rPr lang="en-US" sz="1350" b="1" dirty="0">
-                <a:solidFill>
-                  <a:srgbClr val="ECEBE6"/>
-                </a:solidFill>
-                <a:latin typeface="Calibri" pitchFamily="34" charset="0"/>
-                <a:ea typeface="Calibri" pitchFamily="34" charset="-122"/>
-                <a:cs typeface="Calibri" pitchFamily="34" charset="-120"/>
-              </a:rPr>
-              <a:t>Reparar el MT 122</a:t>
-            </a:r>
-            <a:endParaRPr lang="en-US" sz="1350" dirty="0"/>
-          </a:p>
-        </p:txBody>
-      </p:sp>
-      <p:sp>
-        <p:nvSpPr>
-          <p:cNvPr id="17" name="Text 15"/>
-          <p:cNvSpPr/>
-          <p:nvPr/>
-        </p:nvSpPr>
-        <p:spPr>
-          <a:xfrm>
-            <a:off x="6583680" y="2990088"/>
-            <a:ext cx="4663440" cy="685800"/>
-          </a:xfrm>
-          <a:prstGeom prst="rect">
-            <a:avLst/>
-          </a:prstGeom>
-          <a:noFill/>
-          <a:ln/>
-        </p:spPr>
-        <p:txBody>
-          <a:bodyPr wrap="square" lIns="0" tIns="0" rIns="0" bIns="0" rtlCol="0" anchor="t"/>
-          <a:lstStyle/>
-          <a:p>
-            <a:pPr indent="0" marL="0">
-              <a:buNone/>
-            </a:pPr>
-            <a:r>
-              <a:rPr lang="en-US" sz="1100" dirty="0">
+              <a:t>Fusión Kalman + ArUco</a:t>
+            </a:r>
+            <a:endParaRPr lang="en-US" sz="1600" dirty="0"/>
+          </a:p>
+        </p:txBody>
+      </p:sp>
+      <p:sp>
+        <p:nvSpPr>
+          <p:cNvPr id="13" name="Text 11"/>
+          <p:cNvSpPr/>
+          <p:nvPr/>
+        </p:nvSpPr>
+        <p:spPr>
+          <a:xfrm>
+            <a:off x="4754880" y="3383280"/>
+            <a:ext cx="6583680" cy="914400"/>
+          </a:xfrm>
+          <a:prstGeom prst="rect">
+            <a:avLst/>
+          </a:prstGeom>
+          <a:noFill/>
+          <a:ln/>
+        </p:spPr>
+        <p:txBody>
+          <a:bodyPr wrap="square" lIns="0" tIns="0" rIns="0" bIns="0" rtlCol="0" anchor="ctr"/>
+          <a:lstStyle/>
+          <a:p>
+            <a:pPr indent="0" marL="0">
+              <a:buNone/>
+            </a:pPr>
+            <a:r>
+              <a:rPr lang="en-US" sz="1200" dirty="0">
                 <a:solidFill>
                   <a:srgbClr val="8B949E"/>
                 </a:solidFill>
@@ -9236,104 +9913,26 @@
                 <a:ea typeface="Calibri" pitchFamily="34" charset="-122"/>
                 <a:cs typeface="Calibri" pitchFamily="34" charset="-120"/>
               </a:rPr>
-              <a:t>Su propio activo, que vuelve a rentar. No es gasto del proyecto.</a:t>
-            </a:r>
-            <a:endParaRPr lang="en-US" sz="1100" dirty="0"/>
-          </a:p>
-        </p:txBody>
-      </p:sp>
-      <p:sp>
-        <p:nvSpPr>
-          <p:cNvPr id="18" name="Text 16"/>
-          <p:cNvSpPr/>
-          <p:nvPr/>
-        </p:nvSpPr>
-        <p:spPr>
-          <a:xfrm>
-            <a:off x="6583680" y="3886200"/>
-            <a:ext cx="4663440" cy="320040"/>
-          </a:xfrm>
-          <a:prstGeom prst="rect">
-            <a:avLst/>
-          </a:prstGeom>
-          <a:noFill/>
-          <a:ln/>
-        </p:spPr>
-        <p:txBody>
-          <a:bodyPr wrap="square" lIns="0" tIns="0" rIns="0" bIns="0" rtlCol="0" anchor="ctr"/>
-          <a:lstStyle/>
-          <a:p>
-            <a:pPr indent="0" marL="0">
-              <a:buNone/>
-            </a:pPr>
-            <a:r>
-              <a:rPr lang="en-US" sz="1350" b="1" dirty="0">
-                <a:solidFill>
-                  <a:srgbClr val="ECEBE6"/>
-                </a:solidFill>
-                <a:latin typeface="Calibri" pitchFamily="34" charset="0"/>
-                <a:ea typeface="Calibri" pitchFamily="34" charset="-122"/>
-                <a:cs typeface="Calibri" pitchFamily="34" charset="-120"/>
-              </a:rPr>
-              <a:t>Salario y confianza</a:t>
-            </a:r>
-            <a:endParaRPr lang="en-US" sz="1350" dirty="0"/>
-          </a:p>
-        </p:txBody>
-      </p:sp>
-      <p:sp>
-        <p:nvSpPr>
-          <p:cNvPr id="19" name="Text 17"/>
-          <p:cNvSpPr/>
-          <p:nvPr/>
-        </p:nvSpPr>
-        <p:spPr>
-          <a:xfrm>
-            <a:off x="6583680" y="4178808"/>
-            <a:ext cx="4663440" cy="685800"/>
-          </a:xfrm>
-          <a:prstGeom prst="rect">
-            <a:avLst/>
-          </a:prstGeom>
-          <a:noFill/>
-          <a:ln/>
-        </p:spPr>
-        <p:txBody>
-          <a:bodyPr wrap="square" lIns="0" tIns="0" rIns="0" bIns="0" rtlCol="0" anchor="t"/>
-          <a:lstStyle/>
-          <a:p>
-            <a:pPr indent="0" marL="0">
-              <a:buNone/>
-            </a:pPr>
-            <a:r>
-              <a:rPr lang="en-US" sz="1100" dirty="0">
-                <a:solidFill>
-                  <a:srgbClr val="8B949E"/>
-                </a:solidFill>
-                <a:latin typeface="Calibri" pitchFamily="34" charset="0"/>
-                <a:ea typeface="Calibri" pitchFamily="34" charset="-122"/>
-                <a:cs typeface="Calibri" pitchFamily="34" charset="-120"/>
-              </a:rPr>
-              <a:t>Lo que Montasa ya me ha dado. Lo tomo como su inversión en esto.</a:t>
-            </a:r>
-            <a:endParaRPr lang="en-US" sz="1100" dirty="0"/>
-          </a:p>
-        </p:txBody>
-      </p:sp>
-      <p:sp>
-        <p:nvSpPr>
-          <p:cNvPr id="20" name="Shape 18"/>
-          <p:cNvSpPr/>
-          <p:nvPr/>
-        </p:nvSpPr>
-        <p:spPr>
-          <a:xfrm>
-            <a:off x="594360" y="5486400"/>
-            <a:ext cx="10972800" cy="777240"/>
+              <a:t>Un filtro combina la odometría con las marcas ArUco de los racks: corrige la deriva y da la posición absoluta. Este es el siguiente paso, con sólo cámaras.</a:t>
+            </a:r>
+            <a:endParaRPr lang="en-US" sz="1200" dirty="0"/>
+          </a:p>
+        </p:txBody>
+      </p:sp>
+      <p:sp>
+        <p:nvSpPr>
+          <p:cNvPr id="14" name="Shape 12"/>
+          <p:cNvSpPr/>
+          <p:nvPr/>
+        </p:nvSpPr>
+        <p:spPr>
+          <a:xfrm>
+            <a:off x="594360" y="4572000"/>
+            <a:ext cx="10972800" cy="1188720"/>
           </a:xfrm>
           <a:prstGeom prst="roundRect">
             <a:avLst>
-              <a:gd name="adj" fmla="val 10588"/>
+              <a:gd name="adj" fmla="val 6923"/>
             </a:avLst>
           </a:prstGeom>
           <a:solidFill>
@@ -9351,40 +9950,138 @@
       </p:sp>
       <p:sp>
         <p:nvSpPr>
-          <p:cNvPr id="21" name="Text 19"/>
-          <p:cNvSpPr/>
-          <p:nvPr/>
-        </p:nvSpPr>
-        <p:spPr>
-          <a:xfrm>
-            <a:off x="960120" y="5486400"/>
-            <a:ext cx="10241280" cy="777240"/>
-          </a:xfrm>
-          <a:prstGeom prst="rect">
-            <a:avLst/>
-          </a:prstGeom>
-          <a:noFill/>
-          <a:ln/>
-        </p:spPr>
-        <p:txBody>
-          <a:bodyPr wrap="square" lIns="0" tIns="0" rIns="0" bIns="0" rtlCol="0" anchor="ctr"/>
-          <a:lstStyle/>
-          <a:p>
-            <a:pPr indent="0" marL="0">
-              <a:buNone/>
-            </a:pPr>
-            <a:r>
-              <a:rPr lang="en-US" sz="1400" b="1" dirty="0">
-                <a:solidFill>
-                  <a:srgbClr val="F5C518"/>
-                </a:solidFill>
-                <a:latin typeface="Calibri" pitchFamily="34" charset="0"/>
-                <a:ea typeface="Calibri" pitchFamily="34" charset="-122"/>
-                <a:cs typeface="Calibri" pitchFamily="34" charset="-120"/>
-              </a:rPr>
-              <a:t>No le pido a Montasa que financie mi sueño. Le pido que recupere una máquina suya — y yo pongo todo lo demás.</a:t>
-            </a:r>
-            <a:endParaRPr lang="en-US" sz="1400" dirty="0"/>
+          <p:cNvPr id="15" name="Shape 13"/>
+          <p:cNvSpPr/>
+          <p:nvPr/>
+        </p:nvSpPr>
+        <p:spPr>
+          <a:xfrm>
+            <a:off x="914400" y="4974336"/>
+            <a:ext cx="384048" cy="384048"/>
+          </a:xfrm>
+          <a:prstGeom prst="ellipse">
+            <a:avLst/>
+          </a:prstGeom>
+          <a:solidFill>
+            <a:srgbClr val="39D98A"/>
+          </a:solidFill>
+          <a:ln/>
+        </p:spPr>
+      </p:sp>
+      <p:sp>
+        <p:nvSpPr>
+          <p:cNvPr id="16" name="Text 14"/>
+          <p:cNvSpPr/>
+          <p:nvPr/>
+        </p:nvSpPr>
+        <p:spPr>
+          <a:xfrm>
+            <a:off x="914400" y="4974336"/>
+            <a:ext cx="384048" cy="384048"/>
+          </a:xfrm>
+          <a:prstGeom prst="rect">
+            <a:avLst/>
+          </a:prstGeom>
+          <a:noFill/>
+          <a:ln/>
+        </p:spPr>
+        <p:txBody>
+          <a:bodyPr wrap="square" lIns="0" tIns="0" rIns="0" bIns="0" rtlCol="0" anchor="ctr"/>
+          <a:lstStyle/>
+          <a:p>
+            <a:pPr algn="ctr" indent="0" marL="0">
+              <a:buNone/>
+            </a:pPr>
+            <a:r>
+              <a:rPr lang="en-US" sz="1500" b="1" dirty="0">
+                <a:solidFill>
+                  <a:srgbClr val="14171C"/>
+                </a:solidFill>
+                <a:latin typeface="Calibri" pitchFamily="34" charset="0"/>
+                <a:ea typeface="Calibri" pitchFamily="34" charset="-122"/>
+                <a:cs typeface="Calibri" pitchFamily="34" charset="-120"/>
+              </a:rPr>
+              <a:t>3</a:t>
+            </a:r>
+            <a:endParaRPr lang="en-US" sz="1500" dirty="0"/>
+          </a:p>
+        </p:txBody>
+      </p:sp>
+      <p:sp>
+        <p:nvSpPr>
+          <p:cNvPr id="17" name="Text 15"/>
+          <p:cNvSpPr/>
+          <p:nvPr/>
+        </p:nvSpPr>
+        <p:spPr>
+          <a:xfrm>
+            <a:off x="1508760" y="4828032"/>
+            <a:ext cx="3200400" cy="457200"/>
+          </a:xfrm>
+          <a:prstGeom prst="rect">
+            <a:avLst/>
+          </a:prstGeom>
+          <a:noFill/>
+          <a:ln/>
+        </p:spPr>
+        <p:txBody>
+          <a:bodyPr wrap="square" lIns="0" tIns="0" rIns="0" bIns="0" rtlCol="0" anchor="ctr"/>
+          <a:lstStyle/>
+          <a:p>
+            <a:pPr indent="0" marL="0">
+              <a:buNone/>
+            </a:pPr>
+            <a:r>
+              <a:rPr lang="en-US" sz="1600" b="1" dirty="0">
+                <a:solidFill>
+                  <a:srgbClr val="ECEBE6"/>
+                </a:solidFill>
+                <a:latin typeface="Cambria" pitchFamily="34" charset="0"/>
+                <a:ea typeface="Cambria" pitchFamily="34" charset="-122"/>
+                <a:cs typeface="Cambria" pitchFamily="34" charset="-120"/>
+              </a:rPr>
+              <a:t>LiDAR / SLAM</a:t>
+            </a:r>
+            <a:endParaRPr lang="en-US" sz="1600" dirty="0"/>
+          </a:p>
+        </p:txBody>
+      </p:sp>
+      <p:sp>
+        <p:nvSpPr>
+          <p:cNvPr id="18" name="Text 16"/>
+          <p:cNvSpPr/>
+          <p:nvPr/>
+        </p:nvSpPr>
+        <p:spPr>
+          <a:xfrm>
+            <a:off x="4754880" y="4754880"/>
+            <a:ext cx="6583680" cy="914400"/>
+          </a:xfrm>
+          <a:prstGeom prst="rect">
+            <a:avLst/>
+          </a:prstGeom>
+          <a:noFill/>
+          <a:ln/>
+        </p:spPr>
+        <p:txBody>
+          <a:bodyPr wrap="square" lIns="0" tIns="0" rIns="0" bIns="0" rtlCol="0" anchor="ctr"/>
+          <a:lstStyle/>
+          <a:p>
+            <a:pPr indent="0" marL="0">
+              <a:buNone/>
+            </a:pPr>
+            <a:r>
+              <a:rPr lang="en-US" sz="1200" dirty="0">
+                <a:solidFill>
+                  <a:srgbClr val="8B949E"/>
+                </a:solidFill>
+                <a:latin typeface="Calibri" pitchFamily="34" charset="0"/>
+                <a:ea typeface="Calibri" pitchFamily="34" charset="-122"/>
+                <a:cs typeface="Calibri" pitchFamily="34" charset="-120"/>
+              </a:rPr>
+              <a:t>Mapeo en vivo y detección de obstáculos. Sigue en el plan — se suma después de formalizar el proyecto. No se descarta.</a:t>
+            </a:r>
+            <a:endParaRPr lang="en-US" sz="1200" dirty="0"/>
           </a:p>
         </p:txBody>
       </p:sp>

</xml_diff>

<commit_message>
deck Omar: El Aula como slide de texto (sin plano)
Se quita el dibujo del Aula (a pedido) y los helpers de plano sin uso.
Queda un slide de texto con tres puntos: reconfigurar espacio muerto
(equipamiento no usado + racks) para liberar un espacio de 3x6 m; ambiente
cerrado como cualquier almacen incluido RETHINK; y la luz inestable como
factor que ayuda a la robustez. Footer: pruebas con pantografo sin uñas +
sensor de altura calibrado.

Co-Authored-By: Claude Opus 4.8 <noreply@anthropic.com>
Claude-Session: https://claude.ai/code/session_01KLG9KVbY9Gwk6b8JaDsbqA
</commit_message>
<xml_diff>
--- a/presentaciones/TaTa_Estado_y_Pedido_Omar.pptx
+++ b/presentaciones/TaTa_Estado_y_Pedido_Omar.pptx
@@ -958,7 +958,7 @@
           <a:p>
             <a:r>
               <a:rPr lang="en-US" dirty="0"/>
-              <a:t>Mi orden del dibujo: actual = todo el taller, sombreado = en uso no se toca, rack 4 en area de mecanicos. Propuesta = solo el lado derecho, rack 4 movido flanquea el pasillo y libera a los mecanicos.</a:t>
+              <a:t>Se quito el plano a pedido. El Aula = reconfigurar espacio muerto (equipo no usado + racks) para un espacio 3x6, ambiente cerrado como RETHINK, y la luz inestable ayuda a la robustez.</a:t>
             </a:r>
             <a:endParaRPr lang="en-US" dirty="0"/>
           </a:p>
@@ -5207,7 +5207,7 @@
                 <a:ea typeface="Cambria" pitchFamily="34" charset="-122"/>
                 <a:cs typeface="Cambria" pitchFamily="34" charset="-120"/>
               </a:rPr>
-              <a:t>El Aula — el banco de pruebas, dentro del taller</a:t>
+              <a:t>El Aula — el banco de pruebas</a:t>
             </a:r>
             <a:endParaRPr lang="en-US" sz="3200" dirty="0"/>
           </a:p>
@@ -5246,7 +5246,7 @@
                 <a:ea typeface="Calibri" pitchFamily="34" charset="-122"/>
                 <a:cs typeface="Calibri" pitchFamily="34" charset="-120"/>
               </a:rPr>
-              <a:t>Mover el rack 4 libera espacio a los mecánicos y deja un pasillo de 3.0 × 6.0 m. Lo sombreado ya se usa y no se toca</a:t>
+              <a:t>En una etapa más adelante, dentro del taller</a:t>
             </a:r>
             <a:endParaRPr lang="en-US" sz="1350" dirty="0"/>
           </a:p>
@@ -5254,3548 +5254,18 @@
       </p:sp>
       <p:sp>
         <p:nvSpPr>
-          <p:cNvPr id="4" name="Text 2"/>
-          <p:cNvSpPr/>
-          <p:nvPr/>
-        </p:nvSpPr>
-        <p:spPr>
-          <a:xfrm>
-            <a:off x="594360" y="1554480"/>
-            <a:ext cx="6583680" cy="274320"/>
-          </a:xfrm>
-          <a:prstGeom prst="rect">
-            <a:avLst/>
-          </a:prstGeom>
-          <a:noFill/>
-          <a:ln/>
-        </p:spPr>
-        <p:txBody>
-          <a:bodyPr wrap="square" lIns="0" tIns="0" rIns="0" bIns="0" rtlCol="0" anchor="ctr"/>
-          <a:lstStyle/>
-          <a:p>
-            <a:pPr indent="0" marL="0">
-              <a:buNone/>
-            </a:pPr>
-            <a:r>
-              <a:rPr lang="en-US" sz="1250" b="1" dirty="0">
-                <a:solidFill>
-                  <a:srgbClr val="5B6470"/>
-                </a:solidFill>
-                <a:latin typeface="Calibri" pitchFamily="34" charset="0"/>
-                <a:ea typeface="Calibri" pitchFamily="34" charset="-122"/>
-                <a:cs typeface="Calibri" pitchFamily="34" charset="-120"/>
-              </a:rPr>
-              <a:t>Taller hoy</a:t>
-            </a:r>
-            <a:endParaRPr lang="en-US" sz="1250" dirty="0"/>
-          </a:p>
-        </p:txBody>
-      </p:sp>
-      <p:sp>
-        <p:nvSpPr>
-          <p:cNvPr id="5" name="Shape 3"/>
-          <p:cNvSpPr/>
-          <p:nvPr/>
-        </p:nvSpPr>
-        <p:spPr>
-          <a:xfrm>
-            <a:off x="594360" y="1828800"/>
-            <a:ext cx="6583680" cy="3246120"/>
-          </a:xfrm>
-          <a:prstGeom prst="rect">
-            <a:avLst/>
-          </a:prstGeom>
-          <a:solidFill>
-            <a:srgbClr val="FFFFFF"/>
-          </a:solidFill>
-          <a:ln w="30480">
-            <a:solidFill>
-              <a:srgbClr val="3A3F49"/>
-            </a:solidFill>
-            <a:prstDash val="solid"/>
-          </a:ln>
-        </p:spPr>
-      </p:sp>
-      <p:sp>
-        <p:nvSpPr>
-          <p:cNvPr id="6" name="Shape 4"/>
-          <p:cNvSpPr/>
-          <p:nvPr/>
-        </p:nvSpPr>
-        <p:spPr>
-          <a:xfrm>
-            <a:off x="704088" y="2240280"/>
-            <a:ext cx="2103120" cy="1051560"/>
-          </a:xfrm>
-          <a:prstGeom prst="rect">
-            <a:avLst/>
-          </a:prstGeom>
-          <a:solidFill>
-            <a:srgbClr val="DCE0D6"/>
-          </a:solidFill>
-          <a:ln w="12700">
-            <a:solidFill>
-              <a:srgbClr val="AEB4A6"/>
-            </a:solidFill>
-            <a:prstDash val="solid"/>
-          </a:ln>
-        </p:spPr>
-      </p:sp>
-      <p:sp>
-        <p:nvSpPr>
-          <p:cNvPr id="7" name="Text 5"/>
-          <p:cNvSpPr/>
-          <p:nvPr/>
-        </p:nvSpPr>
-        <p:spPr>
-          <a:xfrm>
-            <a:off x="704088" y="2240280"/>
-            <a:ext cx="2103120" cy="1051560"/>
-          </a:xfrm>
-          <a:prstGeom prst="rect">
-            <a:avLst/>
-          </a:prstGeom>
-          <a:noFill/>
-          <a:ln/>
-        </p:spPr>
-        <p:txBody>
-          <a:bodyPr wrap="square" lIns="0" tIns="0" rIns="0" bIns="0" rtlCol="0" anchor="ctr"/>
-          <a:lstStyle/>
-          <a:p>
-            <a:pPr algn="ctr" indent="0" marL="0">
-              <a:buNone/>
-            </a:pPr>
-            <a:r>
-              <a:rPr lang="en-US" sz="950" i="1" dirty="0">
-                <a:solidFill>
-                  <a:srgbClr val="6B7266"/>
-                </a:solidFill>
-                <a:latin typeface="Calibri" pitchFamily="34" charset="0"/>
-                <a:ea typeface="Calibri" pitchFamily="34" charset="-122"/>
-                <a:cs typeface="Calibri" pitchFamily="34" charset="-120"/>
-              </a:rPr>
-              <a:t>en uso</a:t>
-            </a:r>
-            <a:endParaRPr lang="en-US" sz="950" dirty="0"/>
-          </a:p>
-          <a:p>
-            <a:pPr algn="ctr" indent="0" marL="0">
-              <a:buNone/>
-            </a:pPr>
-            <a:r>
-              <a:rPr lang="en-US" sz="950" i="1" dirty="0">
-                <a:solidFill>
-                  <a:srgbClr val="6B7266"/>
-                </a:solidFill>
-                <a:latin typeface="Calibri" pitchFamily="34" charset="0"/>
-                <a:ea typeface="Calibri" pitchFamily="34" charset="-122"/>
-                <a:cs typeface="Calibri" pitchFamily="34" charset="-120"/>
-              </a:rPr>
-              <a:t>no se toca</a:t>
-            </a:r>
-            <a:endParaRPr lang="en-US" sz="950" dirty="0"/>
-          </a:p>
-        </p:txBody>
-      </p:sp>
-      <p:sp>
-        <p:nvSpPr>
-          <p:cNvPr id="8" name="Shape 6"/>
-          <p:cNvSpPr/>
-          <p:nvPr/>
-        </p:nvSpPr>
-        <p:spPr>
-          <a:xfrm>
-            <a:off x="704088" y="3520440"/>
-            <a:ext cx="1920240" cy="1325880"/>
-          </a:xfrm>
-          <a:prstGeom prst="rect">
-            <a:avLst/>
-          </a:prstGeom>
-          <a:solidFill>
-            <a:srgbClr val="DCE0D6"/>
-          </a:solidFill>
-          <a:ln w="12700">
-            <a:solidFill>
-              <a:srgbClr val="AEB4A6"/>
-            </a:solidFill>
-            <a:prstDash val="solid"/>
-          </a:ln>
-        </p:spPr>
-      </p:sp>
-      <p:sp>
-        <p:nvSpPr>
-          <p:cNvPr id="9" name="Text 7"/>
-          <p:cNvSpPr/>
-          <p:nvPr/>
-        </p:nvSpPr>
-        <p:spPr>
-          <a:xfrm>
-            <a:off x="704088" y="3520440"/>
-            <a:ext cx="1920240" cy="1325880"/>
-          </a:xfrm>
-          <a:prstGeom prst="rect">
-            <a:avLst/>
-          </a:prstGeom>
-          <a:noFill/>
-          <a:ln/>
-        </p:spPr>
-        <p:txBody>
-          <a:bodyPr wrap="square" lIns="0" tIns="0" rIns="0" bIns="0" rtlCol="0" anchor="ctr"/>
-          <a:lstStyle/>
-          <a:p>
-            <a:pPr algn="ctr" indent="0" marL="0">
-              <a:buNone/>
-            </a:pPr>
-            <a:r>
-              <a:rPr lang="en-US" sz="950" i="1" dirty="0">
-                <a:solidFill>
-                  <a:srgbClr val="6B7266"/>
-                </a:solidFill>
-                <a:latin typeface="Calibri" pitchFamily="34" charset="0"/>
-                <a:ea typeface="Calibri" pitchFamily="34" charset="-122"/>
-                <a:cs typeface="Calibri" pitchFamily="34" charset="-120"/>
-              </a:rPr>
-              <a:t>en uso</a:t>
-            </a:r>
-            <a:endParaRPr lang="en-US" sz="950" dirty="0"/>
-          </a:p>
-          <a:p>
-            <a:pPr algn="ctr" indent="0" marL="0">
-              <a:buNone/>
-            </a:pPr>
-            <a:r>
-              <a:rPr lang="en-US" sz="950" i="1" dirty="0">
-                <a:solidFill>
-                  <a:srgbClr val="6B7266"/>
-                </a:solidFill>
-                <a:latin typeface="Calibri" pitchFamily="34" charset="0"/>
-                <a:ea typeface="Calibri" pitchFamily="34" charset="-122"/>
-                <a:cs typeface="Calibri" pitchFamily="34" charset="-120"/>
-              </a:rPr>
-              <a:t>no se toca</a:t>
-            </a:r>
-            <a:endParaRPr lang="en-US" sz="950" dirty="0"/>
-          </a:p>
-        </p:txBody>
-      </p:sp>
-      <p:sp>
-        <p:nvSpPr>
-          <p:cNvPr id="10" name="Shape 8"/>
-          <p:cNvSpPr/>
-          <p:nvPr/>
-        </p:nvSpPr>
-        <p:spPr>
-          <a:xfrm>
-            <a:off x="2880360" y="4370832"/>
-            <a:ext cx="1188720" cy="603504"/>
-          </a:xfrm>
-          <a:prstGeom prst="rect">
-            <a:avLst/>
-          </a:prstGeom>
-          <a:solidFill>
-            <a:srgbClr val="E7DCC8"/>
-          </a:solidFill>
-          <a:ln w="12700">
-            <a:solidFill>
-              <a:srgbClr val="C9B88E"/>
-            </a:solidFill>
-            <a:prstDash val="solid"/>
-          </a:ln>
-        </p:spPr>
-      </p:sp>
-      <p:sp>
-        <p:nvSpPr>
-          <p:cNvPr id="11" name="Text 9"/>
-          <p:cNvSpPr/>
-          <p:nvPr/>
-        </p:nvSpPr>
-        <p:spPr>
-          <a:xfrm>
-            <a:off x="2880360" y="4370832"/>
-            <a:ext cx="1188720" cy="603504"/>
-          </a:xfrm>
-          <a:prstGeom prst="rect">
-            <a:avLst/>
-          </a:prstGeom>
-          <a:noFill/>
-          <a:ln/>
-        </p:spPr>
-        <p:txBody>
-          <a:bodyPr wrap="square" lIns="0" tIns="0" rIns="0" bIns="0" rtlCol="0" anchor="ctr"/>
-          <a:lstStyle/>
-          <a:p>
-            <a:pPr algn="ctr" indent="0" marL="0">
-              <a:buNone/>
-            </a:pPr>
-            <a:r>
-              <a:rPr lang="en-US" sz="850" b="1" dirty="0">
-                <a:solidFill>
-                  <a:srgbClr val="8A6D16"/>
-                </a:solidFill>
-                <a:latin typeface="Calibri" pitchFamily="34" charset="0"/>
-                <a:ea typeface="Calibri" pitchFamily="34" charset="-122"/>
-                <a:cs typeface="Calibri" pitchFamily="34" charset="-120"/>
-              </a:rPr>
-              <a:t>rampa / portón</a:t>
-            </a:r>
-            <a:endParaRPr lang="en-US" sz="850" dirty="0"/>
-          </a:p>
-        </p:txBody>
-      </p:sp>
-      <p:sp>
-        <p:nvSpPr>
-          <p:cNvPr id="12" name="Shape 10"/>
-          <p:cNvSpPr/>
-          <p:nvPr/>
-        </p:nvSpPr>
-        <p:spPr>
-          <a:xfrm>
-            <a:off x="5349240" y="2066544"/>
-            <a:ext cx="274320" cy="274320"/>
-          </a:xfrm>
-          <a:prstGeom prst="rect">
-            <a:avLst/>
-          </a:prstGeom>
-          <a:solidFill>
-            <a:srgbClr val="E7E9EC"/>
-          </a:solidFill>
-          <a:ln w="12700">
-            <a:solidFill>
-              <a:srgbClr val="C8CCD2"/>
-            </a:solidFill>
-            <a:prstDash val="solid"/>
-          </a:ln>
-        </p:spPr>
-      </p:sp>
-      <p:sp>
-        <p:nvSpPr>
-          <p:cNvPr id="13" name="Shape 11"/>
-          <p:cNvSpPr/>
-          <p:nvPr/>
-        </p:nvSpPr>
-        <p:spPr>
-          <a:xfrm>
-            <a:off x="5678424" y="2066544"/>
-            <a:ext cx="274320" cy="274320"/>
-          </a:xfrm>
-          <a:prstGeom prst="rect">
-            <a:avLst/>
-          </a:prstGeom>
-          <a:solidFill>
-            <a:srgbClr val="E7E9EC"/>
-          </a:solidFill>
-          <a:ln w="12700">
-            <a:solidFill>
-              <a:srgbClr val="C8CCD2"/>
-            </a:solidFill>
-            <a:prstDash val="solid"/>
-          </a:ln>
-        </p:spPr>
-      </p:sp>
-      <p:sp>
-        <p:nvSpPr>
-          <p:cNvPr id="14" name="Shape 12"/>
-          <p:cNvSpPr/>
-          <p:nvPr/>
-        </p:nvSpPr>
-        <p:spPr>
-          <a:xfrm>
-            <a:off x="6007608" y="2066544"/>
-            <a:ext cx="274320" cy="274320"/>
-          </a:xfrm>
-          <a:prstGeom prst="rect">
-            <a:avLst/>
-          </a:prstGeom>
-          <a:solidFill>
-            <a:srgbClr val="E7E9EC"/>
-          </a:solidFill>
-          <a:ln w="12700">
-            <a:solidFill>
-              <a:srgbClr val="C8CCD2"/>
-            </a:solidFill>
-            <a:prstDash val="solid"/>
-          </a:ln>
-        </p:spPr>
-      </p:sp>
-      <p:sp>
-        <p:nvSpPr>
-          <p:cNvPr id="15" name="Shape 13"/>
-          <p:cNvSpPr/>
-          <p:nvPr/>
-        </p:nvSpPr>
-        <p:spPr>
-          <a:xfrm>
-            <a:off x="4389120" y="2487168"/>
-            <a:ext cx="777240" cy="438912"/>
+          <p:cNvPr id="4" name="Shape 2"/>
+          <p:cNvSpPr/>
+          <p:nvPr/>
+        </p:nvSpPr>
+        <p:spPr>
+          <a:xfrm>
+            <a:off x="594360" y="1783080"/>
+            <a:ext cx="10972800" cy="1188720"/>
           </a:xfrm>
           <a:prstGeom prst="roundRect">
             <a:avLst>
-              <a:gd name="adj" fmla="val 10417"/>
-            </a:avLst>
-          </a:prstGeom>
-          <a:solidFill>
-            <a:srgbClr val="E4E7DF"/>
-          </a:solidFill>
-          <a:ln w="13970">
-            <a:solidFill>
-              <a:srgbClr val="566270"/>
-            </a:solidFill>
-            <a:prstDash val="solid"/>
-          </a:ln>
-        </p:spPr>
-      </p:sp>
-      <p:sp>
-        <p:nvSpPr>
-          <p:cNvPr id="16" name="Shape 14"/>
-          <p:cNvSpPr/>
-          <p:nvPr/>
-        </p:nvSpPr>
-        <p:spPr>
-          <a:xfrm>
-            <a:off x="4617171" y="2176272"/>
-            <a:ext cx="64008" cy="310896"/>
-          </a:xfrm>
-          <a:prstGeom prst="rect">
-            <a:avLst/>
-          </a:prstGeom>
-          <a:solidFill>
-            <a:srgbClr val="566270"/>
-          </a:solidFill>
-          <a:ln/>
-        </p:spPr>
-      </p:sp>
-      <p:sp>
-        <p:nvSpPr>
-          <p:cNvPr id="17" name="Shape 15"/>
-          <p:cNvSpPr/>
-          <p:nvPr/>
-        </p:nvSpPr>
-        <p:spPr>
-          <a:xfrm>
-            <a:off x="4874301" y="2176272"/>
-            <a:ext cx="64008" cy="310896"/>
-          </a:xfrm>
-          <a:prstGeom prst="rect">
-            <a:avLst/>
-          </a:prstGeom>
-          <a:solidFill>
-            <a:srgbClr val="566270"/>
-          </a:solidFill>
-          <a:ln/>
-        </p:spPr>
-      </p:sp>
-      <p:sp>
-        <p:nvSpPr>
-          <p:cNvPr id="18" name="Shape 16"/>
-          <p:cNvSpPr/>
-          <p:nvPr/>
-        </p:nvSpPr>
-        <p:spPr>
-          <a:xfrm>
-            <a:off x="4617171" y="2441448"/>
-            <a:ext cx="321137" cy="45720"/>
-          </a:xfrm>
-          <a:prstGeom prst="rect">
-            <a:avLst/>
-          </a:prstGeom>
-          <a:solidFill>
-            <a:srgbClr val="566270"/>
-          </a:solidFill>
-          <a:ln/>
-        </p:spPr>
-      </p:sp>
-      <p:sp>
-        <p:nvSpPr>
-          <p:cNvPr id="19" name="Text 17"/>
-          <p:cNvSpPr/>
-          <p:nvPr/>
-        </p:nvSpPr>
-        <p:spPr>
-          <a:xfrm>
-            <a:off x="4389120" y="2487168"/>
-            <a:ext cx="777240" cy="438912"/>
-          </a:xfrm>
-          <a:prstGeom prst="rect">
-            <a:avLst/>
-          </a:prstGeom>
-          <a:noFill/>
-          <a:ln/>
-        </p:spPr>
-        <p:txBody>
-          <a:bodyPr wrap="square" lIns="0" tIns="0" rIns="0" bIns="0" rtlCol="0" anchor="ctr"/>
-          <a:lstStyle/>
-          <a:p>
-            <a:pPr algn="ctr" indent="0" marL="0">
-              <a:buNone/>
-            </a:pPr>
-            <a:r>
-              <a:rPr lang="en-US" sz="900" b="1" dirty="0">
-                <a:solidFill>
-                  <a:srgbClr val="2A2F39"/>
-                </a:solidFill>
-                <a:latin typeface="Calibri" pitchFamily="34" charset="0"/>
-                <a:ea typeface="Calibri" pitchFamily="34" charset="-122"/>
-                <a:cs typeface="Calibri" pitchFamily="34" charset="-120"/>
-              </a:rPr>
-              <a:t>5</a:t>
-            </a:r>
-            <a:endParaRPr lang="en-US" sz="900" dirty="0"/>
-          </a:p>
-        </p:txBody>
-      </p:sp>
-      <p:sp>
-        <p:nvSpPr>
-          <p:cNvPr id="20" name="Shape 18"/>
-          <p:cNvSpPr/>
-          <p:nvPr/>
-        </p:nvSpPr>
-        <p:spPr>
-          <a:xfrm>
-            <a:off x="5394960" y="2505456"/>
-            <a:ext cx="694944" cy="438912"/>
-          </a:xfrm>
-          <a:prstGeom prst="roundRect">
-            <a:avLst>
-              <a:gd name="adj" fmla="val 10417"/>
-            </a:avLst>
-          </a:prstGeom>
-          <a:solidFill>
-            <a:srgbClr val="E4E7DF"/>
-          </a:solidFill>
-          <a:ln w="13970">
-            <a:solidFill>
-              <a:srgbClr val="566270"/>
-            </a:solidFill>
-            <a:prstDash val="solid"/>
-          </a:ln>
-        </p:spPr>
-      </p:sp>
-      <p:sp>
-        <p:nvSpPr>
-          <p:cNvPr id="21" name="Shape 19"/>
-          <p:cNvSpPr/>
-          <p:nvPr/>
-        </p:nvSpPr>
-        <p:spPr>
-          <a:xfrm>
-            <a:off x="5581863" y="2194560"/>
-            <a:ext cx="64008" cy="310896"/>
-          </a:xfrm>
-          <a:prstGeom prst="rect">
-            <a:avLst/>
-          </a:prstGeom>
-          <a:solidFill>
-            <a:srgbClr val="566270"/>
-          </a:solidFill>
-          <a:ln/>
-        </p:spPr>
-      </p:sp>
-      <p:sp>
-        <p:nvSpPr>
-          <p:cNvPr id="22" name="Shape 20"/>
-          <p:cNvSpPr/>
-          <p:nvPr/>
-        </p:nvSpPr>
-        <p:spPr>
-          <a:xfrm>
-            <a:off x="5838993" y="2194560"/>
-            <a:ext cx="64008" cy="310896"/>
-          </a:xfrm>
-          <a:prstGeom prst="rect">
-            <a:avLst/>
-          </a:prstGeom>
-          <a:solidFill>
-            <a:srgbClr val="566270"/>
-          </a:solidFill>
-          <a:ln/>
-        </p:spPr>
-      </p:sp>
-      <p:sp>
-        <p:nvSpPr>
-          <p:cNvPr id="23" name="Shape 21"/>
-          <p:cNvSpPr/>
-          <p:nvPr/>
-        </p:nvSpPr>
-        <p:spPr>
-          <a:xfrm>
-            <a:off x="5581863" y="2459736"/>
-            <a:ext cx="321137" cy="45720"/>
-          </a:xfrm>
-          <a:prstGeom prst="rect">
-            <a:avLst/>
-          </a:prstGeom>
-          <a:solidFill>
-            <a:srgbClr val="566270"/>
-          </a:solidFill>
-          <a:ln/>
-        </p:spPr>
-      </p:sp>
-      <p:sp>
-        <p:nvSpPr>
-          <p:cNvPr id="24" name="Text 22"/>
-          <p:cNvSpPr/>
-          <p:nvPr/>
-        </p:nvSpPr>
-        <p:spPr>
-          <a:xfrm>
-            <a:off x="5394960" y="2505456"/>
-            <a:ext cx="694944" cy="438912"/>
-          </a:xfrm>
-          <a:prstGeom prst="rect">
-            <a:avLst/>
-          </a:prstGeom>
-          <a:noFill/>
-          <a:ln/>
-        </p:spPr>
-        <p:txBody>
-          <a:bodyPr wrap="square" lIns="0" tIns="0" rIns="0" bIns="0" rtlCol="0" anchor="ctr"/>
-          <a:lstStyle/>
-          <a:p>
-            <a:pPr algn="ctr" indent="0" marL="0">
-              <a:buNone/>
-            </a:pPr>
-            <a:r>
-              <a:rPr lang="en-US" sz="900" b="1" dirty="0">
-                <a:solidFill>
-                  <a:srgbClr val="2A2F39"/>
-                </a:solidFill>
-                <a:latin typeface="Calibri" pitchFamily="34" charset="0"/>
-                <a:ea typeface="Calibri" pitchFamily="34" charset="-122"/>
-                <a:cs typeface="Calibri" pitchFamily="34" charset="-120"/>
-              </a:rPr>
-              <a:t>6</a:t>
-            </a:r>
-            <a:endParaRPr lang="en-US" sz="900" dirty="0"/>
-          </a:p>
-        </p:txBody>
-      </p:sp>
-      <p:sp>
-        <p:nvSpPr>
-          <p:cNvPr id="25" name="Shape 23"/>
-          <p:cNvSpPr/>
-          <p:nvPr/>
-        </p:nvSpPr>
-        <p:spPr>
-          <a:xfrm>
-            <a:off x="6336792" y="2212848"/>
-            <a:ext cx="621792" cy="365760"/>
-          </a:xfrm>
-          <a:prstGeom prst="roundRect">
-            <a:avLst>
-              <a:gd name="adj" fmla="val 12500"/>
-            </a:avLst>
-          </a:prstGeom>
-          <a:solidFill>
-            <a:srgbClr val="E4E7DF"/>
-          </a:solidFill>
-          <a:ln w="13970">
-            <a:solidFill>
-              <a:srgbClr val="566270"/>
-            </a:solidFill>
-            <a:prstDash val="solid"/>
-          </a:ln>
-        </p:spPr>
-      </p:sp>
-      <p:sp>
-        <p:nvSpPr>
-          <p:cNvPr id="26" name="Shape 24"/>
-          <p:cNvSpPr/>
-          <p:nvPr/>
-        </p:nvSpPr>
-        <p:spPr>
-          <a:xfrm>
-            <a:off x="6025896" y="2251253"/>
-            <a:ext cx="310896" cy="64008"/>
-          </a:xfrm>
-          <a:prstGeom prst="rect">
-            <a:avLst/>
-          </a:prstGeom>
-          <a:solidFill>
-            <a:srgbClr val="566270"/>
-          </a:solidFill>
-          <a:ln/>
-        </p:spPr>
-      </p:sp>
-      <p:sp>
-        <p:nvSpPr>
-          <p:cNvPr id="27" name="Shape 25"/>
-          <p:cNvSpPr/>
-          <p:nvPr/>
-        </p:nvSpPr>
-        <p:spPr>
-          <a:xfrm>
-            <a:off x="6025896" y="2476195"/>
-            <a:ext cx="310896" cy="64008"/>
-          </a:xfrm>
-          <a:prstGeom prst="rect">
-            <a:avLst/>
-          </a:prstGeom>
-          <a:solidFill>
-            <a:srgbClr val="566270"/>
-          </a:solidFill>
-          <a:ln/>
-        </p:spPr>
-      </p:sp>
-      <p:sp>
-        <p:nvSpPr>
-          <p:cNvPr id="28" name="Text 26"/>
-          <p:cNvSpPr/>
-          <p:nvPr/>
-        </p:nvSpPr>
-        <p:spPr>
-          <a:xfrm>
-            <a:off x="6336792" y="2212848"/>
-            <a:ext cx="621792" cy="365760"/>
-          </a:xfrm>
-          <a:prstGeom prst="rect">
-            <a:avLst/>
-          </a:prstGeom>
-          <a:noFill/>
-          <a:ln/>
-        </p:spPr>
-        <p:txBody>
-          <a:bodyPr wrap="square" lIns="0" tIns="0" rIns="0" bIns="0" rtlCol="0" anchor="ctr"/>
-          <a:lstStyle/>
-          <a:p>
-            <a:pPr algn="ctr" indent="0" marL="0">
-              <a:buNone/>
-            </a:pPr>
-            <a:r>
-              <a:rPr lang="en-US" sz="900" b="1" dirty="0">
-                <a:solidFill>
-                  <a:srgbClr val="2A2F39"/>
-                </a:solidFill>
-                <a:latin typeface="Calibri" pitchFamily="34" charset="0"/>
-                <a:ea typeface="Calibri" pitchFamily="34" charset="-122"/>
-                <a:cs typeface="Calibri" pitchFamily="34" charset="-120"/>
-              </a:rPr>
-              <a:t>2</a:t>
-            </a:r>
-            <a:endParaRPr lang="en-US" sz="900" dirty="0"/>
-          </a:p>
-        </p:txBody>
-      </p:sp>
-      <p:sp>
-        <p:nvSpPr>
-          <p:cNvPr id="29" name="Shape 27"/>
-          <p:cNvSpPr/>
-          <p:nvPr/>
-        </p:nvSpPr>
-        <p:spPr>
-          <a:xfrm>
-            <a:off x="6336792" y="3108960"/>
-            <a:ext cx="658368" cy="365760"/>
-          </a:xfrm>
-          <a:prstGeom prst="roundRect">
-            <a:avLst>
-              <a:gd name="adj" fmla="val 12500"/>
-            </a:avLst>
-          </a:prstGeom>
-          <a:solidFill>
-            <a:srgbClr val="CDE9F7"/>
-          </a:solidFill>
-          <a:ln w="13970">
-            <a:solidFill>
-              <a:srgbClr val="566270"/>
-            </a:solidFill>
-            <a:prstDash val="solid"/>
-          </a:ln>
-        </p:spPr>
-      </p:sp>
-      <p:sp>
-        <p:nvSpPr>
-          <p:cNvPr id="30" name="Shape 28"/>
-          <p:cNvSpPr/>
-          <p:nvPr/>
-        </p:nvSpPr>
-        <p:spPr>
-          <a:xfrm>
-            <a:off x="6025896" y="3147365"/>
-            <a:ext cx="310896" cy="64008"/>
-          </a:xfrm>
-          <a:prstGeom prst="rect">
-            <a:avLst/>
-          </a:prstGeom>
-          <a:solidFill>
-            <a:srgbClr val="566270"/>
-          </a:solidFill>
-          <a:ln/>
-        </p:spPr>
-      </p:sp>
-      <p:sp>
-        <p:nvSpPr>
-          <p:cNvPr id="31" name="Shape 29"/>
-          <p:cNvSpPr/>
-          <p:nvPr/>
-        </p:nvSpPr>
-        <p:spPr>
-          <a:xfrm>
-            <a:off x="6025896" y="3372307"/>
-            <a:ext cx="310896" cy="64008"/>
-          </a:xfrm>
-          <a:prstGeom prst="rect">
-            <a:avLst/>
-          </a:prstGeom>
-          <a:solidFill>
-            <a:srgbClr val="566270"/>
-          </a:solidFill>
-          <a:ln/>
-        </p:spPr>
-      </p:sp>
-      <p:sp>
-        <p:nvSpPr>
-          <p:cNvPr id="32" name="Text 30"/>
-          <p:cNvSpPr/>
-          <p:nvPr/>
-        </p:nvSpPr>
-        <p:spPr>
-          <a:xfrm>
-            <a:off x="6336792" y="3108960"/>
-            <a:ext cx="658368" cy="365760"/>
-          </a:xfrm>
-          <a:prstGeom prst="rect">
-            <a:avLst/>
-          </a:prstGeom>
-          <a:noFill/>
-          <a:ln/>
-        </p:spPr>
-        <p:txBody>
-          <a:bodyPr wrap="square" lIns="0" tIns="0" rIns="0" bIns="0" rtlCol="0" anchor="ctr"/>
-          <a:lstStyle/>
-          <a:p>
-            <a:pPr algn="ctr" indent="0" marL="0">
-              <a:buNone/>
-            </a:pPr>
-            <a:r>
-              <a:rPr lang="en-US" sz="900" b="1" dirty="0">
-                <a:solidFill>
-                  <a:srgbClr val="2A2F39"/>
-                </a:solidFill>
-                <a:latin typeface="Calibri" pitchFamily="34" charset="0"/>
-                <a:ea typeface="Calibri" pitchFamily="34" charset="-122"/>
-                <a:cs typeface="Calibri" pitchFamily="34" charset="-120"/>
-              </a:rPr>
-              <a:t>1</a:t>
-            </a:r>
-            <a:endParaRPr lang="en-US" sz="900" dirty="0"/>
-          </a:p>
-        </p:txBody>
-      </p:sp>
-      <p:sp>
-        <p:nvSpPr>
-          <p:cNvPr id="33" name="Shape 31"/>
-          <p:cNvSpPr/>
-          <p:nvPr/>
-        </p:nvSpPr>
-        <p:spPr>
-          <a:xfrm>
-            <a:off x="4480560" y="3246120"/>
-            <a:ext cx="640080" cy="365760"/>
-          </a:xfrm>
-          <a:prstGeom prst="rect">
-            <a:avLst/>
-          </a:prstGeom>
-          <a:solidFill>
-            <a:srgbClr val="EDE6D7"/>
-          </a:solidFill>
-          <a:ln w="12700">
-            <a:solidFill>
-              <a:srgbClr val="B9BEC6"/>
-            </a:solidFill>
-            <a:prstDash val="solid"/>
-          </a:ln>
-        </p:spPr>
-      </p:sp>
-      <p:sp>
-        <p:nvSpPr>
-          <p:cNvPr id="34" name="Text 32"/>
-          <p:cNvSpPr/>
-          <p:nvPr/>
-        </p:nvSpPr>
-        <p:spPr>
-          <a:xfrm>
-            <a:off x="4480560" y="3246120"/>
-            <a:ext cx="640080" cy="365760"/>
-          </a:xfrm>
-          <a:prstGeom prst="rect">
-            <a:avLst/>
-          </a:prstGeom>
-          <a:noFill/>
-          <a:ln/>
-        </p:spPr>
-        <p:txBody>
-          <a:bodyPr wrap="square" lIns="0" tIns="0" rIns="0" bIns="0" rtlCol="0" anchor="ctr"/>
-          <a:lstStyle/>
-          <a:p>
-            <a:pPr algn="ctr" indent="0" marL="0">
-              <a:buNone/>
-            </a:pPr>
-            <a:r>
-              <a:rPr lang="en-US" sz="900" b="1" dirty="0">
-                <a:solidFill>
-                  <a:srgbClr val="3A3F49"/>
-                </a:solidFill>
-                <a:latin typeface="Calibri" pitchFamily="34" charset="0"/>
-                <a:ea typeface="Calibri" pitchFamily="34" charset="-122"/>
-                <a:cs typeface="Calibri" pitchFamily="34" charset="-120"/>
-              </a:rPr>
-              <a:t>7</a:t>
-            </a:r>
-            <a:endParaRPr lang="en-US" sz="900" dirty="0"/>
-          </a:p>
-        </p:txBody>
-      </p:sp>
-      <p:sp>
-        <p:nvSpPr>
-          <p:cNvPr id="35" name="Shape 33"/>
-          <p:cNvSpPr/>
-          <p:nvPr/>
-        </p:nvSpPr>
-        <p:spPr>
-          <a:xfrm>
-            <a:off x="5349240" y="3246120"/>
-            <a:ext cx="640080" cy="365760"/>
-          </a:xfrm>
-          <a:prstGeom prst="rect">
-            <a:avLst/>
-          </a:prstGeom>
-          <a:solidFill>
-            <a:srgbClr val="EDE6D7"/>
-          </a:solidFill>
-          <a:ln w="12700">
-            <a:solidFill>
-              <a:srgbClr val="B9BEC6"/>
-            </a:solidFill>
-            <a:prstDash val="solid"/>
-          </a:ln>
-        </p:spPr>
-      </p:sp>
-      <p:sp>
-        <p:nvSpPr>
-          <p:cNvPr id="36" name="Text 34"/>
-          <p:cNvSpPr/>
-          <p:nvPr/>
-        </p:nvSpPr>
-        <p:spPr>
-          <a:xfrm>
-            <a:off x="5349240" y="3246120"/>
-            <a:ext cx="640080" cy="365760"/>
-          </a:xfrm>
-          <a:prstGeom prst="rect">
-            <a:avLst/>
-          </a:prstGeom>
-          <a:noFill/>
-          <a:ln/>
-        </p:spPr>
-        <p:txBody>
-          <a:bodyPr wrap="square" lIns="0" tIns="0" rIns="0" bIns="0" rtlCol="0" anchor="ctr"/>
-          <a:lstStyle/>
-          <a:p>
-            <a:pPr algn="ctr" indent="0" marL="0">
-              <a:buNone/>
-            </a:pPr>
-            <a:r>
-              <a:rPr lang="en-US" sz="900" b="1" dirty="0">
-                <a:solidFill>
-                  <a:srgbClr val="3A3F49"/>
-                </a:solidFill>
-                <a:latin typeface="Calibri" pitchFamily="34" charset="0"/>
-                <a:ea typeface="Calibri" pitchFamily="34" charset="-122"/>
-                <a:cs typeface="Calibri" pitchFamily="34" charset="-120"/>
-              </a:rPr>
-              <a:t>8</a:t>
-            </a:r>
-            <a:endParaRPr lang="en-US" sz="900" dirty="0"/>
-          </a:p>
-        </p:txBody>
-      </p:sp>
-      <p:sp>
-        <p:nvSpPr>
-          <p:cNvPr id="37" name="Shape 35"/>
-          <p:cNvSpPr/>
-          <p:nvPr/>
-        </p:nvSpPr>
-        <p:spPr>
-          <a:xfrm>
-            <a:off x="6611112" y="3749040"/>
-            <a:ext cx="438912" cy="1143000"/>
-          </a:xfrm>
-          <a:prstGeom prst="rect">
-            <a:avLst/>
-          </a:prstGeom>
-          <a:solidFill>
-            <a:srgbClr val="DCE0E6"/>
-          </a:solidFill>
-          <a:ln w="16510">
-            <a:solidFill>
-              <a:srgbClr val="8A93A0"/>
-            </a:solidFill>
-            <a:prstDash val="solid"/>
-          </a:ln>
-        </p:spPr>
-      </p:sp>
-      <p:sp>
-        <p:nvSpPr>
-          <p:cNvPr id="38" name="Shape 36"/>
-          <p:cNvSpPr/>
-          <p:nvPr/>
-        </p:nvSpPr>
-        <p:spPr>
-          <a:xfrm>
-            <a:off x="6611112" y="3939540"/>
-            <a:ext cx="438912" cy="0"/>
-          </a:xfrm>
-          <a:prstGeom prst="line">
-            <a:avLst/>
-          </a:prstGeom>
-          <a:noFill/>
-          <a:ln w="10160">
-            <a:solidFill>
-              <a:srgbClr val="9AA3B0"/>
-            </a:solidFill>
-            <a:prstDash val="solid"/>
-          </a:ln>
-        </p:spPr>
-      </p:sp>
-      <p:sp>
-        <p:nvSpPr>
-          <p:cNvPr id="39" name="Shape 37"/>
-          <p:cNvSpPr/>
-          <p:nvPr/>
-        </p:nvSpPr>
-        <p:spPr>
-          <a:xfrm>
-            <a:off x="6611112" y="4130040"/>
-            <a:ext cx="438912" cy="0"/>
-          </a:xfrm>
-          <a:prstGeom prst="line">
-            <a:avLst/>
-          </a:prstGeom>
-          <a:noFill/>
-          <a:ln w="10160">
-            <a:solidFill>
-              <a:srgbClr val="9AA3B0"/>
-            </a:solidFill>
-            <a:prstDash val="solid"/>
-          </a:ln>
-        </p:spPr>
-      </p:sp>
-      <p:sp>
-        <p:nvSpPr>
-          <p:cNvPr id="40" name="Shape 38"/>
-          <p:cNvSpPr/>
-          <p:nvPr/>
-        </p:nvSpPr>
-        <p:spPr>
-          <a:xfrm>
-            <a:off x="6611112" y="4320540"/>
-            <a:ext cx="438912" cy="0"/>
-          </a:xfrm>
-          <a:prstGeom prst="line">
-            <a:avLst/>
-          </a:prstGeom>
-          <a:noFill/>
-          <a:ln w="10160">
-            <a:solidFill>
-              <a:srgbClr val="9AA3B0"/>
-            </a:solidFill>
-            <a:prstDash val="solid"/>
-          </a:ln>
-        </p:spPr>
-      </p:sp>
-      <p:sp>
-        <p:nvSpPr>
-          <p:cNvPr id="41" name="Shape 39"/>
-          <p:cNvSpPr/>
-          <p:nvPr/>
-        </p:nvSpPr>
-        <p:spPr>
-          <a:xfrm>
-            <a:off x="6611112" y="4511040"/>
-            <a:ext cx="438912" cy="0"/>
-          </a:xfrm>
-          <a:prstGeom prst="line">
-            <a:avLst/>
-          </a:prstGeom>
-          <a:noFill/>
-          <a:ln w="10160">
-            <a:solidFill>
-              <a:srgbClr val="9AA3B0"/>
-            </a:solidFill>
-            <a:prstDash val="solid"/>
-          </a:ln>
-        </p:spPr>
-      </p:sp>
-      <p:sp>
-        <p:nvSpPr>
-          <p:cNvPr id="42" name="Shape 40"/>
-          <p:cNvSpPr/>
-          <p:nvPr/>
-        </p:nvSpPr>
-        <p:spPr>
-          <a:xfrm>
-            <a:off x="6611112" y="4701540"/>
-            <a:ext cx="438912" cy="0"/>
-          </a:xfrm>
-          <a:prstGeom prst="line">
-            <a:avLst/>
-          </a:prstGeom>
-          <a:noFill/>
-          <a:ln w="10160">
-            <a:solidFill>
-              <a:srgbClr val="9AA3B0"/>
-            </a:solidFill>
-            <a:prstDash val="solid"/>
-          </a:ln>
-        </p:spPr>
-      </p:sp>
-      <p:sp>
-        <p:nvSpPr>
-          <p:cNvPr id="43" name="Shape 41"/>
-          <p:cNvSpPr/>
-          <p:nvPr/>
-        </p:nvSpPr>
-        <p:spPr>
-          <a:xfrm>
-            <a:off x="6675120" y="3803904"/>
-            <a:ext cx="310896" cy="80772"/>
-          </a:xfrm>
-          <a:prstGeom prst="rect">
-            <a:avLst/>
-          </a:prstGeom>
-          <a:solidFill>
-            <a:srgbClr val="CFC2A0"/>
-          </a:solidFill>
-          <a:ln w="5080">
-            <a:solidFill>
-              <a:srgbClr val="AC9E78"/>
-            </a:solidFill>
-            <a:prstDash val="solid"/>
-          </a:ln>
-        </p:spPr>
-      </p:sp>
-      <p:sp>
-        <p:nvSpPr>
-          <p:cNvPr id="44" name="Shape 42"/>
-          <p:cNvSpPr/>
-          <p:nvPr/>
-        </p:nvSpPr>
-        <p:spPr>
-          <a:xfrm>
-            <a:off x="6675120" y="4184904"/>
-            <a:ext cx="310896" cy="80772"/>
-          </a:xfrm>
-          <a:prstGeom prst="rect">
-            <a:avLst/>
-          </a:prstGeom>
-          <a:solidFill>
-            <a:srgbClr val="CFC2A0"/>
-          </a:solidFill>
-          <a:ln w="5080">
-            <a:solidFill>
-              <a:srgbClr val="AC9E78"/>
-            </a:solidFill>
-            <a:prstDash val="solid"/>
-          </a:ln>
-        </p:spPr>
-      </p:sp>
-      <p:sp>
-        <p:nvSpPr>
-          <p:cNvPr id="45" name="Shape 43"/>
-          <p:cNvSpPr/>
-          <p:nvPr/>
-        </p:nvSpPr>
-        <p:spPr>
-          <a:xfrm>
-            <a:off x="6675120" y="4565904"/>
-            <a:ext cx="310896" cy="80772"/>
-          </a:xfrm>
-          <a:prstGeom prst="rect">
-            <a:avLst/>
-          </a:prstGeom>
-          <a:solidFill>
-            <a:srgbClr val="CFC2A0"/>
-          </a:solidFill>
-          <a:ln w="5080">
-            <a:solidFill>
-              <a:srgbClr val="AC9E78"/>
-            </a:solidFill>
-            <a:prstDash val="solid"/>
-          </a:ln>
-        </p:spPr>
-      </p:sp>
-      <p:sp>
-        <p:nvSpPr>
-          <p:cNvPr id="46" name="Shape 44"/>
-          <p:cNvSpPr/>
-          <p:nvPr/>
-        </p:nvSpPr>
-        <p:spPr>
-          <a:xfrm>
-            <a:off x="6446520" y="3511296"/>
-            <a:ext cx="768096" cy="237744"/>
-          </a:xfrm>
-          <a:prstGeom prst="roundRect">
-            <a:avLst>
-              <a:gd name="adj" fmla="val 15385"/>
-            </a:avLst>
-          </a:prstGeom>
-          <a:solidFill>
-            <a:srgbClr val="566270"/>
-          </a:solidFill>
-          <a:ln/>
-        </p:spPr>
-      </p:sp>
-      <p:sp>
-        <p:nvSpPr>
-          <p:cNvPr id="47" name="Text 45"/>
-          <p:cNvSpPr/>
-          <p:nvPr/>
-        </p:nvSpPr>
-        <p:spPr>
-          <a:xfrm>
-            <a:off x="6446520" y="3511296"/>
-            <a:ext cx="768096" cy="237744"/>
-          </a:xfrm>
-          <a:prstGeom prst="rect">
-            <a:avLst/>
-          </a:prstGeom>
-          <a:noFill/>
-          <a:ln/>
-        </p:spPr>
-        <p:txBody>
-          <a:bodyPr wrap="square" lIns="0" tIns="0" rIns="0" bIns="0" rtlCol="0" anchor="ctr"/>
-          <a:lstStyle/>
-          <a:p>
-            <a:pPr algn="ctr" indent="0" marL="0">
-              <a:buNone/>
-            </a:pPr>
-            <a:r>
-              <a:rPr lang="en-US" sz="950" b="1" dirty="0">
-                <a:solidFill>
-                  <a:srgbClr val="FFFFFF"/>
-                </a:solidFill>
-                <a:latin typeface="Calibri" pitchFamily="34" charset="0"/>
-                <a:ea typeface="Calibri" pitchFamily="34" charset="-122"/>
-                <a:cs typeface="Calibri" pitchFamily="34" charset="-120"/>
-              </a:rPr>
-              <a:t>3</a:t>
-            </a:r>
-            <a:endParaRPr lang="en-US" sz="950" dirty="0"/>
-          </a:p>
-        </p:txBody>
-      </p:sp>
-      <p:sp>
-        <p:nvSpPr>
-          <p:cNvPr id="48" name="Shape 46"/>
-          <p:cNvSpPr/>
-          <p:nvPr/>
-        </p:nvSpPr>
-        <p:spPr>
-          <a:xfrm>
-            <a:off x="4617720" y="4206240"/>
-            <a:ext cx="475488" cy="777240"/>
-          </a:xfrm>
-          <a:prstGeom prst="rect">
-            <a:avLst/>
-          </a:prstGeom>
-          <a:solidFill>
-            <a:srgbClr val="DCE0E6"/>
-          </a:solidFill>
-          <a:ln w="16510">
-            <a:solidFill>
-              <a:srgbClr val="8A93A0"/>
-            </a:solidFill>
-            <a:prstDash val="solid"/>
-          </a:ln>
-        </p:spPr>
-      </p:sp>
-      <p:sp>
-        <p:nvSpPr>
-          <p:cNvPr id="49" name="Shape 47"/>
-          <p:cNvSpPr/>
-          <p:nvPr/>
-        </p:nvSpPr>
-        <p:spPr>
-          <a:xfrm>
-            <a:off x="4617720" y="4335780"/>
-            <a:ext cx="475488" cy="0"/>
-          </a:xfrm>
-          <a:prstGeom prst="line">
-            <a:avLst/>
-          </a:prstGeom>
-          <a:noFill/>
-          <a:ln w="10160">
-            <a:solidFill>
-              <a:srgbClr val="9AA3B0"/>
-            </a:solidFill>
-            <a:prstDash val="solid"/>
-          </a:ln>
-        </p:spPr>
-      </p:sp>
-      <p:sp>
-        <p:nvSpPr>
-          <p:cNvPr id="50" name="Shape 48"/>
-          <p:cNvSpPr/>
-          <p:nvPr/>
-        </p:nvSpPr>
-        <p:spPr>
-          <a:xfrm>
-            <a:off x="4617720" y="4465320"/>
-            <a:ext cx="475488" cy="0"/>
-          </a:xfrm>
-          <a:prstGeom prst="line">
-            <a:avLst/>
-          </a:prstGeom>
-          <a:noFill/>
-          <a:ln w="10160">
-            <a:solidFill>
-              <a:srgbClr val="9AA3B0"/>
-            </a:solidFill>
-            <a:prstDash val="solid"/>
-          </a:ln>
-        </p:spPr>
-      </p:sp>
-      <p:sp>
-        <p:nvSpPr>
-          <p:cNvPr id="51" name="Shape 49"/>
-          <p:cNvSpPr/>
-          <p:nvPr/>
-        </p:nvSpPr>
-        <p:spPr>
-          <a:xfrm>
-            <a:off x="4617720" y="4594860"/>
-            <a:ext cx="475488" cy="0"/>
-          </a:xfrm>
-          <a:prstGeom prst="line">
-            <a:avLst/>
-          </a:prstGeom>
-          <a:noFill/>
-          <a:ln w="10160">
-            <a:solidFill>
-              <a:srgbClr val="9AA3B0"/>
-            </a:solidFill>
-            <a:prstDash val="solid"/>
-          </a:ln>
-        </p:spPr>
-      </p:sp>
-      <p:sp>
-        <p:nvSpPr>
-          <p:cNvPr id="52" name="Shape 50"/>
-          <p:cNvSpPr/>
-          <p:nvPr/>
-        </p:nvSpPr>
-        <p:spPr>
-          <a:xfrm>
-            <a:off x="4617720" y="4724400"/>
-            <a:ext cx="475488" cy="0"/>
-          </a:xfrm>
-          <a:prstGeom prst="line">
-            <a:avLst/>
-          </a:prstGeom>
-          <a:noFill/>
-          <a:ln w="10160">
-            <a:solidFill>
-              <a:srgbClr val="9AA3B0"/>
-            </a:solidFill>
-            <a:prstDash val="solid"/>
-          </a:ln>
-        </p:spPr>
-      </p:sp>
-      <p:sp>
-        <p:nvSpPr>
-          <p:cNvPr id="53" name="Shape 51"/>
-          <p:cNvSpPr/>
-          <p:nvPr/>
-        </p:nvSpPr>
-        <p:spPr>
-          <a:xfrm>
-            <a:off x="4617720" y="4853940"/>
-            <a:ext cx="475488" cy="0"/>
-          </a:xfrm>
-          <a:prstGeom prst="line">
-            <a:avLst/>
-          </a:prstGeom>
-          <a:noFill/>
-          <a:ln w="10160">
-            <a:solidFill>
-              <a:srgbClr val="9AA3B0"/>
-            </a:solidFill>
-            <a:prstDash val="solid"/>
-          </a:ln>
-        </p:spPr>
-      </p:sp>
-      <p:sp>
-        <p:nvSpPr>
-          <p:cNvPr id="54" name="Shape 52"/>
-          <p:cNvSpPr/>
-          <p:nvPr/>
-        </p:nvSpPr>
-        <p:spPr>
-          <a:xfrm>
-            <a:off x="4681728" y="4261104"/>
-            <a:ext cx="347472" cy="19812"/>
-          </a:xfrm>
-          <a:prstGeom prst="rect">
-            <a:avLst/>
-          </a:prstGeom>
-          <a:solidFill>
-            <a:srgbClr val="CFC2A0"/>
-          </a:solidFill>
-          <a:ln w="5080">
-            <a:solidFill>
-              <a:srgbClr val="AC9E78"/>
-            </a:solidFill>
-            <a:prstDash val="solid"/>
-          </a:ln>
-        </p:spPr>
-      </p:sp>
-      <p:sp>
-        <p:nvSpPr>
-          <p:cNvPr id="55" name="Shape 53"/>
-          <p:cNvSpPr/>
-          <p:nvPr/>
-        </p:nvSpPr>
-        <p:spPr>
-          <a:xfrm>
-            <a:off x="4681728" y="4520184"/>
-            <a:ext cx="347472" cy="19812"/>
-          </a:xfrm>
-          <a:prstGeom prst="rect">
-            <a:avLst/>
-          </a:prstGeom>
-          <a:solidFill>
-            <a:srgbClr val="CFC2A0"/>
-          </a:solidFill>
-          <a:ln w="5080">
-            <a:solidFill>
-              <a:srgbClr val="AC9E78"/>
-            </a:solidFill>
-            <a:prstDash val="solid"/>
-          </a:ln>
-        </p:spPr>
-      </p:sp>
-      <p:sp>
-        <p:nvSpPr>
-          <p:cNvPr id="56" name="Shape 54"/>
-          <p:cNvSpPr/>
-          <p:nvPr/>
-        </p:nvSpPr>
-        <p:spPr>
-          <a:xfrm>
-            <a:off x="4681728" y="4779264"/>
-            <a:ext cx="347472" cy="19812"/>
-          </a:xfrm>
-          <a:prstGeom prst="rect">
-            <a:avLst/>
-          </a:prstGeom>
-          <a:solidFill>
-            <a:srgbClr val="CFC2A0"/>
-          </a:solidFill>
-          <a:ln w="5080">
-            <a:solidFill>
-              <a:srgbClr val="AC9E78"/>
-            </a:solidFill>
-            <a:prstDash val="solid"/>
-          </a:ln>
-        </p:spPr>
-      </p:sp>
-      <p:sp>
-        <p:nvSpPr>
-          <p:cNvPr id="57" name="Shape 55"/>
-          <p:cNvSpPr/>
-          <p:nvPr/>
-        </p:nvSpPr>
-        <p:spPr>
-          <a:xfrm>
-            <a:off x="4471416" y="3968496"/>
-            <a:ext cx="768096" cy="237744"/>
-          </a:xfrm>
-          <a:prstGeom prst="roundRect">
-            <a:avLst>
-              <a:gd name="adj" fmla="val 15385"/>
-            </a:avLst>
-          </a:prstGeom>
-          <a:solidFill>
-            <a:srgbClr val="566270"/>
-          </a:solidFill>
-          <a:ln/>
-        </p:spPr>
-      </p:sp>
-      <p:sp>
-        <p:nvSpPr>
-          <p:cNvPr id="58" name="Text 56"/>
-          <p:cNvSpPr/>
-          <p:nvPr/>
-        </p:nvSpPr>
-        <p:spPr>
-          <a:xfrm>
-            <a:off x="4471416" y="3968496"/>
-            <a:ext cx="768096" cy="237744"/>
-          </a:xfrm>
-          <a:prstGeom prst="rect">
-            <a:avLst/>
-          </a:prstGeom>
-          <a:noFill/>
-          <a:ln/>
-        </p:spPr>
-        <p:txBody>
-          <a:bodyPr wrap="square" lIns="0" tIns="0" rIns="0" bIns="0" rtlCol="0" anchor="ctr"/>
-          <a:lstStyle/>
-          <a:p>
-            <a:pPr algn="ctr" indent="0" marL="0">
-              <a:buNone/>
-            </a:pPr>
-            <a:r>
-              <a:rPr lang="en-US" sz="950" b="1" dirty="0">
-                <a:solidFill>
-                  <a:srgbClr val="FFFFFF"/>
-                </a:solidFill>
-                <a:latin typeface="Calibri" pitchFamily="34" charset="0"/>
-                <a:ea typeface="Calibri" pitchFamily="34" charset="-122"/>
-                <a:cs typeface="Calibri" pitchFamily="34" charset="-120"/>
-              </a:rPr>
-              <a:t>4</a:t>
-            </a:r>
-            <a:endParaRPr lang="en-US" sz="950" dirty="0"/>
-          </a:p>
-        </p:txBody>
-      </p:sp>
-      <p:sp>
-        <p:nvSpPr>
-          <p:cNvPr id="59" name="Shape 57"/>
-          <p:cNvSpPr/>
-          <p:nvPr/>
-        </p:nvSpPr>
-        <p:spPr>
-          <a:xfrm>
-            <a:off x="4361688" y="3977640"/>
-            <a:ext cx="1234440" cy="1024128"/>
-          </a:xfrm>
-          <a:prstGeom prst="roundRect">
-            <a:avLst>
-              <a:gd name="adj" fmla="val 5357"/>
-            </a:avLst>
-          </a:prstGeom>
-          <a:solidFill>
-            <a:srgbClr val="FFFFFF">
-              <a:alpha val="0"/>
-            </a:srgbClr>
-          </a:solidFill>
-          <a:ln w="20320">
-            <a:solidFill>
-              <a:srgbClr val="FF5A52"/>
-            </a:solidFill>
-            <a:prstDash val="dash"/>
-          </a:ln>
-        </p:spPr>
-      </p:sp>
-      <p:sp>
-        <p:nvSpPr>
-          <p:cNvPr id="60" name="Text 58"/>
-          <p:cNvSpPr/>
-          <p:nvPr/>
-        </p:nvSpPr>
-        <p:spPr>
-          <a:xfrm>
-            <a:off x="4206240" y="3639312"/>
-            <a:ext cx="1554480" cy="365760"/>
-          </a:xfrm>
-          <a:prstGeom prst="rect">
-            <a:avLst/>
-          </a:prstGeom>
-          <a:noFill/>
-          <a:ln/>
-        </p:spPr>
-        <p:txBody>
-          <a:bodyPr wrap="square" lIns="0" tIns="0" rIns="0" bIns="0" rtlCol="0" anchor="ctr"/>
-          <a:lstStyle/>
-          <a:p>
-            <a:pPr algn="ctr" indent="0" marL="0">
-              <a:buNone/>
-            </a:pPr>
-            <a:r>
-              <a:rPr lang="en-US" sz="800" b="1" dirty="0">
-                <a:solidFill>
-                  <a:srgbClr val="FF5A52"/>
-                </a:solidFill>
-                <a:latin typeface="Calibri" pitchFamily="34" charset="0"/>
-                <a:ea typeface="Calibri" pitchFamily="34" charset="-122"/>
-                <a:cs typeface="Calibri" pitchFamily="34" charset="-120"/>
-              </a:rPr>
-              <a:t>rack 4 — ocupa área que</a:t>
-            </a:r>
-            <a:endParaRPr lang="en-US" sz="800" dirty="0"/>
-          </a:p>
-          <a:p>
-            <a:pPr algn="ctr" indent="0" marL="0">
-              <a:buNone/>
-            </a:pPr>
-            <a:r>
-              <a:rPr lang="en-US" sz="800" b="1" dirty="0">
-                <a:solidFill>
-                  <a:srgbClr val="FF5A52"/>
-                </a:solidFill>
-                <a:latin typeface="Calibri" pitchFamily="34" charset="0"/>
-                <a:ea typeface="Calibri" pitchFamily="34" charset="-122"/>
-                <a:cs typeface="Calibri" pitchFamily="34" charset="-120"/>
-              </a:rPr>
-              <a:t>usan los mecánicos</a:t>
-            </a:r>
-            <a:endParaRPr lang="en-US" sz="800" dirty="0"/>
-          </a:p>
-        </p:txBody>
-      </p:sp>
-      <p:sp>
-        <p:nvSpPr>
-          <p:cNvPr id="61" name="Text 59"/>
-          <p:cNvSpPr/>
-          <p:nvPr/>
-        </p:nvSpPr>
-        <p:spPr>
-          <a:xfrm>
-            <a:off x="7452360" y="1554480"/>
-            <a:ext cx="4114800" cy="274320"/>
-          </a:xfrm>
-          <a:prstGeom prst="rect">
-            <a:avLst/>
-          </a:prstGeom>
-          <a:noFill/>
-          <a:ln/>
-        </p:spPr>
-        <p:txBody>
-          <a:bodyPr wrap="square" lIns="0" tIns="0" rIns="0" bIns="0" rtlCol="0" anchor="ctr"/>
-          <a:lstStyle/>
-          <a:p>
-            <a:pPr indent="0" marL="0">
-              <a:buNone/>
-            </a:pPr>
-            <a:r>
-              <a:rPr lang="en-US" sz="1250" b="1" dirty="0">
-                <a:solidFill>
-                  <a:srgbClr val="1A1D23"/>
-                </a:solidFill>
-                <a:latin typeface="Calibri" pitchFamily="34" charset="0"/>
-                <a:ea typeface="Calibri" pitchFamily="34" charset="-122"/>
-                <a:cs typeface="Calibri" pitchFamily="34" charset="-120"/>
-              </a:rPr>
-              <a:t>Propuesta — lado derecho</a:t>
-            </a:r>
-            <a:endParaRPr lang="en-US" sz="1250" dirty="0"/>
-          </a:p>
-        </p:txBody>
-      </p:sp>
-      <p:sp>
-        <p:nvSpPr>
-          <p:cNvPr id="62" name="Shape 60"/>
-          <p:cNvSpPr/>
-          <p:nvPr/>
-        </p:nvSpPr>
-        <p:spPr>
-          <a:xfrm>
-            <a:off x="7452360" y="1828800"/>
-            <a:ext cx="4114800" cy="3246120"/>
-          </a:xfrm>
-          <a:prstGeom prst="rect">
-            <a:avLst/>
-          </a:prstGeom>
-          <a:solidFill>
-            <a:srgbClr val="FFFFFF"/>
-          </a:solidFill>
-          <a:ln w="30480">
-            <a:solidFill>
-              <a:srgbClr val="3A3F49"/>
-            </a:solidFill>
-            <a:prstDash val="solid"/>
-          </a:ln>
-        </p:spPr>
-      </p:sp>
-      <p:sp>
-        <p:nvSpPr>
-          <p:cNvPr id="63" name="Shape 61"/>
-          <p:cNvSpPr/>
-          <p:nvPr/>
-        </p:nvSpPr>
-        <p:spPr>
-          <a:xfrm>
-            <a:off x="8842248" y="2560320"/>
-            <a:ext cx="1280160" cy="1828800"/>
-          </a:xfrm>
-          <a:prstGeom prst="rect">
-            <a:avLst/>
-          </a:prstGeom>
-          <a:solidFill>
-            <a:srgbClr val="FBEFC9"/>
-          </a:solidFill>
-          <a:ln w="12700">
-            <a:solidFill>
-              <a:srgbClr val="E0C96A"/>
-            </a:solidFill>
-            <a:prstDash val="solid"/>
-          </a:ln>
-        </p:spPr>
-      </p:sp>
-      <p:sp>
-        <p:nvSpPr>
-          <p:cNvPr id="64" name="Text 62"/>
-          <p:cNvSpPr/>
-          <p:nvPr/>
-        </p:nvSpPr>
-        <p:spPr>
-          <a:xfrm>
-            <a:off x="8842248" y="3337560"/>
-            <a:ext cx="1280160" cy="274320"/>
-          </a:xfrm>
-          <a:prstGeom prst="rect">
-            <a:avLst/>
-          </a:prstGeom>
-          <a:noFill/>
-          <a:ln/>
-        </p:spPr>
-        <p:txBody>
-          <a:bodyPr wrap="square" lIns="0" tIns="0" rIns="0" bIns="0" rtlCol="0" anchor="ctr"/>
-          <a:lstStyle/>
-          <a:p>
-            <a:pPr algn="ctr" indent="0" marL="0">
-              <a:buNone/>
-            </a:pPr>
-            <a:r>
-              <a:rPr lang="en-US" sz="1000" b="1" dirty="0">
-                <a:solidFill>
-                  <a:srgbClr val="8A6D16"/>
-                </a:solidFill>
-                <a:latin typeface="Calibri" pitchFamily="34" charset="0"/>
-                <a:ea typeface="Calibri" pitchFamily="34" charset="-122"/>
-                <a:cs typeface="Calibri" pitchFamily="34" charset="-120"/>
-              </a:rPr>
-              <a:t>Pasillo 0</a:t>
-            </a:r>
-            <a:endParaRPr lang="en-US" sz="1000" dirty="0"/>
-          </a:p>
-        </p:txBody>
-      </p:sp>
-      <p:sp>
-        <p:nvSpPr>
-          <p:cNvPr id="65" name="Shape 63"/>
-          <p:cNvSpPr/>
-          <p:nvPr/>
-        </p:nvSpPr>
-        <p:spPr>
-          <a:xfrm>
-            <a:off x="8257032" y="2560320"/>
-            <a:ext cx="530352" cy="1828800"/>
-          </a:xfrm>
-          <a:prstGeom prst="rect">
-            <a:avLst/>
-          </a:prstGeom>
-          <a:solidFill>
-            <a:srgbClr val="DCE0E6"/>
-          </a:solidFill>
-          <a:ln w="16510">
-            <a:solidFill>
-              <a:srgbClr val="8A93A0"/>
-            </a:solidFill>
-            <a:prstDash val="solid"/>
-          </a:ln>
-        </p:spPr>
-      </p:sp>
-      <p:sp>
-        <p:nvSpPr>
-          <p:cNvPr id="66" name="Shape 64"/>
-          <p:cNvSpPr/>
-          <p:nvPr/>
-        </p:nvSpPr>
-        <p:spPr>
-          <a:xfrm>
-            <a:off x="8257032" y="2865120"/>
-            <a:ext cx="530352" cy="0"/>
-          </a:xfrm>
-          <a:prstGeom prst="line">
-            <a:avLst/>
-          </a:prstGeom>
-          <a:noFill/>
-          <a:ln w="10160">
-            <a:solidFill>
-              <a:srgbClr val="9AA3B0"/>
-            </a:solidFill>
-            <a:prstDash val="solid"/>
-          </a:ln>
-        </p:spPr>
-      </p:sp>
-      <p:sp>
-        <p:nvSpPr>
-          <p:cNvPr id="67" name="Shape 65"/>
-          <p:cNvSpPr/>
-          <p:nvPr/>
-        </p:nvSpPr>
-        <p:spPr>
-          <a:xfrm>
-            <a:off x="8257032" y="3169920"/>
-            <a:ext cx="530352" cy="0"/>
-          </a:xfrm>
-          <a:prstGeom prst="line">
-            <a:avLst/>
-          </a:prstGeom>
-          <a:noFill/>
-          <a:ln w="10160">
-            <a:solidFill>
-              <a:srgbClr val="9AA3B0"/>
-            </a:solidFill>
-            <a:prstDash val="solid"/>
-          </a:ln>
-        </p:spPr>
-      </p:sp>
-      <p:sp>
-        <p:nvSpPr>
-          <p:cNvPr id="68" name="Shape 66"/>
-          <p:cNvSpPr/>
-          <p:nvPr/>
-        </p:nvSpPr>
-        <p:spPr>
-          <a:xfrm>
-            <a:off x="8257032" y="3474720"/>
-            <a:ext cx="530352" cy="0"/>
-          </a:xfrm>
-          <a:prstGeom prst="line">
-            <a:avLst/>
-          </a:prstGeom>
-          <a:noFill/>
-          <a:ln w="10160">
-            <a:solidFill>
-              <a:srgbClr val="9AA3B0"/>
-            </a:solidFill>
-            <a:prstDash val="solid"/>
-          </a:ln>
-        </p:spPr>
-      </p:sp>
-      <p:sp>
-        <p:nvSpPr>
-          <p:cNvPr id="69" name="Shape 67"/>
-          <p:cNvSpPr/>
-          <p:nvPr/>
-        </p:nvSpPr>
-        <p:spPr>
-          <a:xfrm>
-            <a:off x="8257032" y="3779520"/>
-            <a:ext cx="530352" cy="0"/>
-          </a:xfrm>
-          <a:prstGeom prst="line">
-            <a:avLst/>
-          </a:prstGeom>
-          <a:noFill/>
-          <a:ln w="10160">
-            <a:solidFill>
-              <a:srgbClr val="9AA3B0"/>
-            </a:solidFill>
-            <a:prstDash val="solid"/>
-          </a:ln>
-        </p:spPr>
-      </p:sp>
-      <p:sp>
-        <p:nvSpPr>
-          <p:cNvPr id="70" name="Shape 68"/>
-          <p:cNvSpPr/>
-          <p:nvPr/>
-        </p:nvSpPr>
-        <p:spPr>
-          <a:xfrm>
-            <a:off x="8257032" y="4084320"/>
-            <a:ext cx="530352" cy="0"/>
-          </a:xfrm>
-          <a:prstGeom prst="line">
-            <a:avLst/>
-          </a:prstGeom>
-          <a:noFill/>
-          <a:ln w="10160">
-            <a:solidFill>
-              <a:srgbClr val="9AA3B0"/>
-            </a:solidFill>
-            <a:prstDash val="solid"/>
-          </a:ln>
-        </p:spPr>
-      </p:sp>
-      <p:sp>
-        <p:nvSpPr>
-          <p:cNvPr id="71" name="Shape 69"/>
-          <p:cNvSpPr/>
-          <p:nvPr/>
-        </p:nvSpPr>
-        <p:spPr>
-          <a:xfrm>
-            <a:off x="8321040" y="2615184"/>
-            <a:ext cx="402336" cy="195072"/>
-          </a:xfrm>
-          <a:prstGeom prst="rect">
-            <a:avLst/>
-          </a:prstGeom>
-          <a:solidFill>
-            <a:srgbClr val="CFC2A0"/>
-          </a:solidFill>
-          <a:ln w="5080">
-            <a:solidFill>
-              <a:srgbClr val="AC9E78"/>
-            </a:solidFill>
-            <a:prstDash val="solid"/>
-          </a:ln>
-        </p:spPr>
-      </p:sp>
-      <p:sp>
-        <p:nvSpPr>
-          <p:cNvPr id="72" name="Shape 70"/>
-          <p:cNvSpPr/>
-          <p:nvPr/>
-        </p:nvSpPr>
-        <p:spPr>
-          <a:xfrm>
-            <a:off x="8321040" y="3224784"/>
-            <a:ext cx="402336" cy="195072"/>
-          </a:xfrm>
-          <a:prstGeom prst="rect">
-            <a:avLst/>
-          </a:prstGeom>
-          <a:solidFill>
-            <a:srgbClr val="CFC2A0"/>
-          </a:solidFill>
-          <a:ln w="5080">
-            <a:solidFill>
-              <a:srgbClr val="AC9E78"/>
-            </a:solidFill>
-            <a:prstDash val="solid"/>
-          </a:ln>
-        </p:spPr>
-      </p:sp>
-      <p:sp>
-        <p:nvSpPr>
-          <p:cNvPr id="73" name="Shape 71"/>
-          <p:cNvSpPr/>
-          <p:nvPr/>
-        </p:nvSpPr>
-        <p:spPr>
-          <a:xfrm>
-            <a:off x="8321040" y="3834384"/>
-            <a:ext cx="402336" cy="195072"/>
-          </a:xfrm>
-          <a:prstGeom prst="rect">
-            <a:avLst/>
-          </a:prstGeom>
-          <a:solidFill>
-            <a:srgbClr val="CFC2A0"/>
-          </a:solidFill>
-          <a:ln w="5080">
-            <a:solidFill>
-              <a:srgbClr val="AC9E78"/>
-            </a:solidFill>
-            <a:prstDash val="solid"/>
-          </a:ln>
-        </p:spPr>
-      </p:sp>
-      <p:sp>
-        <p:nvSpPr>
-          <p:cNvPr id="74" name="Shape 72"/>
-          <p:cNvSpPr/>
-          <p:nvPr/>
-        </p:nvSpPr>
-        <p:spPr>
-          <a:xfrm>
-            <a:off x="8138160" y="2322576"/>
-            <a:ext cx="768096" cy="237744"/>
-          </a:xfrm>
-          <a:prstGeom prst="roundRect">
-            <a:avLst>
-              <a:gd name="adj" fmla="val 15385"/>
-            </a:avLst>
-          </a:prstGeom>
-          <a:solidFill>
-            <a:srgbClr val="566270"/>
-          </a:solidFill>
-          <a:ln/>
-        </p:spPr>
-      </p:sp>
-      <p:sp>
-        <p:nvSpPr>
-          <p:cNvPr id="75" name="Text 73"/>
-          <p:cNvSpPr/>
-          <p:nvPr/>
-        </p:nvSpPr>
-        <p:spPr>
-          <a:xfrm>
-            <a:off x="8138160" y="2322576"/>
-            <a:ext cx="768096" cy="237744"/>
-          </a:xfrm>
-          <a:prstGeom prst="rect">
-            <a:avLst/>
-          </a:prstGeom>
-          <a:noFill/>
-          <a:ln/>
-        </p:spPr>
-        <p:txBody>
-          <a:bodyPr wrap="square" lIns="0" tIns="0" rIns="0" bIns="0" rtlCol="0" anchor="ctr"/>
-          <a:lstStyle/>
-          <a:p>
-            <a:pPr algn="ctr" indent="0" marL="0">
-              <a:buNone/>
-            </a:pPr>
-            <a:r>
-              <a:rPr lang="en-US" sz="950" b="1" dirty="0">
-                <a:solidFill>
-                  <a:srgbClr val="FFFFFF"/>
-                </a:solidFill>
-                <a:latin typeface="Calibri" pitchFamily="34" charset="0"/>
-                <a:ea typeface="Calibri" pitchFamily="34" charset="-122"/>
-                <a:cs typeface="Calibri" pitchFamily="34" charset="-120"/>
-              </a:rPr>
-              <a:t>4</a:t>
-            </a:r>
-            <a:endParaRPr lang="en-US" sz="950" dirty="0"/>
-          </a:p>
-        </p:txBody>
-      </p:sp>
-      <p:sp>
-        <p:nvSpPr>
-          <p:cNvPr id="76" name="Shape 74"/>
-          <p:cNvSpPr/>
-          <p:nvPr/>
-        </p:nvSpPr>
-        <p:spPr>
-          <a:xfrm>
-            <a:off x="10195560" y="2560320"/>
-            <a:ext cx="530352" cy="1828800"/>
-          </a:xfrm>
-          <a:prstGeom prst="rect">
-            <a:avLst/>
-          </a:prstGeom>
-          <a:solidFill>
-            <a:srgbClr val="DCE0E6"/>
-          </a:solidFill>
-          <a:ln w="16510">
-            <a:solidFill>
-              <a:srgbClr val="8A93A0"/>
-            </a:solidFill>
-            <a:prstDash val="solid"/>
-          </a:ln>
-        </p:spPr>
-      </p:sp>
-      <p:sp>
-        <p:nvSpPr>
-          <p:cNvPr id="77" name="Shape 75"/>
-          <p:cNvSpPr/>
-          <p:nvPr/>
-        </p:nvSpPr>
-        <p:spPr>
-          <a:xfrm>
-            <a:off x="10195560" y="2865120"/>
-            <a:ext cx="530352" cy="0"/>
-          </a:xfrm>
-          <a:prstGeom prst="line">
-            <a:avLst/>
-          </a:prstGeom>
-          <a:noFill/>
-          <a:ln w="10160">
-            <a:solidFill>
-              <a:srgbClr val="9AA3B0"/>
-            </a:solidFill>
-            <a:prstDash val="solid"/>
-          </a:ln>
-        </p:spPr>
-      </p:sp>
-      <p:sp>
-        <p:nvSpPr>
-          <p:cNvPr id="78" name="Shape 76"/>
-          <p:cNvSpPr/>
-          <p:nvPr/>
-        </p:nvSpPr>
-        <p:spPr>
-          <a:xfrm>
-            <a:off x="10195560" y="3169920"/>
-            <a:ext cx="530352" cy="0"/>
-          </a:xfrm>
-          <a:prstGeom prst="line">
-            <a:avLst/>
-          </a:prstGeom>
-          <a:noFill/>
-          <a:ln w="10160">
-            <a:solidFill>
-              <a:srgbClr val="9AA3B0"/>
-            </a:solidFill>
-            <a:prstDash val="solid"/>
-          </a:ln>
-        </p:spPr>
-      </p:sp>
-      <p:sp>
-        <p:nvSpPr>
-          <p:cNvPr id="79" name="Shape 77"/>
-          <p:cNvSpPr/>
-          <p:nvPr/>
-        </p:nvSpPr>
-        <p:spPr>
-          <a:xfrm>
-            <a:off x="10195560" y="3474720"/>
-            <a:ext cx="530352" cy="0"/>
-          </a:xfrm>
-          <a:prstGeom prst="line">
-            <a:avLst/>
-          </a:prstGeom>
-          <a:noFill/>
-          <a:ln w="10160">
-            <a:solidFill>
-              <a:srgbClr val="9AA3B0"/>
-            </a:solidFill>
-            <a:prstDash val="solid"/>
-          </a:ln>
-        </p:spPr>
-      </p:sp>
-      <p:sp>
-        <p:nvSpPr>
-          <p:cNvPr id="80" name="Shape 78"/>
-          <p:cNvSpPr/>
-          <p:nvPr/>
-        </p:nvSpPr>
-        <p:spPr>
-          <a:xfrm>
-            <a:off x="10195560" y="3779520"/>
-            <a:ext cx="530352" cy="0"/>
-          </a:xfrm>
-          <a:prstGeom prst="line">
-            <a:avLst/>
-          </a:prstGeom>
-          <a:noFill/>
-          <a:ln w="10160">
-            <a:solidFill>
-              <a:srgbClr val="9AA3B0"/>
-            </a:solidFill>
-            <a:prstDash val="solid"/>
-          </a:ln>
-        </p:spPr>
-      </p:sp>
-      <p:sp>
-        <p:nvSpPr>
-          <p:cNvPr id="81" name="Shape 79"/>
-          <p:cNvSpPr/>
-          <p:nvPr/>
-        </p:nvSpPr>
-        <p:spPr>
-          <a:xfrm>
-            <a:off x="10195560" y="4084320"/>
-            <a:ext cx="530352" cy="0"/>
-          </a:xfrm>
-          <a:prstGeom prst="line">
-            <a:avLst/>
-          </a:prstGeom>
-          <a:noFill/>
-          <a:ln w="10160">
-            <a:solidFill>
-              <a:srgbClr val="9AA3B0"/>
-            </a:solidFill>
-            <a:prstDash val="solid"/>
-          </a:ln>
-        </p:spPr>
-      </p:sp>
-      <p:sp>
-        <p:nvSpPr>
-          <p:cNvPr id="82" name="Shape 80"/>
-          <p:cNvSpPr/>
-          <p:nvPr/>
-        </p:nvSpPr>
-        <p:spPr>
-          <a:xfrm>
-            <a:off x="10259568" y="2615184"/>
-            <a:ext cx="402336" cy="195072"/>
-          </a:xfrm>
-          <a:prstGeom prst="rect">
-            <a:avLst/>
-          </a:prstGeom>
-          <a:solidFill>
-            <a:srgbClr val="CFC2A0"/>
-          </a:solidFill>
-          <a:ln w="5080">
-            <a:solidFill>
-              <a:srgbClr val="AC9E78"/>
-            </a:solidFill>
-            <a:prstDash val="solid"/>
-          </a:ln>
-        </p:spPr>
-      </p:sp>
-      <p:sp>
-        <p:nvSpPr>
-          <p:cNvPr id="83" name="Shape 81"/>
-          <p:cNvSpPr/>
-          <p:nvPr/>
-        </p:nvSpPr>
-        <p:spPr>
-          <a:xfrm>
-            <a:off x="10259568" y="3224784"/>
-            <a:ext cx="402336" cy="195072"/>
-          </a:xfrm>
-          <a:prstGeom prst="rect">
-            <a:avLst/>
-          </a:prstGeom>
-          <a:solidFill>
-            <a:srgbClr val="CFC2A0"/>
-          </a:solidFill>
-          <a:ln w="5080">
-            <a:solidFill>
-              <a:srgbClr val="AC9E78"/>
-            </a:solidFill>
-            <a:prstDash val="solid"/>
-          </a:ln>
-        </p:spPr>
-      </p:sp>
-      <p:sp>
-        <p:nvSpPr>
-          <p:cNvPr id="84" name="Shape 82"/>
-          <p:cNvSpPr/>
-          <p:nvPr/>
-        </p:nvSpPr>
-        <p:spPr>
-          <a:xfrm>
-            <a:off x="10259568" y="3834384"/>
-            <a:ext cx="402336" cy="195072"/>
-          </a:xfrm>
-          <a:prstGeom prst="rect">
-            <a:avLst/>
-          </a:prstGeom>
-          <a:solidFill>
-            <a:srgbClr val="CFC2A0"/>
-          </a:solidFill>
-          <a:ln w="5080">
-            <a:solidFill>
-              <a:srgbClr val="AC9E78"/>
-            </a:solidFill>
-            <a:prstDash val="solid"/>
-          </a:ln>
-        </p:spPr>
-      </p:sp>
-      <p:sp>
-        <p:nvSpPr>
-          <p:cNvPr id="85" name="Shape 83"/>
-          <p:cNvSpPr/>
-          <p:nvPr/>
-        </p:nvSpPr>
-        <p:spPr>
-          <a:xfrm>
-            <a:off x="10076688" y="2322576"/>
-            <a:ext cx="768096" cy="237744"/>
-          </a:xfrm>
-          <a:prstGeom prst="roundRect">
-            <a:avLst>
-              <a:gd name="adj" fmla="val 15385"/>
-            </a:avLst>
-          </a:prstGeom>
-          <a:solidFill>
-            <a:srgbClr val="566270"/>
-          </a:solidFill>
-          <a:ln/>
-        </p:spPr>
-      </p:sp>
-      <p:sp>
-        <p:nvSpPr>
-          <p:cNvPr id="86" name="Text 84"/>
-          <p:cNvSpPr/>
-          <p:nvPr/>
-        </p:nvSpPr>
-        <p:spPr>
-          <a:xfrm>
-            <a:off x="10076688" y="2322576"/>
-            <a:ext cx="768096" cy="237744"/>
-          </a:xfrm>
-          <a:prstGeom prst="rect">
-            <a:avLst/>
-          </a:prstGeom>
-          <a:noFill/>
-          <a:ln/>
-        </p:spPr>
-        <p:txBody>
-          <a:bodyPr wrap="square" lIns="0" tIns="0" rIns="0" bIns="0" rtlCol="0" anchor="ctr"/>
-          <a:lstStyle/>
-          <a:p>
-            <a:pPr algn="ctr" indent="0" marL="0">
-              <a:buNone/>
-            </a:pPr>
-            <a:r>
-              <a:rPr lang="en-US" sz="950" b="1" dirty="0">
-                <a:solidFill>
-                  <a:srgbClr val="FFFFFF"/>
-                </a:solidFill>
-                <a:latin typeface="Calibri" pitchFamily="34" charset="0"/>
-                <a:ea typeface="Calibri" pitchFamily="34" charset="-122"/>
-                <a:cs typeface="Calibri" pitchFamily="34" charset="-120"/>
-              </a:rPr>
-              <a:t>3</a:t>
-            </a:r>
-            <a:endParaRPr lang="en-US" sz="950" dirty="0"/>
-          </a:p>
-        </p:txBody>
-      </p:sp>
-      <p:sp>
-        <p:nvSpPr>
-          <p:cNvPr id="87" name="Shape 85"/>
-          <p:cNvSpPr/>
-          <p:nvPr/>
-        </p:nvSpPr>
-        <p:spPr>
-          <a:xfrm>
-            <a:off x="8869680" y="2743200"/>
-            <a:ext cx="137160" cy="137160"/>
-          </a:xfrm>
-          <a:prstGeom prst="rect">
-            <a:avLst/>
-          </a:prstGeom>
-          <a:solidFill>
-            <a:srgbClr val="111111"/>
-          </a:solidFill>
-          <a:ln/>
-        </p:spPr>
-      </p:sp>
-      <p:sp>
-        <p:nvSpPr>
-          <p:cNvPr id="88" name="Shape 86"/>
-          <p:cNvSpPr/>
-          <p:nvPr/>
-        </p:nvSpPr>
-        <p:spPr>
-          <a:xfrm>
-            <a:off x="8897112" y="2770632"/>
-            <a:ext cx="24689" cy="24689"/>
-          </a:xfrm>
-          <a:prstGeom prst="rect">
-            <a:avLst/>
-          </a:prstGeom>
-          <a:solidFill>
-            <a:srgbClr val="FFFFFF"/>
-          </a:solidFill>
-          <a:ln/>
-        </p:spPr>
-      </p:sp>
-      <p:sp>
-        <p:nvSpPr>
-          <p:cNvPr id="89" name="Shape 87"/>
-          <p:cNvSpPr/>
-          <p:nvPr/>
-        </p:nvSpPr>
-        <p:spPr>
-          <a:xfrm>
-            <a:off x="8951976" y="2770632"/>
-            <a:ext cx="24689" cy="24689"/>
-          </a:xfrm>
-          <a:prstGeom prst="rect">
-            <a:avLst/>
-          </a:prstGeom>
-          <a:solidFill>
-            <a:srgbClr val="FFFFFF"/>
-          </a:solidFill>
-          <a:ln/>
-        </p:spPr>
-      </p:sp>
-      <p:sp>
-        <p:nvSpPr>
-          <p:cNvPr id="90" name="Shape 88"/>
-          <p:cNvSpPr/>
-          <p:nvPr/>
-        </p:nvSpPr>
-        <p:spPr>
-          <a:xfrm>
-            <a:off x="8924544" y="2798064"/>
-            <a:ext cx="24689" cy="24689"/>
-          </a:xfrm>
-          <a:prstGeom prst="rect">
-            <a:avLst/>
-          </a:prstGeom>
-          <a:solidFill>
-            <a:srgbClr val="FFFFFF"/>
-          </a:solidFill>
-          <a:ln/>
-        </p:spPr>
-      </p:sp>
-      <p:sp>
-        <p:nvSpPr>
-          <p:cNvPr id="91" name="Shape 89"/>
-          <p:cNvSpPr/>
-          <p:nvPr/>
-        </p:nvSpPr>
-        <p:spPr>
-          <a:xfrm>
-            <a:off x="8897112" y="2825496"/>
-            <a:ext cx="24689" cy="24689"/>
-          </a:xfrm>
-          <a:prstGeom prst="rect">
-            <a:avLst/>
-          </a:prstGeom>
-          <a:solidFill>
-            <a:srgbClr val="FFFFFF"/>
-          </a:solidFill>
-          <a:ln/>
-        </p:spPr>
-      </p:sp>
-      <p:sp>
-        <p:nvSpPr>
-          <p:cNvPr id="92" name="Shape 90"/>
-          <p:cNvSpPr/>
-          <p:nvPr/>
-        </p:nvSpPr>
-        <p:spPr>
-          <a:xfrm>
-            <a:off x="8951976" y="2825496"/>
-            <a:ext cx="24689" cy="24689"/>
-          </a:xfrm>
-          <a:prstGeom prst="rect">
-            <a:avLst/>
-          </a:prstGeom>
-          <a:solidFill>
-            <a:srgbClr val="FFFFFF"/>
-          </a:solidFill>
-          <a:ln/>
-        </p:spPr>
-      </p:sp>
-      <p:sp>
-        <p:nvSpPr>
-          <p:cNvPr id="93" name="Shape 91"/>
-          <p:cNvSpPr/>
-          <p:nvPr/>
-        </p:nvSpPr>
-        <p:spPr>
-          <a:xfrm>
-            <a:off x="9957816" y="2743200"/>
-            <a:ext cx="137160" cy="137160"/>
-          </a:xfrm>
-          <a:prstGeom prst="rect">
-            <a:avLst/>
-          </a:prstGeom>
-          <a:solidFill>
-            <a:srgbClr val="111111"/>
-          </a:solidFill>
-          <a:ln/>
-        </p:spPr>
-      </p:sp>
-      <p:sp>
-        <p:nvSpPr>
-          <p:cNvPr id="94" name="Shape 92"/>
-          <p:cNvSpPr/>
-          <p:nvPr/>
-        </p:nvSpPr>
-        <p:spPr>
-          <a:xfrm>
-            <a:off x="9985248" y="2770632"/>
-            <a:ext cx="24689" cy="24689"/>
-          </a:xfrm>
-          <a:prstGeom prst="rect">
-            <a:avLst/>
-          </a:prstGeom>
-          <a:solidFill>
-            <a:srgbClr val="FFFFFF"/>
-          </a:solidFill>
-          <a:ln/>
-        </p:spPr>
-      </p:sp>
-      <p:sp>
-        <p:nvSpPr>
-          <p:cNvPr id="95" name="Shape 93"/>
-          <p:cNvSpPr/>
-          <p:nvPr/>
-        </p:nvSpPr>
-        <p:spPr>
-          <a:xfrm>
-            <a:off x="10040112" y="2770632"/>
-            <a:ext cx="24689" cy="24689"/>
-          </a:xfrm>
-          <a:prstGeom prst="rect">
-            <a:avLst/>
-          </a:prstGeom>
-          <a:solidFill>
-            <a:srgbClr val="FFFFFF"/>
-          </a:solidFill>
-          <a:ln/>
-        </p:spPr>
-      </p:sp>
-      <p:sp>
-        <p:nvSpPr>
-          <p:cNvPr id="96" name="Shape 94"/>
-          <p:cNvSpPr/>
-          <p:nvPr/>
-        </p:nvSpPr>
-        <p:spPr>
-          <a:xfrm>
-            <a:off x="10012680" y="2798064"/>
-            <a:ext cx="24689" cy="24689"/>
-          </a:xfrm>
-          <a:prstGeom prst="rect">
-            <a:avLst/>
-          </a:prstGeom>
-          <a:solidFill>
-            <a:srgbClr val="FFFFFF"/>
-          </a:solidFill>
-          <a:ln/>
-        </p:spPr>
-      </p:sp>
-      <p:sp>
-        <p:nvSpPr>
-          <p:cNvPr id="97" name="Shape 95"/>
-          <p:cNvSpPr/>
-          <p:nvPr/>
-        </p:nvSpPr>
-        <p:spPr>
-          <a:xfrm>
-            <a:off x="9985248" y="2825496"/>
-            <a:ext cx="24689" cy="24689"/>
-          </a:xfrm>
-          <a:prstGeom prst="rect">
-            <a:avLst/>
-          </a:prstGeom>
-          <a:solidFill>
-            <a:srgbClr val="FFFFFF"/>
-          </a:solidFill>
-          <a:ln/>
-        </p:spPr>
-      </p:sp>
-      <p:sp>
-        <p:nvSpPr>
-          <p:cNvPr id="98" name="Shape 96"/>
-          <p:cNvSpPr/>
-          <p:nvPr/>
-        </p:nvSpPr>
-        <p:spPr>
-          <a:xfrm>
-            <a:off x="10040112" y="2825496"/>
-            <a:ext cx="24689" cy="24689"/>
-          </a:xfrm>
-          <a:prstGeom prst="rect">
-            <a:avLst/>
-          </a:prstGeom>
-          <a:solidFill>
-            <a:srgbClr val="FFFFFF"/>
-          </a:solidFill>
-          <a:ln/>
-        </p:spPr>
-      </p:sp>
-      <p:sp>
-        <p:nvSpPr>
-          <p:cNvPr id="99" name="Shape 97"/>
-          <p:cNvSpPr/>
-          <p:nvPr/>
-        </p:nvSpPr>
-        <p:spPr>
-          <a:xfrm>
-            <a:off x="8869680" y="3246120"/>
-            <a:ext cx="137160" cy="137160"/>
-          </a:xfrm>
-          <a:prstGeom prst="rect">
-            <a:avLst/>
-          </a:prstGeom>
-          <a:solidFill>
-            <a:srgbClr val="111111"/>
-          </a:solidFill>
-          <a:ln/>
-        </p:spPr>
-      </p:sp>
-      <p:sp>
-        <p:nvSpPr>
-          <p:cNvPr id="100" name="Shape 98"/>
-          <p:cNvSpPr/>
-          <p:nvPr/>
-        </p:nvSpPr>
-        <p:spPr>
-          <a:xfrm>
-            <a:off x="8897112" y="3273552"/>
-            <a:ext cx="24689" cy="24689"/>
-          </a:xfrm>
-          <a:prstGeom prst="rect">
-            <a:avLst/>
-          </a:prstGeom>
-          <a:solidFill>
-            <a:srgbClr val="FFFFFF"/>
-          </a:solidFill>
-          <a:ln/>
-        </p:spPr>
-      </p:sp>
-      <p:sp>
-        <p:nvSpPr>
-          <p:cNvPr id="101" name="Shape 99"/>
-          <p:cNvSpPr/>
-          <p:nvPr/>
-        </p:nvSpPr>
-        <p:spPr>
-          <a:xfrm>
-            <a:off x="8951976" y="3273552"/>
-            <a:ext cx="24689" cy="24689"/>
-          </a:xfrm>
-          <a:prstGeom prst="rect">
-            <a:avLst/>
-          </a:prstGeom>
-          <a:solidFill>
-            <a:srgbClr val="FFFFFF"/>
-          </a:solidFill>
-          <a:ln/>
-        </p:spPr>
-      </p:sp>
-      <p:sp>
-        <p:nvSpPr>
-          <p:cNvPr id="102" name="Shape 100"/>
-          <p:cNvSpPr/>
-          <p:nvPr/>
-        </p:nvSpPr>
-        <p:spPr>
-          <a:xfrm>
-            <a:off x="8924544" y="3300984"/>
-            <a:ext cx="24689" cy="24689"/>
-          </a:xfrm>
-          <a:prstGeom prst="rect">
-            <a:avLst/>
-          </a:prstGeom>
-          <a:solidFill>
-            <a:srgbClr val="FFFFFF"/>
-          </a:solidFill>
-          <a:ln/>
-        </p:spPr>
-      </p:sp>
-      <p:sp>
-        <p:nvSpPr>
-          <p:cNvPr id="103" name="Shape 101"/>
-          <p:cNvSpPr/>
-          <p:nvPr/>
-        </p:nvSpPr>
-        <p:spPr>
-          <a:xfrm>
-            <a:off x="8897112" y="3328416"/>
-            <a:ext cx="24689" cy="24689"/>
-          </a:xfrm>
-          <a:prstGeom prst="rect">
-            <a:avLst/>
-          </a:prstGeom>
-          <a:solidFill>
-            <a:srgbClr val="FFFFFF"/>
-          </a:solidFill>
-          <a:ln/>
-        </p:spPr>
-      </p:sp>
-      <p:sp>
-        <p:nvSpPr>
-          <p:cNvPr id="104" name="Shape 102"/>
-          <p:cNvSpPr/>
-          <p:nvPr/>
-        </p:nvSpPr>
-        <p:spPr>
-          <a:xfrm>
-            <a:off x="8951976" y="3328416"/>
-            <a:ext cx="24689" cy="24689"/>
-          </a:xfrm>
-          <a:prstGeom prst="rect">
-            <a:avLst/>
-          </a:prstGeom>
-          <a:solidFill>
-            <a:srgbClr val="FFFFFF"/>
-          </a:solidFill>
-          <a:ln/>
-        </p:spPr>
-      </p:sp>
-      <p:sp>
-        <p:nvSpPr>
-          <p:cNvPr id="105" name="Shape 103"/>
-          <p:cNvSpPr/>
-          <p:nvPr/>
-        </p:nvSpPr>
-        <p:spPr>
-          <a:xfrm>
-            <a:off x="9957816" y="3246120"/>
-            <a:ext cx="137160" cy="137160"/>
-          </a:xfrm>
-          <a:prstGeom prst="rect">
-            <a:avLst/>
-          </a:prstGeom>
-          <a:solidFill>
-            <a:srgbClr val="111111"/>
-          </a:solidFill>
-          <a:ln/>
-        </p:spPr>
-      </p:sp>
-      <p:sp>
-        <p:nvSpPr>
-          <p:cNvPr id="106" name="Shape 104"/>
-          <p:cNvSpPr/>
-          <p:nvPr/>
-        </p:nvSpPr>
-        <p:spPr>
-          <a:xfrm>
-            <a:off x="9985248" y="3273552"/>
-            <a:ext cx="24689" cy="24689"/>
-          </a:xfrm>
-          <a:prstGeom prst="rect">
-            <a:avLst/>
-          </a:prstGeom>
-          <a:solidFill>
-            <a:srgbClr val="FFFFFF"/>
-          </a:solidFill>
-          <a:ln/>
-        </p:spPr>
-      </p:sp>
-      <p:sp>
-        <p:nvSpPr>
-          <p:cNvPr id="107" name="Shape 105"/>
-          <p:cNvSpPr/>
-          <p:nvPr/>
-        </p:nvSpPr>
-        <p:spPr>
-          <a:xfrm>
-            <a:off x="10040112" y="3273552"/>
-            <a:ext cx="24689" cy="24689"/>
-          </a:xfrm>
-          <a:prstGeom prst="rect">
-            <a:avLst/>
-          </a:prstGeom>
-          <a:solidFill>
-            <a:srgbClr val="FFFFFF"/>
-          </a:solidFill>
-          <a:ln/>
-        </p:spPr>
-      </p:sp>
-      <p:sp>
-        <p:nvSpPr>
-          <p:cNvPr id="108" name="Shape 106"/>
-          <p:cNvSpPr/>
-          <p:nvPr/>
-        </p:nvSpPr>
-        <p:spPr>
-          <a:xfrm>
-            <a:off x="10012680" y="3300984"/>
-            <a:ext cx="24689" cy="24689"/>
-          </a:xfrm>
-          <a:prstGeom prst="rect">
-            <a:avLst/>
-          </a:prstGeom>
-          <a:solidFill>
-            <a:srgbClr val="FFFFFF"/>
-          </a:solidFill>
-          <a:ln/>
-        </p:spPr>
-      </p:sp>
-      <p:sp>
-        <p:nvSpPr>
-          <p:cNvPr id="109" name="Shape 107"/>
-          <p:cNvSpPr/>
-          <p:nvPr/>
-        </p:nvSpPr>
-        <p:spPr>
-          <a:xfrm>
-            <a:off x="9985248" y="3328416"/>
-            <a:ext cx="24689" cy="24689"/>
-          </a:xfrm>
-          <a:prstGeom prst="rect">
-            <a:avLst/>
-          </a:prstGeom>
-          <a:solidFill>
-            <a:srgbClr val="FFFFFF"/>
-          </a:solidFill>
-          <a:ln/>
-        </p:spPr>
-      </p:sp>
-      <p:sp>
-        <p:nvSpPr>
-          <p:cNvPr id="110" name="Shape 108"/>
-          <p:cNvSpPr/>
-          <p:nvPr/>
-        </p:nvSpPr>
-        <p:spPr>
-          <a:xfrm>
-            <a:off x="10040112" y="3328416"/>
-            <a:ext cx="24689" cy="24689"/>
-          </a:xfrm>
-          <a:prstGeom prst="rect">
-            <a:avLst/>
-          </a:prstGeom>
-          <a:solidFill>
-            <a:srgbClr val="FFFFFF"/>
-          </a:solidFill>
-          <a:ln/>
-        </p:spPr>
-      </p:sp>
-      <p:sp>
-        <p:nvSpPr>
-          <p:cNvPr id="111" name="Shape 109"/>
-          <p:cNvSpPr/>
-          <p:nvPr/>
-        </p:nvSpPr>
-        <p:spPr>
-          <a:xfrm>
-            <a:off x="8869680" y="3749040"/>
-            <a:ext cx="137160" cy="137160"/>
-          </a:xfrm>
-          <a:prstGeom prst="rect">
-            <a:avLst/>
-          </a:prstGeom>
-          <a:solidFill>
-            <a:srgbClr val="111111"/>
-          </a:solidFill>
-          <a:ln/>
-        </p:spPr>
-      </p:sp>
-      <p:sp>
-        <p:nvSpPr>
-          <p:cNvPr id="112" name="Shape 110"/>
-          <p:cNvSpPr/>
-          <p:nvPr/>
-        </p:nvSpPr>
-        <p:spPr>
-          <a:xfrm>
-            <a:off x="8897112" y="3776472"/>
-            <a:ext cx="24689" cy="24689"/>
-          </a:xfrm>
-          <a:prstGeom prst="rect">
-            <a:avLst/>
-          </a:prstGeom>
-          <a:solidFill>
-            <a:srgbClr val="FFFFFF"/>
-          </a:solidFill>
-          <a:ln/>
-        </p:spPr>
-      </p:sp>
-      <p:sp>
-        <p:nvSpPr>
-          <p:cNvPr id="113" name="Shape 111"/>
-          <p:cNvSpPr/>
-          <p:nvPr/>
-        </p:nvSpPr>
-        <p:spPr>
-          <a:xfrm>
-            <a:off x="8951976" y="3776472"/>
-            <a:ext cx="24689" cy="24689"/>
-          </a:xfrm>
-          <a:prstGeom prst="rect">
-            <a:avLst/>
-          </a:prstGeom>
-          <a:solidFill>
-            <a:srgbClr val="FFFFFF"/>
-          </a:solidFill>
-          <a:ln/>
-        </p:spPr>
-      </p:sp>
-      <p:sp>
-        <p:nvSpPr>
-          <p:cNvPr id="114" name="Shape 112"/>
-          <p:cNvSpPr/>
-          <p:nvPr/>
-        </p:nvSpPr>
-        <p:spPr>
-          <a:xfrm>
-            <a:off x="8924544" y="3803904"/>
-            <a:ext cx="24689" cy="24689"/>
-          </a:xfrm>
-          <a:prstGeom prst="rect">
-            <a:avLst/>
-          </a:prstGeom>
-          <a:solidFill>
-            <a:srgbClr val="FFFFFF"/>
-          </a:solidFill>
-          <a:ln/>
-        </p:spPr>
-      </p:sp>
-      <p:sp>
-        <p:nvSpPr>
-          <p:cNvPr id="115" name="Shape 113"/>
-          <p:cNvSpPr/>
-          <p:nvPr/>
-        </p:nvSpPr>
-        <p:spPr>
-          <a:xfrm>
-            <a:off x="8897112" y="3831336"/>
-            <a:ext cx="24689" cy="24689"/>
-          </a:xfrm>
-          <a:prstGeom prst="rect">
-            <a:avLst/>
-          </a:prstGeom>
-          <a:solidFill>
-            <a:srgbClr val="FFFFFF"/>
-          </a:solidFill>
-          <a:ln/>
-        </p:spPr>
-      </p:sp>
-      <p:sp>
-        <p:nvSpPr>
-          <p:cNvPr id="116" name="Shape 114"/>
-          <p:cNvSpPr/>
-          <p:nvPr/>
-        </p:nvSpPr>
-        <p:spPr>
-          <a:xfrm>
-            <a:off x="8951976" y="3831336"/>
-            <a:ext cx="24689" cy="24689"/>
-          </a:xfrm>
-          <a:prstGeom prst="rect">
-            <a:avLst/>
-          </a:prstGeom>
-          <a:solidFill>
-            <a:srgbClr val="FFFFFF"/>
-          </a:solidFill>
-          <a:ln/>
-        </p:spPr>
-      </p:sp>
-      <p:sp>
-        <p:nvSpPr>
-          <p:cNvPr id="117" name="Shape 115"/>
-          <p:cNvSpPr/>
-          <p:nvPr/>
-        </p:nvSpPr>
-        <p:spPr>
-          <a:xfrm>
-            <a:off x="9957816" y="3749040"/>
-            <a:ext cx="137160" cy="137160"/>
-          </a:xfrm>
-          <a:prstGeom prst="rect">
-            <a:avLst/>
-          </a:prstGeom>
-          <a:solidFill>
-            <a:srgbClr val="111111"/>
-          </a:solidFill>
-          <a:ln/>
-        </p:spPr>
-      </p:sp>
-      <p:sp>
-        <p:nvSpPr>
-          <p:cNvPr id="118" name="Shape 116"/>
-          <p:cNvSpPr/>
-          <p:nvPr/>
-        </p:nvSpPr>
-        <p:spPr>
-          <a:xfrm>
-            <a:off x="9985248" y="3776472"/>
-            <a:ext cx="24689" cy="24689"/>
-          </a:xfrm>
-          <a:prstGeom prst="rect">
-            <a:avLst/>
-          </a:prstGeom>
-          <a:solidFill>
-            <a:srgbClr val="FFFFFF"/>
-          </a:solidFill>
-          <a:ln/>
-        </p:spPr>
-      </p:sp>
-      <p:sp>
-        <p:nvSpPr>
-          <p:cNvPr id="119" name="Shape 117"/>
-          <p:cNvSpPr/>
-          <p:nvPr/>
-        </p:nvSpPr>
-        <p:spPr>
-          <a:xfrm>
-            <a:off x="10040112" y="3776472"/>
-            <a:ext cx="24689" cy="24689"/>
-          </a:xfrm>
-          <a:prstGeom prst="rect">
-            <a:avLst/>
-          </a:prstGeom>
-          <a:solidFill>
-            <a:srgbClr val="FFFFFF"/>
-          </a:solidFill>
-          <a:ln/>
-        </p:spPr>
-      </p:sp>
-      <p:sp>
-        <p:nvSpPr>
-          <p:cNvPr id="120" name="Shape 118"/>
-          <p:cNvSpPr/>
-          <p:nvPr/>
-        </p:nvSpPr>
-        <p:spPr>
-          <a:xfrm>
-            <a:off x="10012680" y="3803904"/>
-            <a:ext cx="24689" cy="24689"/>
-          </a:xfrm>
-          <a:prstGeom prst="rect">
-            <a:avLst/>
-          </a:prstGeom>
-          <a:solidFill>
-            <a:srgbClr val="FFFFFF"/>
-          </a:solidFill>
-          <a:ln/>
-        </p:spPr>
-      </p:sp>
-      <p:sp>
-        <p:nvSpPr>
-          <p:cNvPr id="121" name="Shape 119"/>
-          <p:cNvSpPr/>
-          <p:nvPr/>
-        </p:nvSpPr>
-        <p:spPr>
-          <a:xfrm>
-            <a:off x="9985248" y="3831336"/>
-            <a:ext cx="24689" cy="24689"/>
-          </a:xfrm>
-          <a:prstGeom prst="rect">
-            <a:avLst/>
-          </a:prstGeom>
-          <a:solidFill>
-            <a:srgbClr val="FFFFFF"/>
-          </a:solidFill>
-          <a:ln/>
-        </p:spPr>
-      </p:sp>
-      <p:sp>
-        <p:nvSpPr>
-          <p:cNvPr id="122" name="Shape 120"/>
-          <p:cNvSpPr/>
-          <p:nvPr/>
-        </p:nvSpPr>
-        <p:spPr>
-          <a:xfrm>
-            <a:off x="10040112" y="3831336"/>
-            <a:ext cx="24689" cy="24689"/>
-          </a:xfrm>
-          <a:prstGeom prst="rect">
-            <a:avLst/>
-          </a:prstGeom>
-          <a:solidFill>
-            <a:srgbClr val="FFFFFF"/>
-          </a:solidFill>
-          <a:ln/>
-        </p:spPr>
-      </p:sp>
-      <p:sp>
-        <p:nvSpPr>
-          <p:cNvPr id="123" name="Shape 121"/>
-          <p:cNvSpPr/>
-          <p:nvPr/>
-        </p:nvSpPr>
-        <p:spPr>
-          <a:xfrm>
-            <a:off x="9134856" y="2267712"/>
-            <a:ext cx="694944" cy="347472"/>
-          </a:xfrm>
-          <a:prstGeom prst="roundRect">
-            <a:avLst>
-              <a:gd name="adj" fmla="val 13158"/>
-            </a:avLst>
-          </a:prstGeom>
-          <a:solidFill>
-            <a:srgbClr val="CDE9F7"/>
-          </a:solidFill>
-          <a:ln w="13970">
-            <a:solidFill>
-              <a:srgbClr val="566270"/>
-            </a:solidFill>
-            <a:prstDash val="solid"/>
-          </a:ln>
-        </p:spPr>
-      </p:sp>
-      <p:sp>
-        <p:nvSpPr>
-          <p:cNvPr id="124" name="Shape 122"/>
-          <p:cNvSpPr/>
-          <p:nvPr/>
-        </p:nvSpPr>
-        <p:spPr>
-          <a:xfrm>
-            <a:off x="9341876" y="2615184"/>
-            <a:ext cx="64008" cy="310896"/>
-          </a:xfrm>
-          <a:prstGeom prst="rect">
-            <a:avLst/>
-          </a:prstGeom>
-          <a:solidFill>
-            <a:srgbClr val="566270"/>
-          </a:solidFill>
-          <a:ln/>
-        </p:spPr>
-      </p:sp>
-      <p:sp>
-        <p:nvSpPr>
-          <p:cNvPr id="125" name="Shape 123"/>
-          <p:cNvSpPr/>
-          <p:nvPr/>
-        </p:nvSpPr>
-        <p:spPr>
-          <a:xfrm>
-            <a:off x="9558772" y="2615184"/>
-            <a:ext cx="64008" cy="310896"/>
-          </a:xfrm>
-          <a:prstGeom prst="rect">
-            <a:avLst/>
-          </a:prstGeom>
-          <a:solidFill>
-            <a:srgbClr val="566270"/>
-          </a:solidFill>
-          <a:ln/>
-        </p:spPr>
-      </p:sp>
-      <p:sp>
-        <p:nvSpPr>
-          <p:cNvPr id="126" name="Text 124"/>
-          <p:cNvSpPr/>
-          <p:nvPr/>
-        </p:nvSpPr>
-        <p:spPr>
-          <a:xfrm>
-            <a:off x="9134856" y="2267712"/>
-            <a:ext cx="694944" cy="347472"/>
-          </a:xfrm>
-          <a:prstGeom prst="rect">
-            <a:avLst/>
-          </a:prstGeom>
-          <a:noFill/>
-          <a:ln/>
-        </p:spPr>
-        <p:txBody>
-          <a:bodyPr wrap="square" lIns="0" tIns="0" rIns="0" bIns="0" rtlCol="0" anchor="ctr"/>
-          <a:lstStyle/>
-          <a:p>
-            <a:pPr algn="ctr" indent="0" marL="0">
-              <a:buNone/>
-            </a:pPr>
-            <a:r>
-              <a:rPr lang="en-US" sz="900" b="1" dirty="0">
-                <a:solidFill>
-                  <a:srgbClr val="2A2F39"/>
-                </a:solidFill>
-                <a:latin typeface="Calibri" pitchFamily="34" charset="0"/>
-                <a:ea typeface="Calibri" pitchFamily="34" charset="-122"/>
-                <a:cs typeface="Calibri" pitchFamily="34" charset="-120"/>
-              </a:rPr>
-              <a:t>1</a:t>
-            </a:r>
-            <a:endParaRPr lang="en-US" sz="900" dirty="0"/>
-          </a:p>
-        </p:txBody>
-      </p:sp>
-      <p:sp>
-        <p:nvSpPr>
-          <p:cNvPr id="127" name="Shape 125"/>
-          <p:cNvSpPr/>
-          <p:nvPr/>
-        </p:nvSpPr>
-        <p:spPr>
-          <a:xfrm>
-            <a:off x="8842248" y="2139696"/>
-            <a:ext cx="1280160" cy="0"/>
-          </a:xfrm>
-          <a:prstGeom prst="line">
-            <a:avLst/>
-          </a:prstGeom>
-          <a:noFill/>
-          <a:ln w="16510">
-            <a:solidFill>
-              <a:srgbClr val="8A6D16"/>
-            </a:solidFill>
-            <a:prstDash val="solid"/>
-            <a:headEnd type="triangle"/>
-            <a:tailEnd type="triangle"/>
-          </a:ln>
-        </p:spPr>
-      </p:sp>
-      <p:sp>
-        <p:nvSpPr>
-          <p:cNvPr id="128" name="Text 126"/>
-          <p:cNvSpPr/>
-          <p:nvPr/>
-        </p:nvSpPr>
-        <p:spPr>
-          <a:xfrm>
-            <a:off x="8842248" y="1883664"/>
-            <a:ext cx="1280160" cy="219456"/>
-          </a:xfrm>
-          <a:prstGeom prst="rect">
-            <a:avLst/>
-          </a:prstGeom>
-          <a:noFill/>
-          <a:ln/>
-        </p:spPr>
-        <p:txBody>
-          <a:bodyPr wrap="square" lIns="0" tIns="0" rIns="0" bIns="0" rtlCol="0" anchor="ctr"/>
-          <a:lstStyle/>
-          <a:p>
-            <a:pPr algn="ctr" indent="0" marL="0">
-              <a:buNone/>
-            </a:pPr>
-            <a:r>
-              <a:rPr lang="en-US" sz="1100" b="1" dirty="0">
-                <a:solidFill>
-                  <a:srgbClr val="8A6D16"/>
-                </a:solidFill>
-                <a:latin typeface="Calibri" pitchFamily="34" charset="0"/>
-                <a:ea typeface="Calibri" pitchFamily="34" charset="-122"/>
-                <a:cs typeface="Calibri" pitchFamily="34" charset="-120"/>
-              </a:rPr>
-              <a:t>3.0 m</a:t>
-            </a:r>
-            <a:endParaRPr lang="en-US" sz="1100" dirty="0"/>
-          </a:p>
-        </p:txBody>
-      </p:sp>
-      <p:sp>
-        <p:nvSpPr>
-          <p:cNvPr id="129" name="Shape 127"/>
-          <p:cNvSpPr/>
-          <p:nvPr/>
-        </p:nvSpPr>
-        <p:spPr>
-          <a:xfrm>
-            <a:off x="8129016" y="2560320"/>
-            <a:ext cx="0" cy="1828800"/>
-          </a:xfrm>
-          <a:prstGeom prst="line">
-            <a:avLst/>
-          </a:prstGeom>
-          <a:noFill/>
-          <a:ln w="16510">
-            <a:solidFill>
-              <a:srgbClr val="8A6D16"/>
-            </a:solidFill>
-            <a:prstDash val="solid"/>
-            <a:headEnd type="triangle"/>
-            <a:tailEnd type="triangle"/>
-          </a:ln>
-        </p:spPr>
-      </p:sp>
-      <p:sp>
-        <p:nvSpPr>
-          <p:cNvPr id="130" name="Text 128"/>
-          <p:cNvSpPr/>
-          <p:nvPr/>
-        </p:nvSpPr>
-        <p:spPr>
-          <a:xfrm>
-            <a:off x="7488936" y="3355848"/>
-            <a:ext cx="603504" cy="237744"/>
-          </a:xfrm>
-          <a:prstGeom prst="rect">
-            <a:avLst/>
-          </a:prstGeom>
-          <a:noFill/>
-          <a:ln/>
-        </p:spPr>
-        <p:txBody>
-          <a:bodyPr wrap="square" lIns="0" tIns="0" rIns="0" bIns="0" rtlCol="0" anchor="ctr"/>
-          <a:lstStyle/>
-          <a:p>
-            <a:pPr algn="ctr" indent="0" marL="0">
-              <a:buNone/>
-            </a:pPr>
-            <a:r>
-              <a:rPr lang="en-US" sz="900" b="1" dirty="0">
-                <a:solidFill>
-                  <a:srgbClr val="8A6D16"/>
-                </a:solidFill>
-                <a:latin typeface="Calibri" pitchFamily="34" charset="0"/>
-                <a:ea typeface="Calibri" pitchFamily="34" charset="-122"/>
-                <a:cs typeface="Calibri" pitchFamily="34" charset="-120"/>
-              </a:rPr>
-              <a:t>6.0 m</a:t>
-            </a:r>
-            <a:endParaRPr lang="en-US" sz="900" dirty="0"/>
-          </a:p>
-        </p:txBody>
-      </p:sp>
-      <p:sp>
-        <p:nvSpPr>
-          <p:cNvPr id="131" name="Shape 129"/>
-          <p:cNvSpPr/>
-          <p:nvPr/>
-        </p:nvSpPr>
-        <p:spPr>
-          <a:xfrm>
-            <a:off x="8366760" y="4645152"/>
-            <a:ext cx="566928" cy="329184"/>
-          </a:xfrm>
-          <a:prstGeom prst="roundRect">
-            <a:avLst>
-              <a:gd name="adj" fmla="val 13889"/>
-            </a:avLst>
-          </a:prstGeom>
-          <a:solidFill>
-            <a:srgbClr val="E4E7DF"/>
-          </a:solidFill>
-          <a:ln w="13970">
-            <a:solidFill>
-              <a:srgbClr val="566270"/>
-            </a:solidFill>
-            <a:prstDash val="solid"/>
-          </a:ln>
-        </p:spPr>
-      </p:sp>
-      <p:sp>
-        <p:nvSpPr>
-          <p:cNvPr id="132" name="Shape 130"/>
-          <p:cNvSpPr/>
-          <p:nvPr/>
-        </p:nvSpPr>
-        <p:spPr>
-          <a:xfrm>
-            <a:off x="8513796" y="4334256"/>
-            <a:ext cx="64008" cy="310896"/>
-          </a:xfrm>
-          <a:prstGeom prst="rect">
-            <a:avLst/>
-          </a:prstGeom>
-          <a:solidFill>
-            <a:srgbClr val="566270"/>
-          </a:solidFill>
-          <a:ln/>
-        </p:spPr>
-      </p:sp>
-      <p:sp>
-        <p:nvSpPr>
-          <p:cNvPr id="133" name="Shape 131"/>
-          <p:cNvSpPr/>
-          <p:nvPr/>
-        </p:nvSpPr>
-        <p:spPr>
-          <a:xfrm>
-            <a:off x="8722644" y="4334256"/>
-            <a:ext cx="64008" cy="310896"/>
-          </a:xfrm>
-          <a:prstGeom prst="rect">
-            <a:avLst/>
-          </a:prstGeom>
-          <a:solidFill>
-            <a:srgbClr val="566270"/>
-          </a:solidFill>
-          <a:ln/>
-        </p:spPr>
-      </p:sp>
-      <p:sp>
-        <p:nvSpPr>
-          <p:cNvPr id="134" name="Shape 132"/>
-          <p:cNvSpPr/>
-          <p:nvPr/>
-        </p:nvSpPr>
-        <p:spPr>
-          <a:xfrm>
-            <a:off x="8513796" y="4599432"/>
-            <a:ext cx="272857" cy="45720"/>
-          </a:xfrm>
-          <a:prstGeom prst="rect">
-            <a:avLst/>
-          </a:prstGeom>
-          <a:solidFill>
-            <a:srgbClr val="566270"/>
-          </a:solidFill>
-          <a:ln/>
-        </p:spPr>
-      </p:sp>
-      <p:sp>
-        <p:nvSpPr>
-          <p:cNvPr id="135" name="Text 133"/>
-          <p:cNvSpPr/>
-          <p:nvPr/>
-        </p:nvSpPr>
-        <p:spPr>
-          <a:xfrm>
-            <a:off x="8366760" y="4645152"/>
-            <a:ext cx="566928" cy="329184"/>
-          </a:xfrm>
-          <a:prstGeom prst="rect">
-            <a:avLst/>
-          </a:prstGeom>
-          <a:noFill/>
-          <a:ln/>
-        </p:spPr>
-        <p:txBody>
-          <a:bodyPr wrap="square" lIns="0" tIns="0" rIns="0" bIns="0" rtlCol="0" anchor="ctr"/>
-          <a:lstStyle/>
-          <a:p>
-            <a:pPr algn="ctr" indent="0" marL="0">
-              <a:buNone/>
-            </a:pPr>
-            <a:r>
-              <a:rPr lang="en-US" sz="900" b="1" dirty="0">
-                <a:solidFill>
-                  <a:srgbClr val="2A2F39"/>
-                </a:solidFill>
-                <a:latin typeface="Calibri" pitchFamily="34" charset="0"/>
-                <a:ea typeface="Calibri" pitchFamily="34" charset="-122"/>
-                <a:cs typeface="Calibri" pitchFamily="34" charset="-120"/>
-              </a:rPr>
-              <a:t>2</a:t>
-            </a:r>
-            <a:endParaRPr lang="en-US" sz="900" dirty="0"/>
-          </a:p>
-        </p:txBody>
-      </p:sp>
-      <p:sp>
-        <p:nvSpPr>
-          <p:cNvPr id="136" name="Shape 134"/>
-          <p:cNvSpPr/>
-          <p:nvPr/>
-        </p:nvSpPr>
-        <p:spPr>
-          <a:xfrm>
-            <a:off x="10195560" y="4645152"/>
-            <a:ext cx="566928" cy="329184"/>
-          </a:xfrm>
-          <a:prstGeom prst="roundRect">
-            <a:avLst>
-              <a:gd name="adj" fmla="val 13889"/>
-            </a:avLst>
-          </a:prstGeom>
-          <a:solidFill>
-            <a:srgbClr val="E4E7DF"/>
-          </a:solidFill>
-          <a:ln w="13970">
-            <a:solidFill>
-              <a:srgbClr val="566270"/>
-            </a:solidFill>
-            <a:prstDash val="solid"/>
-          </a:ln>
-        </p:spPr>
-      </p:sp>
-      <p:sp>
-        <p:nvSpPr>
-          <p:cNvPr id="137" name="Shape 135"/>
-          <p:cNvSpPr/>
-          <p:nvPr/>
-        </p:nvSpPr>
-        <p:spPr>
-          <a:xfrm>
-            <a:off x="10342596" y="4334256"/>
-            <a:ext cx="64008" cy="310896"/>
-          </a:xfrm>
-          <a:prstGeom prst="rect">
-            <a:avLst/>
-          </a:prstGeom>
-          <a:solidFill>
-            <a:srgbClr val="566270"/>
-          </a:solidFill>
-          <a:ln/>
-        </p:spPr>
-      </p:sp>
-      <p:sp>
-        <p:nvSpPr>
-          <p:cNvPr id="138" name="Shape 136"/>
-          <p:cNvSpPr/>
-          <p:nvPr/>
-        </p:nvSpPr>
-        <p:spPr>
-          <a:xfrm>
-            <a:off x="10551444" y="4334256"/>
-            <a:ext cx="64008" cy="310896"/>
-          </a:xfrm>
-          <a:prstGeom prst="rect">
-            <a:avLst/>
-          </a:prstGeom>
-          <a:solidFill>
-            <a:srgbClr val="566270"/>
-          </a:solidFill>
-          <a:ln/>
-        </p:spPr>
-      </p:sp>
-      <p:sp>
-        <p:nvSpPr>
-          <p:cNvPr id="139" name="Shape 137"/>
-          <p:cNvSpPr/>
-          <p:nvPr/>
-        </p:nvSpPr>
-        <p:spPr>
-          <a:xfrm>
-            <a:off x="10342596" y="4599432"/>
-            <a:ext cx="272857" cy="45720"/>
-          </a:xfrm>
-          <a:prstGeom prst="rect">
-            <a:avLst/>
-          </a:prstGeom>
-          <a:solidFill>
-            <a:srgbClr val="566270"/>
-          </a:solidFill>
-          <a:ln/>
-        </p:spPr>
-      </p:sp>
-      <p:sp>
-        <p:nvSpPr>
-          <p:cNvPr id="140" name="Text 138"/>
-          <p:cNvSpPr/>
-          <p:nvPr/>
-        </p:nvSpPr>
-        <p:spPr>
-          <a:xfrm>
-            <a:off x="10195560" y="4645152"/>
-            <a:ext cx="566928" cy="329184"/>
-          </a:xfrm>
-          <a:prstGeom prst="rect">
-            <a:avLst/>
-          </a:prstGeom>
-          <a:noFill/>
-          <a:ln/>
-        </p:spPr>
-        <p:txBody>
-          <a:bodyPr wrap="square" lIns="0" tIns="0" rIns="0" bIns="0" rtlCol="0" anchor="ctr"/>
-          <a:lstStyle/>
-          <a:p>
-            <a:pPr algn="ctr" indent="0" marL="0">
-              <a:buNone/>
-            </a:pPr>
-            <a:r>
-              <a:rPr lang="en-US" sz="900" b="1" dirty="0">
-                <a:solidFill>
-                  <a:srgbClr val="2A2F39"/>
-                </a:solidFill>
-                <a:latin typeface="Calibri" pitchFamily="34" charset="0"/>
-                <a:ea typeface="Calibri" pitchFamily="34" charset="-122"/>
-                <a:cs typeface="Calibri" pitchFamily="34" charset="-120"/>
-              </a:rPr>
-              <a:t>6</a:t>
-            </a:r>
-            <a:endParaRPr lang="en-US" sz="900" dirty="0"/>
-          </a:p>
-        </p:txBody>
-      </p:sp>
-      <p:sp>
-        <p:nvSpPr>
-          <p:cNvPr id="141" name="Shape 139"/>
-          <p:cNvSpPr/>
-          <p:nvPr/>
-        </p:nvSpPr>
-        <p:spPr>
-          <a:xfrm>
-            <a:off x="9235440" y="4681728"/>
-            <a:ext cx="274320" cy="274320"/>
-          </a:xfrm>
-          <a:prstGeom prst="rect">
-            <a:avLst/>
-          </a:prstGeom>
-          <a:solidFill>
-            <a:srgbClr val="E7E9EC"/>
-          </a:solidFill>
-          <a:ln w="12700">
-            <a:solidFill>
-              <a:srgbClr val="B9BEC6"/>
-            </a:solidFill>
-            <a:prstDash val="solid"/>
-          </a:ln>
-        </p:spPr>
-      </p:sp>
-      <p:sp>
-        <p:nvSpPr>
-          <p:cNvPr id="142" name="Shape 140"/>
-          <p:cNvSpPr/>
-          <p:nvPr/>
-        </p:nvSpPr>
-        <p:spPr>
-          <a:xfrm>
-            <a:off x="9573768" y="4681728"/>
-            <a:ext cx="274320" cy="274320"/>
-          </a:xfrm>
-          <a:prstGeom prst="rect">
-            <a:avLst/>
-          </a:prstGeom>
-          <a:solidFill>
-            <a:srgbClr val="E7E9EC"/>
-          </a:solidFill>
-          <a:ln w="12700">
-            <a:solidFill>
-              <a:srgbClr val="B9BEC6"/>
-            </a:solidFill>
-            <a:prstDash val="solid"/>
-          </a:ln>
-        </p:spPr>
-      </p:sp>
-      <p:sp>
-        <p:nvSpPr>
-          <p:cNvPr id="143" name="Shape 141"/>
-          <p:cNvSpPr/>
-          <p:nvPr/>
-        </p:nvSpPr>
-        <p:spPr>
-          <a:xfrm>
-            <a:off x="594360" y="5230368"/>
-            <a:ext cx="10972800" cy="1097280"/>
-          </a:xfrm>
-          <a:prstGeom prst="roundRect">
-            <a:avLst>
-              <a:gd name="adj" fmla="val 7500"/>
+              <a:gd name="adj" fmla="val 6923"/>
             </a:avLst>
           </a:prstGeom>
           <a:solidFill>
@@ -8813,53 +5283,73 @@
       </p:sp>
       <p:sp>
         <p:nvSpPr>
-          <p:cNvPr id="144" name="Text 142"/>
-          <p:cNvSpPr/>
-          <p:nvPr/>
-        </p:nvSpPr>
-        <p:spPr>
-          <a:xfrm>
-            <a:off x="914400" y="5303520"/>
-            <a:ext cx="10332720" cy="274320"/>
-          </a:xfrm>
-          <a:prstGeom prst="rect">
-            <a:avLst/>
-          </a:prstGeom>
-          <a:noFill/>
-          <a:ln/>
-        </p:spPr>
-        <p:txBody>
-          <a:bodyPr wrap="square" lIns="0" tIns="0" rIns="0" bIns="0" rtlCol="0" anchor="ctr"/>
-          <a:lstStyle/>
-          <a:p>
-            <a:pPr indent="0" marL="0">
-              <a:buNone/>
-            </a:pPr>
-            <a:r>
-              <a:rPr lang="en-US" sz="1200" b="1" dirty="0">
-                <a:solidFill>
-                  <a:srgbClr val="2FA866"/>
-                </a:solidFill>
-                <a:latin typeface="Calibri" pitchFamily="34" charset="0"/>
-                <a:ea typeface="Calibri" pitchFamily="34" charset="-122"/>
-                <a:cs typeface="Calibri" pitchFamily="34" charset="-120"/>
-              </a:rPr>
-              <a:t>✓  Mover el rack 4 además libera un área que usan los mecánicos.</a:t>
-            </a:r>
-            <a:endParaRPr lang="en-US" sz="1200" dirty="0"/>
-          </a:p>
-        </p:txBody>
-      </p:sp>
-      <p:sp>
-        <p:nvSpPr>
-          <p:cNvPr id="145" name="Text 143"/>
-          <p:cNvSpPr/>
-          <p:nvPr/>
-        </p:nvSpPr>
-        <p:spPr>
-          <a:xfrm>
-            <a:off x="914400" y="5614416"/>
-            <a:ext cx="10332720" cy="685800"/>
+          <p:cNvPr id="5" name="Shape 3"/>
+          <p:cNvSpPr/>
+          <p:nvPr/>
+        </p:nvSpPr>
+        <p:spPr>
+          <a:xfrm>
+            <a:off x="594360" y="1783080"/>
+            <a:ext cx="82296" cy="1188720"/>
+          </a:xfrm>
+          <a:prstGeom prst="rect">
+            <a:avLst/>
+          </a:prstGeom>
+          <a:solidFill>
+            <a:srgbClr val="37C3FF"/>
+          </a:solidFill>
+          <a:ln/>
+        </p:spPr>
+      </p:sp>
+      <p:sp>
+        <p:nvSpPr>
+          <p:cNvPr id="6" name="Text 4"/>
+          <p:cNvSpPr/>
+          <p:nvPr/>
+        </p:nvSpPr>
+        <p:spPr>
+          <a:xfrm>
+            <a:off x="914400" y="1965960"/>
+            <a:ext cx="10332720" cy="411480"/>
+          </a:xfrm>
+          <a:prstGeom prst="rect">
+            <a:avLst/>
+          </a:prstGeom>
+          <a:noFill/>
+          <a:ln/>
+        </p:spPr>
+        <p:txBody>
+          <a:bodyPr wrap="square" lIns="0" tIns="0" rIns="0" bIns="0" rtlCol="0" anchor="ctr"/>
+          <a:lstStyle/>
+          <a:p>
+            <a:pPr indent="0" marL="0">
+              <a:buNone/>
+            </a:pPr>
+            <a:r>
+              <a:rPr lang="en-US" sz="1700" b="1" dirty="0">
+                <a:solidFill>
+                  <a:srgbClr val="1A1D23"/>
+                </a:solidFill>
+                <a:latin typeface="Cambria" pitchFamily="34" charset="0"/>
+                <a:ea typeface="Cambria" pitchFamily="34" charset="-122"/>
+                <a:cs typeface="Cambria" pitchFamily="34" charset="-120"/>
+              </a:rPr>
+              <a:t>Reconfigurar espacio muerto</a:t>
+            </a:r>
+            <a:endParaRPr lang="en-US" sz="1700" dirty="0"/>
+          </a:p>
+        </p:txBody>
+      </p:sp>
+      <p:sp>
+        <p:nvSpPr>
+          <p:cNvPr id="7" name="Text 5"/>
+          <p:cNvSpPr/>
+          <p:nvPr/>
+        </p:nvSpPr>
+        <p:spPr>
+          <a:xfrm>
+            <a:off x="914400" y="2386584"/>
+            <a:ext cx="10332720" cy="548640"/>
           </a:xfrm>
           <a:prstGeom prst="rect">
             <a:avLst/>
@@ -8872,13 +5362,10 @@
           <a:lstStyle/>
           <a:p>
             <a:pPr indent="0" marL="0">
-              <a:lnSpc>
-                <a:spcPts val="1400"/>
-              </a:lnSpc>
-              <a:buNone/>
-            </a:pPr>
-            <a:r>
-              <a:rPr lang="en-US" sz="1100" dirty="0">
+              <a:buNone/>
+            </a:pPr>
+            <a:r>
+              <a:rPr lang="en-US" sz="1300" dirty="0">
                 <a:solidFill>
                   <a:srgbClr val="5B6470"/>
                 </a:solidFill>
@@ -8886,19 +5373,126 @@
                 <a:ea typeface="Calibri" pitchFamily="34" charset="-122"/>
                 <a:cs typeface="Calibri" pitchFamily="34" charset="-120"/>
               </a:rPr>
-              <a:t>•  Solo reorganizar estantes para el pasillo de 3.0 × 6.0 m — los racks 3 y 4 siguen accesibles, no se vacían, y todo lo sombreado (espacio en uso) y las mesas se quedan.</a:t>
-            </a:r>
-            <a:endParaRPr lang="en-US" sz="1100" dirty="0"/>
-          </a:p>
-          <a:p>
-            <a:pPr indent="0" marL="0">
-              <a:lnSpc>
-                <a:spcPts val="1400"/>
-              </a:lnSpc>
-              <a:buNone/>
-            </a:pPr>
-            <a:r>
-              <a:rPr lang="en-US" sz="1100" dirty="0">
+              <a:t>En el taller hay espacio muerto ocupado por equipamiento que no se usa y por racks. Reorganizándolo se libera un espacio de 3.0 m de ancho × 6.0 m de largo — sin deshacer el taller.</a:t>
+            </a:r>
+            <a:endParaRPr lang="en-US" sz="1300" dirty="0"/>
+          </a:p>
+        </p:txBody>
+      </p:sp>
+      <p:sp>
+        <p:nvSpPr>
+          <p:cNvPr id="8" name="Shape 6"/>
+          <p:cNvSpPr/>
+          <p:nvPr/>
+        </p:nvSpPr>
+        <p:spPr>
+          <a:xfrm>
+            <a:off x="594360" y="3154680"/>
+            <a:ext cx="10972800" cy="1188720"/>
+          </a:xfrm>
+          <a:prstGeom prst="roundRect">
+            <a:avLst>
+              <a:gd name="adj" fmla="val 6923"/>
+            </a:avLst>
+          </a:prstGeom>
+          <a:solidFill>
+            <a:srgbClr val="FFFFFF"/>
+          </a:solidFill>
+          <a:ln/>
+          <a:effectLst>
+            <a:outerShdw sx="100000" sy="100000" kx="0" ky="0" algn="bl" rotWithShape="0" blurRad="152400" dist="38100" dir="5400000">
+              <a:srgbClr val="000000">
+                <a:alpha val="28000"/>
+              </a:srgbClr>
+            </a:outerShdw>
+          </a:effectLst>
+        </p:spPr>
+      </p:sp>
+      <p:sp>
+        <p:nvSpPr>
+          <p:cNvPr id="9" name="Shape 7"/>
+          <p:cNvSpPr/>
+          <p:nvPr/>
+        </p:nvSpPr>
+        <p:spPr>
+          <a:xfrm>
+            <a:off x="594360" y="3154680"/>
+            <a:ext cx="82296" cy="1188720"/>
+          </a:xfrm>
+          <a:prstGeom prst="rect">
+            <a:avLst/>
+          </a:prstGeom>
+          <a:solidFill>
+            <a:srgbClr val="F5C518"/>
+          </a:solidFill>
+          <a:ln/>
+        </p:spPr>
+      </p:sp>
+      <p:sp>
+        <p:nvSpPr>
+          <p:cNvPr id="10" name="Text 8"/>
+          <p:cNvSpPr/>
+          <p:nvPr/>
+        </p:nvSpPr>
+        <p:spPr>
+          <a:xfrm>
+            <a:off x="914400" y="3337560"/>
+            <a:ext cx="10332720" cy="411480"/>
+          </a:xfrm>
+          <a:prstGeom prst="rect">
+            <a:avLst/>
+          </a:prstGeom>
+          <a:noFill/>
+          <a:ln/>
+        </p:spPr>
+        <p:txBody>
+          <a:bodyPr wrap="square" lIns="0" tIns="0" rIns="0" bIns="0" rtlCol="0" anchor="ctr"/>
+          <a:lstStyle/>
+          <a:p>
+            <a:pPr indent="0" marL="0">
+              <a:buNone/>
+            </a:pPr>
+            <a:r>
+              <a:rPr lang="en-US" sz="1700" b="1" dirty="0">
+                <a:solidFill>
+                  <a:srgbClr val="1A1D23"/>
+                </a:solidFill>
+                <a:latin typeface="Cambria" pitchFamily="34" charset="0"/>
+                <a:ea typeface="Cambria" pitchFamily="34" charset="-122"/>
+                <a:cs typeface="Cambria" pitchFamily="34" charset="-120"/>
+              </a:rPr>
+              <a:t>Un ambiente cerrado y real</a:t>
+            </a:r>
+            <a:endParaRPr lang="en-US" sz="1700" dirty="0"/>
+          </a:p>
+        </p:txBody>
+      </p:sp>
+      <p:sp>
+        <p:nvSpPr>
+          <p:cNvPr id="11" name="Text 9"/>
+          <p:cNvSpPr/>
+          <p:nvPr/>
+        </p:nvSpPr>
+        <p:spPr>
+          <a:xfrm>
+            <a:off x="914400" y="3758184"/>
+            <a:ext cx="10332720" cy="548640"/>
+          </a:xfrm>
+          <a:prstGeom prst="rect">
+            <a:avLst/>
+          </a:prstGeom>
+          <a:noFill/>
+          <a:ln/>
+        </p:spPr>
+        <p:txBody>
+          <a:bodyPr wrap="square" lIns="0" tIns="0" rIns="0" bIns="0" rtlCol="0" anchor="t"/>
+          <a:lstStyle/>
+          <a:p>
+            <a:pPr indent="0" marL="0">
+              <a:buNone/>
+            </a:pPr>
+            <a:r>
+              <a:rPr lang="en-US" sz="1300" dirty="0">
                 <a:solidFill>
                   <a:srgbClr val="5B6470"/>
                 </a:solidFill>
@@ -8906,9 +5500,175 @@
                 <a:ea typeface="Calibri" pitchFamily="34" charset="-122"/>
                 <a:cs typeface="Calibri" pitchFamily="34" charset="-120"/>
               </a:rPr>
-              <a:t>•  Pruebas con el pantógrafo (sin uñas) + un sensor de altura simple y calibrado en las uñas — no viene en el equipo, lo necesitamos, y ya lo resolví al milímetro en Botoni.</a:t>
-            </a:r>
-            <a:endParaRPr lang="en-US" sz="1100" dirty="0"/>
+              <a:t>Es un ambiente cerrado, como el de cualquier almacén de verdad —incluido RETHINK—. Reproduce las condiciones reales donde el equipo va a operar.</a:t>
+            </a:r>
+            <a:endParaRPr lang="en-US" sz="1300" dirty="0"/>
+          </a:p>
+        </p:txBody>
+      </p:sp>
+      <p:sp>
+        <p:nvSpPr>
+          <p:cNvPr id="12" name="Shape 10"/>
+          <p:cNvSpPr/>
+          <p:nvPr/>
+        </p:nvSpPr>
+        <p:spPr>
+          <a:xfrm>
+            <a:off x="594360" y="4526280"/>
+            <a:ext cx="10972800" cy="1188720"/>
+          </a:xfrm>
+          <a:prstGeom prst="roundRect">
+            <a:avLst>
+              <a:gd name="adj" fmla="val 6923"/>
+            </a:avLst>
+          </a:prstGeom>
+          <a:solidFill>
+            <a:srgbClr val="FFFFFF"/>
+          </a:solidFill>
+          <a:ln/>
+          <a:effectLst>
+            <a:outerShdw sx="100000" sy="100000" kx="0" ky="0" algn="bl" rotWithShape="0" blurRad="152400" dist="38100" dir="5400000">
+              <a:srgbClr val="000000">
+                <a:alpha val="28000"/>
+              </a:srgbClr>
+            </a:outerShdw>
+          </a:effectLst>
+        </p:spPr>
+      </p:sp>
+      <p:sp>
+        <p:nvSpPr>
+          <p:cNvPr id="13" name="Shape 11"/>
+          <p:cNvSpPr/>
+          <p:nvPr/>
+        </p:nvSpPr>
+        <p:spPr>
+          <a:xfrm>
+            <a:off x="594360" y="4526280"/>
+            <a:ext cx="82296" cy="1188720"/>
+          </a:xfrm>
+          <a:prstGeom prst="rect">
+            <a:avLst/>
+          </a:prstGeom>
+          <a:solidFill>
+            <a:srgbClr val="39D98A"/>
+          </a:solidFill>
+          <a:ln/>
+        </p:spPr>
+      </p:sp>
+      <p:sp>
+        <p:nvSpPr>
+          <p:cNvPr id="14" name="Text 12"/>
+          <p:cNvSpPr/>
+          <p:nvPr/>
+        </p:nvSpPr>
+        <p:spPr>
+          <a:xfrm>
+            <a:off x="914400" y="4709160"/>
+            <a:ext cx="10332720" cy="411480"/>
+          </a:xfrm>
+          <a:prstGeom prst="rect">
+            <a:avLst/>
+          </a:prstGeom>
+          <a:noFill/>
+          <a:ln/>
+        </p:spPr>
+        <p:txBody>
+          <a:bodyPr wrap="square" lIns="0" tIns="0" rIns="0" bIns="0" rtlCol="0" anchor="ctr"/>
+          <a:lstStyle/>
+          <a:p>
+            <a:pPr indent="0" marL="0">
+              <a:buNone/>
+            </a:pPr>
+            <a:r>
+              <a:rPr lang="en-US" sz="1700" b="1" dirty="0">
+                <a:solidFill>
+                  <a:srgbClr val="1A1D23"/>
+                </a:solidFill>
+                <a:latin typeface="Cambria" pitchFamily="34" charset="0"/>
+                <a:ea typeface="Cambria" pitchFamily="34" charset="-122"/>
+                <a:cs typeface="Cambria" pitchFamily="34" charset="-120"/>
+              </a:rPr>
+              <a:t>La luz inestable juega a favor</a:t>
+            </a:r>
+            <a:endParaRPr lang="en-US" sz="1700" dirty="0"/>
+          </a:p>
+        </p:txBody>
+      </p:sp>
+      <p:sp>
+        <p:nvSpPr>
+          <p:cNvPr id="15" name="Text 13"/>
+          <p:cNvSpPr/>
+          <p:nvPr/>
+        </p:nvSpPr>
+        <p:spPr>
+          <a:xfrm>
+            <a:off x="914400" y="5129784"/>
+            <a:ext cx="10332720" cy="548640"/>
+          </a:xfrm>
+          <a:prstGeom prst="rect">
+            <a:avLst/>
+          </a:prstGeom>
+          <a:noFill/>
+          <a:ln/>
+        </p:spPr>
+        <p:txBody>
+          <a:bodyPr wrap="square" lIns="0" tIns="0" rIns="0" bIns="0" rtlCol="0" anchor="t"/>
+          <a:lstStyle/>
+          <a:p>
+            <a:pPr indent="0" marL="0">
+              <a:buNone/>
+            </a:pPr>
+            <a:r>
+              <a:rPr lang="en-US" sz="1300" dirty="0">
+                <a:solidFill>
+                  <a:srgbClr val="5B6470"/>
+                </a:solidFill>
+                <a:latin typeface="Calibri" pitchFamily="34" charset="0"/>
+                <a:ea typeface="Calibri" pitchFamily="34" charset="-122"/>
+                <a:cs typeface="Calibri" pitchFamily="34" charset="-120"/>
+              </a:rPr>
+              <a:t>La iluminación inestable que tendríamos no es un problema: probar con luz imperfecta hace la visión (ArUco) y la robótica más robustas para el campo.</a:t>
+            </a:r>
+            <a:endParaRPr lang="en-US" sz="1300" dirty="0"/>
+          </a:p>
+        </p:txBody>
+      </p:sp>
+      <p:sp>
+        <p:nvSpPr>
+          <p:cNvPr id="16" name="Text 14"/>
+          <p:cNvSpPr/>
+          <p:nvPr/>
+        </p:nvSpPr>
+        <p:spPr>
+          <a:xfrm>
+            <a:off x="594360" y="5943600"/>
+            <a:ext cx="10972800" cy="365760"/>
+          </a:xfrm>
+          <a:prstGeom prst="rect">
+            <a:avLst/>
+          </a:prstGeom>
+          <a:noFill/>
+          <a:ln/>
+        </p:spPr>
+        <p:txBody>
+          <a:bodyPr wrap="square" lIns="0" tIns="0" rIns="0" bIns="0" rtlCol="0" anchor="ctr"/>
+          <a:lstStyle/>
+          <a:p>
+            <a:pPr indent="0" marL="0">
+              <a:buNone/>
+            </a:pPr>
+            <a:r>
+              <a:rPr lang="en-US" sz="1150" i="1" dirty="0">
+                <a:solidFill>
+                  <a:srgbClr val="5B6470"/>
+                </a:solidFill>
+                <a:latin typeface="Calibri" pitchFamily="34" charset="0"/>
+                <a:ea typeface="Calibri" pitchFamily="34" charset="-122"/>
+                <a:cs typeface="Calibri" pitchFamily="34" charset="-120"/>
+              </a:rPr>
+              <a:t>En esta etapa se prueba el ciclo con el pantógrafo (sin uñas) + un sensor de altura calibrado.</a:t>
+            </a:r>
+            <a:endParaRPr lang="en-US" sz="1150" dirty="0"/>
           </a:p>
         </p:txBody>
       </p:sp>

</xml_diff>